<commit_message>
docs(ppt): update ppt with own progress
</commit_message>
<xml_diff>
--- a/Kanban webapp - Buborék együttes.pptx
+++ b/Kanban webapp - Buborék együttes.pptx
@@ -5,10 +5,10 @@
     <p:sldMasterId id="2147483672" r:id="rId1"/>
   </p:sldMasterIdLst>
   <p:notesMasterIdLst>
-    <p:notesMasterId r:id="rId12"/>
+    <p:notesMasterId r:id="rId19"/>
   </p:notesMasterIdLst>
   <p:handoutMasterIdLst>
-    <p:handoutMasterId r:id="rId13"/>
+    <p:handoutMasterId r:id="rId20"/>
   </p:handoutMasterIdLst>
   <p:sldIdLst>
     <p:sldId id="258" r:id="rId2"/>
@@ -21,6 +21,13 @@
     <p:sldId id="263" r:id="rId9"/>
     <p:sldId id="264" r:id="rId10"/>
     <p:sldId id="267" r:id="rId11"/>
+    <p:sldId id="269" r:id="rId12"/>
+    <p:sldId id="270" r:id="rId13"/>
+    <p:sldId id="271" r:id="rId14"/>
+    <p:sldId id="272" r:id="rId15"/>
+    <p:sldId id="273" r:id="rId16"/>
+    <p:sldId id="274" r:id="rId17"/>
+    <p:sldId id="275" r:id="rId18"/>
   </p:sldIdLst>
   <p:sldSz cx="12192000" cy="6858000"/>
   <p:notesSz cx="6858000" cy="9144000"/>
@@ -221,7 +228,7 @@
           <a:p>
             <a:fld id="{795EECD7-D4C7-4FE3-AB70-00E199DD6761}" type="datetimeFigureOut">
               <a:rPr lang="hu-HU" smtClean="0"/>
-              <a:t>2025. 11. 14.</a:t>
+              <a:t>2025. 11. 15.</a:t>
             </a:fld>
             <a:endParaRPr lang="hu-HU"/>
           </a:p>
@@ -399,7 +406,7 @@
           <a:p>
             <a:fld id="{2D5DABCF-F2FF-4310-8608-C10C325E963C}" type="datetimeFigureOut">
               <a:rPr lang="hu-HU" smtClean="0"/>
-              <a:t>2025. 11. 14.</a:t>
+              <a:t>2025. 11. 15.</a:t>
             </a:fld>
             <a:endParaRPr lang="hu-HU"/>
           </a:p>
@@ -890,7 +897,7 @@
           <a:p>
             <a:fld id="{67F45AC6-C491-4585-A584-9CE2AF7D5500}" type="datetime1">
               <a:rPr lang="en-US" smtClean="0"/>
-              <a:t>11/14/2025</a:t>
+              <a:t>11/15/2025</a:t>
             </a:fld>
             <a:endParaRPr lang="en-US"/>
           </a:p>
@@ -1102,7 +1109,7 @@
           <a:p>
             <a:fld id="{67F45AC6-C491-4585-A584-9CE2AF7D5500}" type="datetime1">
               <a:rPr lang="en-US" smtClean="0"/>
-              <a:t>11/14/2025</a:t>
+              <a:t>11/15/2025</a:t>
             </a:fld>
             <a:endParaRPr lang="en-US"/>
           </a:p>
@@ -1318,7 +1325,7 @@
           <a:p>
             <a:fld id="{67F45AC6-C491-4585-A584-9CE2AF7D5500}" type="datetime1">
               <a:rPr lang="en-US" smtClean="0"/>
-              <a:t>11/14/2025</a:t>
+              <a:t>11/15/2025</a:t>
             </a:fld>
             <a:endParaRPr lang="en-US"/>
           </a:p>
@@ -1520,7 +1527,7 @@
           <a:p>
             <a:fld id="{67F45AC6-C491-4585-A584-9CE2AF7D5500}" type="datetime1">
               <a:rPr lang="en-US" smtClean="0"/>
-              <a:t>11/14/2025</a:t>
+              <a:t>11/15/2025</a:t>
             </a:fld>
             <a:endParaRPr lang="en-US"/>
           </a:p>
@@ -1800,7 +1807,7 @@
           <a:p>
             <a:fld id="{67F45AC6-C491-4585-A584-9CE2AF7D5500}" type="datetime1">
               <a:rPr lang="en-US" smtClean="0"/>
-              <a:t>11/14/2025</a:t>
+              <a:t>11/15/2025</a:t>
             </a:fld>
             <a:endParaRPr lang="en-US"/>
           </a:p>
@@ -2069,7 +2076,7 @@
           <a:p>
             <a:fld id="{67F45AC6-C491-4585-A584-9CE2AF7D5500}" type="datetime1">
               <a:rPr lang="en-US" smtClean="0"/>
-              <a:t>11/14/2025</a:t>
+              <a:t>11/15/2025</a:t>
             </a:fld>
             <a:endParaRPr lang="en-US"/>
           </a:p>
@@ -2486,7 +2493,7 @@
           <a:p>
             <a:fld id="{67F45AC6-C491-4585-A584-9CE2AF7D5500}" type="datetime1">
               <a:rPr lang="en-US" smtClean="0"/>
-              <a:t>11/14/2025</a:t>
+              <a:t>11/15/2025</a:t>
             </a:fld>
             <a:endParaRPr lang="en-US"/>
           </a:p>
@@ -2636,7 +2643,7 @@
           <a:p>
             <a:fld id="{67F45AC6-C491-4585-A584-9CE2AF7D5500}" type="datetime1">
               <a:rPr lang="en-US" smtClean="0"/>
-              <a:t>11/14/2025</a:t>
+              <a:t>11/15/2025</a:t>
             </a:fld>
             <a:endParaRPr lang="en-US"/>
           </a:p>
@@ -2763,7 +2770,7 @@
           <a:p>
             <a:fld id="{67F45AC6-C491-4585-A584-9CE2AF7D5500}" type="datetime1">
               <a:rPr lang="en-US" smtClean="0"/>
-              <a:t>11/14/2025</a:t>
+              <a:t>11/15/2025</a:t>
             </a:fld>
             <a:endParaRPr lang="en-US"/>
           </a:p>
@@ -3015,7 +3022,7 @@
           <a:p>
             <a:fld id="{67F45AC6-C491-4585-A584-9CE2AF7D5500}" type="datetime1">
               <a:rPr lang="en-US" smtClean="0"/>
-              <a:t>11/14/2025</a:t>
+              <a:t>11/15/2025</a:t>
             </a:fld>
             <a:endParaRPr lang="en-US"/>
           </a:p>
@@ -3461,7 +3468,7 @@
           <a:p>
             <a:fld id="{67F45AC6-C491-4585-A584-9CE2AF7D5500}" type="datetime1">
               <a:rPr lang="en-US" smtClean="0"/>
-              <a:t>11/14/2025</a:t>
+              <a:t>11/15/2025</a:t>
             </a:fld>
             <a:endParaRPr lang="en-US"/>
           </a:p>
@@ -3796,7 +3803,7 @@
           <a:p>
             <a:fld id="{67F45AC6-C491-4585-A584-9CE2AF7D5500}" type="datetime1">
               <a:rPr lang="en-US" smtClean="0"/>
-              <a:t>11/14/2025</a:t>
+              <a:t>11/15/2025</a:t>
             </a:fld>
             <a:endParaRPr lang="en-US"/>
           </a:p>
@@ -5204,6 +5211,4206 @@
       </p:par>
     </p:tnLst>
   </p:timing>
+</p:sld>
+</file>
+
+<file path=ppt/slides/slide11.xml><?xml version="1.0" encoding="utf-8"?>
+<p:sld xmlns:a="http://schemas.openxmlformats.org/drawingml/2006/main" xmlns:r="http://schemas.openxmlformats.org/officeDocument/2006/relationships" xmlns:p="http://schemas.openxmlformats.org/presentationml/2006/main">
+  <p:cSld>
+    <p:bg>
+      <p:bgPr>
+        <a:gradFill rotWithShape="1">
+          <a:gsLst>
+            <a:gs pos="0">
+              <a:schemeClr val="bg2">
+                <a:tint val="94000"/>
+                <a:satMod val="80000"/>
+                <a:lumMod val="106000"/>
+              </a:schemeClr>
+            </a:gs>
+            <a:gs pos="100000">
+              <a:schemeClr val="bg2">
+                <a:shade val="80000"/>
+              </a:schemeClr>
+            </a:gs>
+          </a:gsLst>
+          <a:path path="circle">
+            <a:fillToRect l="43000" r="43000" b="100000"/>
+          </a:path>
+        </a:gradFill>
+        <a:effectLst/>
+      </p:bgPr>
+    </p:bg>
+    <p:spTree>
+      <p:nvGrpSpPr>
+        <p:cNvPr id="1" name=""/>
+        <p:cNvGrpSpPr/>
+        <p:nvPr/>
+      </p:nvGrpSpPr>
+      <p:grpSpPr>
+        <a:xfrm>
+          <a:off x="0" y="0"/>
+          <a:ext cx="0" cy="0"/>
+          <a:chOff x="0" y="0"/>
+          <a:chExt cx="0" cy="0"/>
+        </a:xfrm>
+      </p:grpSpPr>
+      <p:sp>
+        <p:nvSpPr>
+          <p:cNvPr id="43" name="Rectangle 42">
+            <a:extLst>
+              <a:ext uri="{FF2B5EF4-FFF2-40B4-BE49-F238E27FC236}">
+                <a16:creationId xmlns:a16="http://schemas.microsoft.com/office/drawing/2014/main" id="{905CFAD9-EABE-4F83-B098-604752164E6A}"/>
+              </a:ext>
+              <a:ext uri="{C183D7F6-B498-43B3-948B-1728B52AA6E4}">
+                <adec:decorative xmlns:adec="http://schemas.microsoft.com/office/drawing/2017/decorative" val="1"/>
+              </a:ext>
+            </a:extLst>
+          </p:cNvPr>
+          <p:cNvSpPr>
+            <a:spLocks noGrp="1" noRot="1" noChangeAspect="1" noMove="1" noResize="1" noEditPoints="1" noAdjustHandles="1" noChangeArrowheads="1" noChangeShapeType="1" noTextEdit="1"/>
+          </p:cNvSpPr>
+          <p:nvPr>
+            <p:extLst>
+              <p:ext uri="{386F3935-93C4-4BCD-93E2-E3B085C9AB24}">
+                <p16:designElem xmlns:p16="http://schemas.microsoft.com/office/powerpoint/2015/main" val="1"/>
+              </p:ext>
+            </p:extLst>
+          </p:nvPr>
+        </p:nvSpPr>
+        <p:spPr>
+          <a:xfrm>
+            <a:off x="0" y="2019476"/>
+            <a:ext cx="12192000" cy="4105941"/>
+          </a:xfrm>
+          <a:prstGeom prst="rect">
+            <a:avLst/>
+          </a:prstGeom>
+          <a:gradFill flip="none" rotWithShape="1">
+            <a:gsLst>
+              <a:gs pos="0">
+                <a:schemeClr val="bg2">
+                  <a:alpha val="0"/>
+                </a:schemeClr>
+              </a:gs>
+              <a:gs pos="100000">
+                <a:schemeClr val="bg2"/>
+              </a:gs>
+            </a:gsLst>
+            <a:lin ang="5400000" scaled="0"/>
+            <a:tileRect/>
+          </a:gradFill>
+          <a:ln>
+            <a:noFill/>
+          </a:ln>
+        </p:spPr>
+        <p:style>
+          <a:lnRef idx="2">
+            <a:schemeClr val="accent1">
+              <a:shade val="50000"/>
+            </a:schemeClr>
+          </a:lnRef>
+          <a:fillRef idx="1">
+            <a:schemeClr val="accent1"/>
+          </a:fillRef>
+          <a:effectRef idx="0">
+            <a:schemeClr val="accent1"/>
+          </a:effectRef>
+          <a:fontRef idx="minor">
+            <a:schemeClr val="lt1"/>
+          </a:fontRef>
+        </p:style>
+        <p:txBody>
+          <a:bodyPr/>
+          <a:lstStyle/>
+          <a:p>
+            <a:endParaRPr lang="en-US"/>
+          </a:p>
+        </p:txBody>
+      </p:sp>
+      <p:pic>
+        <p:nvPicPr>
+          <p:cNvPr id="45" name="Picture 44">
+            <a:extLst>
+              <a:ext uri="{FF2B5EF4-FFF2-40B4-BE49-F238E27FC236}">
+                <a16:creationId xmlns:a16="http://schemas.microsoft.com/office/drawing/2014/main" id="{C99610E4-6194-4817-B152-498995E77181}"/>
+              </a:ext>
+              <a:ext uri="{C183D7F6-B498-43B3-948B-1728B52AA6E4}">
+                <adec:decorative xmlns:adec="http://schemas.microsoft.com/office/drawing/2017/decorative" val="1"/>
+              </a:ext>
+            </a:extLst>
+          </p:cNvPr>
+          <p:cNvPicPr>
+            <a:picLocks noGrp="1" noRot="1" noChangeAspect="1" noMove="1" noResize="1" noEditPoints="1" noAdjustHandles="1" noChangeArrowheads="1" noChangeShapeType="1" noCrop="1"/>
+          </p:cNvPicPr>
+          <p:nvPr>
+            <p:extLst>
+              <p:ext uri="{386F3935-93C4-4BCD-93E2-E3B085C9AB24}">
+                <p16:designElem xmlns:p16="http://schemas.microsoft.com/office/powerpoint/2015/main" val="1"/>
+              </p:ext>
+            </p:extLst>
+          </p:nvPr>
+        </p:nvPicPr>
+        <p:blipFill rotWithShape="1">
+          <a:blip r:embed="rId2">
+            <a:extLst>
+              <a:ext uri="{28A0092B-C50C-407E-A947-70E740481C1C}">
+                <a14:useLocalDpi xmlns:a14="http://schemas.microsoft.com/office/drawing/2010/main" val="0"/>
+              </a:ext>
+            </a:extLst>
+          </a:blip>
+          <a:srcRect t="1538" b="-1538"/>
+          <a:stretch/>
+        </p:blipFill>
+        <p:spPr bwMode="black">
+          <a:xfrm>
+            <a:off x="0" y="6126480"/>
+            <a:ext cx="12192000" cy="742950"/>
+          </a:xfrm>
+          <a:prstGeom prst="rect">
+            <a:avLst/>
+          </a:prstGeom>
+        </p:spPr>
+      </p:pic>
+      <p:cxnSp>
+        <p:nvCxnSpPr>
+          <p:cNvPr id="47" name="Straight Connector 46">
+            <a:extLst>
+              <a:ext uri="{FF2B5EF4-FFF2-40B4-BE49-F238E27FC236}">
+                <a16:creationId xmlns:a16="http://schemas.microsoft.com/office/drawing/2014/main" id="{D885E9F4-7DB6-4B77-B1FF-80BFCE81277B}"/>
+              </a:ext>
+              <a:ext uri="{C183D7F6-B498-43B3-948B-1728B52AA6E4}">
+                <adec:decorative xmlns:adec="http://schemas.microsoft.com/office/drawing/2017/decorative" val="1"/>
+              </a:ext>
+            </a:extLst>
+          </p:cNvPr>
+          <p:cNvCxnSpPr>
+            <a:cxnSpLocks noGrp="1" noRot="1" noChangeAspect="1" noMove="1" noResize="1" noEditPoints="1" noAdjustHandles="1" noChangeArrowheads="1" noChangeShapeType="1"/>
+          </p:cNvCxnSpPr>
+          <p:nvPr>
+            <p:extLst>
+              <p:ext uri="{386F3935-93C4-4BCD-93E2-E3B085C9AB24}">
+                <p16:designElem xmlns:p16="http://schemas.microsoft.com/office/powerpoint/2015/main" val="1"/>
+              </p:ext>
+            </p:extLst>
+          </p:nvPr>
+        </p:nvCxnSpPr>
+        <p:spPr>
+          <a:xfrm>
+            <a:off x="0" y="6128413"/>
+            <a:ext cx="12192000" cy="0"/>
+          </a:xfrm>
+          <a:prstGeom prst="line">
+            <a:avLst/>
+          </a:prstGeom>
+          <a:ln w="12700">
+            <a:solidFill>
+              <a:srgbClr val="000001">
+                <a:alpha val="20000"/>
+              </a:srgbClr>
+            </a:solidFill>
+          </a:ln>
+        </p:spPr>
+        <p:style>
+          <a:lnRef idx="1">
+            <a:schemeClr val="accent1"/>
+          </a:lnRef>
+          <a:fillRef idx="0">
+            <a:schemeClr val="accent1"/>
+          </a:fillRef>
+          <a:effectRef idx="0">
+            <a:schemeClr val="accent1"/>
+          </a:effectRef>
+          <a:fontRef idx="minor">
+            <a:schemeClr val="tx1"/>
+          </a:fontRef>
+        </p:style>
+      </p:cxnSp>
+      <p:cxnSp>
+        <p:nvCxnSpPr>
+          <p:cNvPr id="49" name="Straight Connector 48">
+            <a:extLst>
+              <a:ext uri="{FF2B5EF4-FFF2-40B4-BE49-F238E27FC236}">
+                <a16:creationId xmlns:a16="http://schemas.microsoft.com/office/drawing/2014/main" id="{DB639A2B-C30C-4F6F-B847-6960F3CF8A64}"/>
+              </a:ext>
+              <a:ext uri="{C183D7F6-B498-43B3-948B-1728B52AA6E4}">
+                <adec:decorative xmlns:adec="http://schemas.microsoft.com/office/drawing/2017/decorative" val="1"/>
+              </a:ext>
+            </a:extLst>
+          </p:cNvPr>
+          <p:cNvCxnSpPr>
+            <a:cxnSpLocks noGrp="1" noRot="1" noChangeAspect="1" noMove="1" noResize="1" noEditPoints="1" noAdjustHandles="1" noChangeArrowheads="1" noChangeShapeType="1"/>
+          </p:cNvCxnSpPr>
+          <p:nvPr>
+            <p:extLst>
+              <p:ext uri="{386F3935-93C4-4BCD-93E2-E3B085C9AB24}">
+                <p16:designElem xmlns:p16="http://schemas.microsoft.com/office/powerpoint/2015/main" val="1"/>
+              </p:ext>
+            </p:extLst>
+          </p:nvPr>
+        </p:nvCxnSpPr>
+        <p:spPr>
+          <a:xfrm>
+            <a:off x="2417780" y="3528542"/>
+            <a:ext cx="8637072" cy="0"/>
+          </a:xfrm>
+          <a:prstGeom prst="line">
+            <a:avLst/>
+          </a:prstGeom>
+          <a:ln w="31750"/>
+        </p:spPr>
+        <p:style>
+          <a:lnRef idx="3">
+            <a:schemeClr val="accent1"/>
+          </a:lnRef>
+          <a:fillRef idx="0">
+            <a:schemeClr val="accent1"/>
+          </a:fillRef>
+          <a:effectRef idx="2">
+            <a:schemeClr val="accent1"/>
+          </a:effectRef>
+          <a:fontRef idx="minor">
+            <a:schemeClr val="tx1"/>
+          </a:fontRef>
+        </p:style>
+      </p:cxnSp>
+      <p:sp useBgFill="1">
+        <p:nvSpPr>
+          <p:cNvPr id="51" name="Rectangle 50">
+            <a:extLst>
+              <a:ext uri="{FF2B5EF4-FFF2-40B4-BE49-F238E27FC236}">
+                <a16:creationId xmlns:a16="http://schemas.microsoft.com/office/drawing/2014/main" id="{D9926FA0-8ED1-4F3A-B23B-FD94D82C74B5}"/>
+              </a:ext>
+              <a:ext uri="{C183D7F6-B498-43B3-948B-1728B52AA6E4}">
+                <adec:decorative xmlns:adec="http://schemas.microsoft.com/office/drawing/2017/decorative" val="1"/>
+              </a:ext>
+            </a:extLst>
+          </p:cNvPr>
+          <p:cNvSpPr>
+            <a:spLocks noGrp="1" noRot="1" noChangeAspect="1" noMove="1" noResize="1" noEditPoints="1" noAdjustHandles="1" noChangeArrowheads="1" noChangeShapeType="1" noTextEdit="1"/>
+          </p:cNvSpPr>
+          <p:nvPr>
+            <p:extLst>
+              <p:ext uri="{386F3935-93C4-4BCD-93E2-E3B085C9AB24}">
+                <p16:designElem xmlns:p16="http://schemas.microsoft.com/office/powerpoint/2015/main" val="1"/>
+              </p:ext>
+            </p:extLst>
+          </p:nvPr>
+        </p:nvSpPr>
+        <p:spPr>
+          <a:xfrm>
+            <a:off x="2" y="0"/>
+            <a:ext cx="12191695" cy="6858000"/>
+          </a:xfrm>
+          <a:prstGeom prst="rect">
+            <a:avLst/>
+          </a:prstGeom>
+          <a:ln>
+            <a:noFill/>
+          </a:ln>
+        </p:spPr>
+        <p:style>
+          <a:lnRef idx="2">
+            <a:schemeClr val="accent1">
+              <a:shade val="50000"/>
+            </a:schemeClr>
+          </a:lnRef>
+          <a:fillRef idx="1">
+            <a:schemeClr val="accent1"/>
+          </a:fillRef>
+          <a:effectRef idx="0">
+            <a:schemeClr val="accent1"/>
+          </a:effectRef>
+          <a:fontRef idx="minor">
+            <a:schemeClr val="lt1"/>
+          </a:fontRef>
+        </p:style>
+        <p:txBody>
+          <a:bodyPr rtlCol="0" anchor="ctr"/>
+          <a:lstStyle/>
+          <a:p>
+            <a:pPr algn="ctr"/>
+            <a:endParaRPr lang="en-US"/>
+          </a:p>
+        </p:txBody>
+      </p:sp>
+      <p:sp>
+        <p:nvSpPr>
+          <p:cNvPr id="53" name="Rectangle 52">
+            <a:extLst>
+              <a:ext uri="{FF2B5EF4-FFF2-40B4-BE49-F238E27FC236}">
+                <a16:creationId xmlns:a16="http://schemas.microsoft.com/office/drawing/2014/main" id="{3A102CD9-C25A-4A86-B9D3-D7280D91428B}"/>
+              </a:ext>
+              <a:ext uri="{C183D7F6-B498-43B3-948B-1728B52AA6E4}">
+                <adec:decorative xmlns:adec="http://schemas.microsoft.com/office/drawing/2017/decorative" val="1"/>
+              </a:ext>
+            </a:extLst>
+          </p:cNvPr>
+          <p:cNvSpPr>
+            <a:spLocks noGrp="1" noRot="1" noChangeAspect="1" noMove="1" noResize="1" noEditPoints="1" noAdjustHandles="1" noChangeArrowheads="1" noChangeShapeType="1" noTextEdit="1"/>
+          </p:cNvSpPr>
+          <p:nvPr>
+            <p:extLst>
+              <p:ext uri="{386F3935-93C4-4BCD-93E2-E3B085C9AB24}">
+                <p16:designElem xmlns:p16="http://schemas.microsoft.com/office/powerpoint/2015/main" val="1"/>
+              </p:ext>
+            </p:extLst>
+          </p:nvPr>
+        </p:nvSpPr>
+        <p:spPr>
+          <a:xfrm>
+            <a:off x="0" y="2019476"/>
+            <a:ext cx="12192000" cy="4105941"/>
+          </a:xfrm>
+          <a:prstGeom prst="rect">
+            <a:avLst/>
+          </a:prstGeom>
+          <a:gradFill flip="none" rotWithShape="1">
+            <a:gsLst>
+              <a:gs pos="0">
+                <a:schemeClr val="bg2">
+                  <a:alpha val="0"/>
+                </a:schemeClr>
+              </a:gs>
+              <a:gs pos="100000">
+                <a:schemeClr val="bg2"/>
+              </a:gs>
+            </a:gsLst>
+            <a:lin ang="5400000" scaled="0"/>
+            <a:tileRect/>
+          </a:gradFill>
+          <a:ln>
+            <a:noFill/>
+          </a:ln>
+        </p:spPr>
+        <p:style>
+          <a:lnRef idx="2">
+            <a:schemeClr val="accent1">
+              <a:shade val="50000"/>
+            </a:schemeClr>
+          </a:lnRef>
+          <a:fillRef idx="1">
+            <a:schemeClr val="accent1"/>
+          </a:fillRef>
+          <a:effectRef idx="0">
+            <a:schemeClr val="accent1"/>
+          </a:effectRef>
+          <a:fontRef idx="minor">
+            <a:schemeClr val="lt1"/>
+          </a:fontRef>
+        </p:style>
+        <p:txBody>
+          <a:bodyPr rtlCol="0" anchor="ctr"/>
+          <a:lstStyle/>
+          <a:p>
+            <a:pPr lvl="0" algn="ctr"/>
+            <a:endParaRPr lang="en-US"/>
+          </a:p>
+        </p:txBody>
+      </p:sp>
+      <p:sp>
+        <p:nvSpPr>
+          <p:cNvPr id="2" name="Title 1">
+            <a:extLst>
+              <a:ext uri="{FF2B5EF4-FFF2-40B4-BE49-F238E27FC236}">
+                <a16:creationId xmlns:a16="http://schemas.microsoft.com/office/drawing/2014/main" id="{D3862F8B-DB53-D69C-19EE-0A453B36C085}"/>
+              </a:ext>
+            </a:extLst>
+          </p:cNvPr>
+          <p:cNvSpPr>
+            <a:spLocks noGrp="1"/>
+          </p:cNvSpPr>
+          <p:nvPr>
+            <p:ph type="title"/>
+          </p:nvPr>
+        </p:nvSpPr>
+        <p:spPr>
+          <a:xfrm>
+            <a:off x="659301" y="1474969"/>
+            <a:ext cx="2823919" cy="1868760"/>
+          </a:xfrm>
+        </p:spPr>
+        <p:txBody>
+          <a:bodyPr vert="horz" lIns="91440" tIns="45720" rIns="91440" bIns="0" rtlCol="0" anchor="b">
+            <a:normAutofit/>
+          </a:bodyPr>
+          <a:lstStyle/>
+          <a:p>
+            <a:r>
+              <a:rPr lang="en-US" sz="2800"/>
+              <a:t>Vlajk Sándor - Management</a:t>
+            </a:r>
+          </a:p>
+        </p:txBody>
+      </p:sp>
+      <p:pic>
+        <p:nvPicPr>
+          <p:cNvPr id="9" name="Picture 8">
+            <a:extLst>
+              <a:ext uri="{FF2B5EF4-FFF2-40B4-BE49-F238E27FC236}">
+                <a16:creationId xmlns:a16="http://schemas.microsoft.com/office/drawing/2014/main" id="{295C5C9D-063C-AF9D-2862-059BEA52D32C}"/>
+              </a:ext>
+            </a:extLst>
+          </p:cNvPr>
+          <p:cNvPicPr>
+            <a:picLocks noChangeAspect="1"/>
+          </p:cNvPicPr>
+          <p:nvPr/>
+        </p:nvPicPr>
+        <p:blipFill>
+          <a:blip r:embed="rId3"/>
+          <a:stretch>
+            <a:fillRect/>
+          </a:stretch>
+        </p:blipFill>
+        <p:spPr>
+          <a:xfrm>
+            <a:off x="3699533" y="533450"/>
+            <a:ext cx="4261962" cy="2994029"/>
+          </a:xfrm>
+          <a:prstGeom prst="rect">
+            <a:avLst/>
+          </a:prstGeom>
+        </p:spPr>
+      </p:pic>
+      <p:pic>
+        <p:nvPicPr>
+          <p:cNvPr id="11" name="Picture 10">
+            <a:extLst>
+              <a:ext uri="{FF2B5EF4-FFF2-40B4-BE49-F238E27FC236}">
+                <a16:creationId xmlns:a16="http://schemas.microsoft.com/office/drawing/2014/main" id="{39383BF8-280F-E773-B719-D67867986341}"/>
+              </a:ext>
+            </a:extLst>
+          </p:cNvPr>
+          <p:cNvPicPr>
+            <a:picLocks noChangeAspect="1"/>
+          </p:cNvPicPr>
+          <p:nvPr/>
+        </p:nvPicPr>
+        <p:blipFill>
+          <a:blip r:embed="rId4"/>
+          <a:stretch>
+            <a:fillRect/>
+          </a:stretch>
+        </p:blipFill>
+        <p:spPr>
+          <a:xfrm>
+            <a:off x="8027625" y="1071185"/>
+            <a:ext cx="2015925" cy="3858231"/>
+          </a:xfrm>
+          <a:prstGeom prst="rect">
+            <a:avLst/>
+          </a:prstGeom>
+        </p:spPr>
+      </p:pic>
+      <p:cxnSp>
+        <p:nvCxnSpPr>
+          <p:cNvPr id="55" name="Straight Connector 54">
+            <a:extLst>
+              <a:ext uri="{FF2B5EF4-FFF2-40B4-BE49-F238E27FC236}">
+                <a16:creationId xmlns:a16="http://schemas.microsoft.com/office/drawing/2014/main" id="{90676B93-40FB-4FA7-8E89-C24B7B1F8F57}"/>
+              </a:ext>
+              <a:ext uri="{C183D7F6-B498-43B3-948B-1728B52AA6E4}">
+                <adec:decorative xmlns:adec="http://schemas.microsoft.com/office/drawing/2017/decorative" val="1"/>
+              </a:ext>
+            </a:extLst>
+          </p:cNvPr>
+          <p:cNvCxnSpPr>
+            <a:cxnSpLocks noGrp="1" noRot="1" noChangeAspect="1" noMove="1" noResize="1" noEditPoints="1" noAdjustHandles="1" noChangeArrowheads="1" noChangeShapeType="1"/>
+          </p:cNvCxnSpPr>
+          <p:nvPr>
+            <p:extLst>
+              <p:ext uri="{386F3935-93C4-4BCD-93E2-E3B085C9AB24}">
+                <p16:designElem xmlns:p16="http://schemas.microsoft.com/office/powerpoint/2015/main" val="1"/>
+              </p:ext>
+            </p:extLst>
+          </p:nvPr>
+        </p:nvCxnSpPr>
+        <p:spPr>
+          <a:xfrm>
+            <a:off x="659301" y="3528543"/>
+            <a:ext cx="2823919" cy="0"/>
+          </a:xfrm>
+          <a:prstGeom prst="line">
+            <a:avLst/>
+          </a:prstGeom>
+          <a:ln w="31750"/>
+        </p:spPr>
+        <p:style>
+          <a:lnRef idx="3">
+            <a:schemeClr val="accent1"/>
+          </a:lnRef>
+          <a:fillRef idx="0">
+            <a:schemeClr val="accent1"/>
+          </a:fillRef>
+          <a:effectRef idx="2">
+            <a:schemeClr val="accent1"/>
+          </a:effectRef>
+          <a:fontRef idx="minor">
+            <a:schemeClr val="tx1"/>
+          </a:fontRef>
+        </p:style>
+      </p:cxnSp>
+      <p:pic>
+        <p:nvPicPr>
+          <p:cNvPr id="7" name="Picture 6">
+            <a:extLst>
+              <a:ext uri="{FF2B5EF4-FFF2-40B4-BE49-F238E27FC236}">
+                <a16:creationId xmlns:a16="http://schemas.microsoft.com/office/drawing/2014/main" id="{83799579-8EB9-DC77-CDAC-986F8B3F2A7D}"/>
+              </a:ext>
+            </a:extLst>
+          </p:cNvPr>
+          <p:cNvPicPr>
+            <a:picLocks noChangeAspect="1"/>
+          </p:cNvPicPr>
+          <p:nvPr/>
+        </p:nvPicPr>
+        <p:blipFill>
+          <a:blip r:embed="rId5"/>
+          <a:stretch>
+            <a:fillRect/>
+          </a:stretch>
+        </p:blipFill>
+        <p:spPr>
+          <a:xfrm>
+            <a:off x="463795" y="3885819"/>
+            <a:ext cx="4508551" cy="1882320"/>
+          </a:xfrm>
+          <a:prstGeom prst="rect">
+            <a:avLst/>
+          </a:prstGeom>
+        </p:spPr>
+      </p:pic>
+      <p:pic>
+        <p:nvPicPr>
+          <p:cNvPr id="5" name="Picture 4">
+            <a:extLst>
+              <a:ext uri="{FF2B5EF4-FFF2-40B4-BE49-F238E27FC236}">
+                <a16:creationId xmlns:a16="http://schemas.microsoft.com/office/drawing/2014/main" id="{43E50A31-341F-5C88-C296-35A974D49814}"/>
+              </a:ext>
+            </a:extLst>
+          </p:cNvPr>
+          <p:cNvPicPr>
+            <a:picLocks noChangeAspect="1"/>
+          </p:cNvPicPr>
+          <p:nvPr/>
+        </p:nvPicPr>
+        <p:blipFill>
+          <a:blip r:embed="rId6"/>
+          <a:stretch>
+            <a:fillRect/>
+          </a:stretch>
+        </p:blipFill>
+        <p:spPr>
+          <a:xfrm>
+            <a:off x="10175810" y="1340666"/>
+            <a:ext cx="1890344" cy="3319267"/>
+          </a:xfrm>
+          <a:prstGeom prst="rect">
+            <a:avLst/>
+          </a:prstGeom>
+        </p:spPr>
+      </p:pic>
+      <p:pic>
+        <p:nvPicPr>
+          <p:cNvPr id="57" name="Picture 56">
+            <a:extLst>
+              <a:ext uri="{FF2B5EF4-FFF2-40B4-BE49-F238E27FC236}">
+                <a16:creationId xmlns:a16="http://schemas.microsoft.com/office/drawing/2014/main" id="{3509D85C-1896-4695-A144-B562AFC58EB2}"/>
+              </a:ext>
+              <a:ext uri="{C183D7F6-B498-43B3-948B-1728B52AA6E4}">
+                <adec:decorative xmlns:adec="http://schemas.microsoft.com/office/drawing/2017/decorative" val="1"/>
+              </a:ext>
+            </a:extLst>
+          </p:cNvPr>
+          <p:cNvPicPr>
+            <a:picLocks noGrp="1" noRot="1" noChangeAspect="1" noMove="1" noResize="1" noEditPoints="1" noAdjustHandles="1" noChangeArrowheads="1" noChangeShapeType="1" noCrop="1"/>
+          </p:cNvPicPr>
+          <p:nvPr>
+            <p:extLst>
+              <p:ext uri="{386F3935-93C4-4BCD-93E2-E3B085C9AB24}">
+                <p16:designElem xmlns:p16="http://schemas.microsoft.com/office/powerpoint/2015/main" val="1"/>
+              </p:ext>
+            </p:extLst>
+          </p:nvPr>
+        </p:nvPicPr>
+        <p:blipFill rotWithShape="1">
+          <a:blip r:embed="rId2">
+            <a:extLst>
+              <a:ext uri="{28A0092B-C50C-407E-A947-70E740481C1C}">
+                <a14:useLocalDpi xmlns:a14="http://schemas.microsoft.com/office/drawing/2010/main" val="0"/>
+              </a:ext>
+            </a:extLst>
+          </a:blip>
+          <a:srcRect t="1538" b="-1538"/>
+          <a:stretch/>
+        </p:blipFill>
+        <p:spPr bwMode="black">
+          <a:xfrm>
+            <a:off x="0" y="6126480"/>
+            <a:ext cx="12192000" cy="742950"/>
+          </a:xfrm>
+          <a:prstGeom prst="rect">
+            <a:avLst/>
+          </a:prstGeom>
+        </p:spPr>
+      </p:pic>
+      <p:cxnSp>
+        <p:nvCxnSpPr>
+          <p:cNvPr id="59" name="Straight Connector 58">
+            <a:extLst>
+              <a:ext uri="{FF2B5EF4-FFF2-40B4-BE49-F238E27FC236}">
+                <a16:creationId xmlns:a16="http://schemas.microsoft.com/office/drawing/2014/main" id="{6D9F55CD-CB1D-4CB9-98D3-2BC602BC430E}"/>
+              </a:ext>
+              <a:ext uri="{C183D7F6-B498-43B3-948B-1728B52AA6E4}">
+                <adec:decorative xmlns:adec="http://schemas.microsoft.com/office/drawing/2017/decorative" val="1"/>
+              </a:ext>
+            </a:extLst>
+          </p:cNvPr>
+          <p:cNvCxnSpPr>
+            <a:cxnSpLocks noGrp="1" noRot="1" noChangeAspect="1" noMove="1" noResize="1" noEditPoints="1" noAdjustHandles="1" noChangeArrowheads="1" noChangeShapeType="1"/>
+          </p:cNvCxnSpPr>
+          <p:nvPr>
+            <p:extLst>
+              <p:ext uri="{386F3935-93C4-4BCD-93E2-E3B085C9AB24}">
+                <p16:designElem xmlns:p16="http://schemas.microsoft.com/office/powerpoint/2015/main" val="1"/>
+              </p:ext>
+            </p:extLst>
+          </p:nvPr>
+        </p:nvCxnSpPr>
+        <p:spPr>
+          <a:xfrm>
+            <a:off x="0" y="6128413"/>
+            <a:ext cx="12192000" cy="0"/>
+          </a:xfrm>
+          <a:prstGeom prst="line">
+            <a:avLst/>
+          </a:prstGeom>
+          <a:ln w="12700">
+            <a:solidFill>
+              <a:srgbClr val="000001">
+                <a:alpha val="20000"/>
+              </a:srgbClr>
+            </a:solidFill>
+          </a:ln>
+        </p:spPr>
+        <p:style>
+          <a:lnRef idx="1">
+            <a:schemeClr val="accent1"/>
+          </a:lnRef>
+          <a:fillRef idx="0">
+            <a:schemeClr val="accent1"/>
+          </a:fillRef>
+          <a:effectRef idx="0">
+            <a:schemeClr val="accent1"/>
+          </a:effectRef>
+          <a:fontRef idx="minor">
+            <a:schemeClr val="tx1"/>
+          </a:fontRef>
+        </p:style>
+      </p:cxnSp>
+    </p:spTree>
+    <p:extLst>
+      <p:ext uri="{BB962C8B-B14F-4D97-AF65-F5344CB8AC3E}">
+        <p14:creationId xmlns:p14="http://schemas.microsoft.com/office/powerpoint/2010/main" val="1886950838"/>
+      </p:ext>
+    </p:extLst>
+  </p:cSld>
+  <p:clrMapOvr>
+    <a:masterClrMapping/>
+  </p:clrMapOvr>
+</p:sld>
+</file>
+
+<file path=ppt/slides/slide12.xml><?xml version="1.0" encoding="utf-8"?>
+<p:sld xmlns:a="http://schemas.openxmlformats.org/drawingml/2006/main" xmlns:r="http://schemas.openxmlformats.org/officeDocument/2006/relationships" xmlns:p="http://schemas.openxmlformats.org/presentationml/2006/main">
+  <p:cSld>
+    <p:bg>
+      <p:bgPr>
+        <a:gradFill rotWithShape="1">
+          <a:gsLst>
+            <a:gs pos="0">
+              <a:schemeClr val="bg2">
+                <a:tint val="94000"/>
+                <a:satMod val="80000"/>
+                <a:lumMod val="106000"/>
+              </a:schemeClr>
+            </a:gs>
+            <a:gs pos="100000">
+              <a:schemeClr val="bg2">
+                <a:shade val="80000"/>
+              </a:schemeClr>
+            </a:gs>
+          </a:gsLst>
+          <a:path path="circle">
+            <a:fillToRect l="43000" r="43000" b="100000"/>
+          </a:path>
+        </a:gradFill>
+        <a:effectLst/>
+      </p:bgPr>
+    </p:bg>
+    <p:spTree>
+      <p:nvGrpSpPr>
+        <p:cNvPr id="1" name=""/>
+        <p:cNvGrpSpPr/>
+        <p:nvPr/>
+      </p:nvGrpSpPr>
+      <p:grpSpPr>
+        <a:xfrm>
+          <a:off x="0" y="0"/>
+          <a:ext cx="0" cy="0"/>
+          <a:chOff x="0" y="0"/>
+          <a:chExt cx="0" cy="0"/>
+        </a:xfrm>
+      </p:grpSpPr>
+      <p:sp>
+        <p:nvSpPr>
+          <p:cNvPr id="50" name="Rectangle 49">
+            <a:extLst>
+              <a:ext uri="{FF2B5EF4-FFF2-40B4-BE49-F238E27FC236}">
+                <a16:creationId xmlns:a16="http://schemas.microsoft.com/office/drawing/2014/main" id="{E724B9E8-02C8-4B2E-8770-A00A67760DF0}"/>
+              </a:ext>
+              <a:ext uri="{C183D7F6-B498-43B3-948B-1728B52AA6E4}">
+                <adec:decorative xmlns:adec="http://schemas.microsoft.com/office/drawing/2017/decorative" val="1"/>
+              </a:ext>
+            </a:extLst>
+          </p:cNvPr>
+          <p:cNvSpPr>
+            <a:spLocks noGrp="1" noRot="1" noChangeAspect="1" noMove="1" noResize="1" noEditPoints="1" noAdjustHandles="1" noChangeArrowheads="1" noChangeShapeType="1" noTextEdit="1"/>
+          </p:cNvSpPr>
+          <p:nvPr>
+            <p:extLst>
+              <p:ext uri="{386F3935-93C4-4BCD-93E2-E3B085C9AB24}">
+                <p16:designElem xmlns:p16="http://schemas.microsoft.com/office/powerpoint/2015/main" val="1"/>
+              </p:ext>
+            </p:extLst>
+          </p:nvPr>
+        </p:nvSpPr>
+        <p:spPr>
+          <a:xfrm>
+            <a:off x="0" y="2019476"/>
+            <a:ext cx="12192000" cy="4105941"/>
+          </a:xfrm>
+          <a:prstGeom prst="rect">
+            <a:avLst/>
+          </a:prstGeom>
+          <a:gradFill flip="none" rotWithShape="1">
+            <a:gsLst>
+              <a:gs pos="0">
+                <a:schemeClr val="bg2">
+                  <a:alpha val="0"/>
+                </a:schemeClr>
+              </a:gs>
+              <a:gs pos="100000">
+                <a:schemeClr val="bg2"/>
+              </a:gs>
+            </a:gsLst>
+            <a:lin ang="5400000" scaled="0"/>
+            <a:tileRect/>
+          </a:gradFill>
+          <a:ln>
+            <a:noFill/>
+          </a:ln>
+        </p:spPr>
+        <p:style>
+          <a:lnRef idx="2">
+            <a:schemeClr val="accent1">
+              <a:shade val="50000"/>
+            </a:schemeClr>
+          </a:lnRef>
+          <a:fillRef idx="1">
+            <a:schemeClr val="accent1"/>
+          </a:fillRef>
+          <a:effectRef idx="0">
+            <a:schemeClr val="accent1"/>
+          </a:effectRef>
+          <a:fontRef idx="minor">
+            <a:schemeClr val="lt1"/>
+          </a:fontRef>
+        </p:style>
+        <p:txBody>
+          <a:bodyPr/>
+          <a:lstStyle/>
+          <a:p>
+            <a:endParaRPr lang="en-US"/>
+          </a:p>
+        </p:txBody>
+      </p:sp>
+      <p:pic>
+        <p:nvPicPr>
+          <p:cNvPr id="51" name="Picture 50">
+            <a:extLst>
+              <a:ext uri="{FF2B5EF4-FFF2-40B4-BE49-F238E27FC236}">
+                <a16:creationId xmlns:a16="http://schemas.microsoft.com/office/drawing/2014/main" id="{7B8AE548-0BFA-4792-9962-3375923C7635}"/>
+              </a:ext>
+              <a:ext uri="{C183D7F6-B498-43B3-948B-1728B52AA6E4}">
+                <adec:decorative xmlns:adec="http://schemas.microsoft.com/office/drawing/2017/decorative" val="1"/>
+              </a:ext>
+            </a:extLst>
+          </p:cNvPr>
+          <p:cNvPicPr>
+            <a:picLocks noGrp="1" noRot="1" noChangeAspect="1" noMove="1" noResize="1" noEditPoints="1" noAdjustHandles="1" noChangeArrowheads="1" noChangeShapeType="1" noCrop="1"/>
+          </p:cNvPicPr>
+          <p:nvPr>
+            <p:extLst>
+              <p:ext uri="{386F3935-93C4-4BCD-93E2-E3B085C9AB24}">
+                <p16:designElem xmlns:p16="http://schemas.microsoft.com/office/powerpoint/2015/main" val="1"/>
+              </p:ext>
+            </p:extLst>
+          </p:nvPr>
+        </p:nvPicPr>
+        <p:blipFill rotWithShape="1">
+          <a:blip r:embed="rId2">
+            <a:extLst>
+              <a:ext uri="{28A0092B-C50C-407E-A947-70E740481C1C}">
+                <a14:useLocalDpi xmlns:a14="http://schemas.microsoft.com/office/drawing/2010/main" val="0"/>
+              </a:ext>
+            </a:extLst>
+          </a:blip>
+          <a:srcRect t="1538" b="-1538"/>
+          <a:stretch/>
+        </p:blipFill>
+        <p:spPr bwMode="black">
+          <a:xfrm>
+            <a:off x="0" y="6126480"/>
+            <a:ext cx="12192000" cy="742950"/>
+          </a:xfrm>
+          <a:prstGeom prst="rect">
+            <a:avLst/>
+          </a:prstGeom>
+        </p:spPr>
+      </p:pic>
+      <p:cxnSp>
+        <p:nvCxnSpPr>
+          <p:cNvPr id="52" name="Straight Connector 51">
+            <a:extLst>
+              <a:ext uri="{FF2B5EF4-FFF2-40B4-BE49-F238E27FC236}">
+                <a16:creationId xmlns:a16="http://schemas.microsoft.com/office/drawing/2014/main" id="{67639EF4-FA83-4D85-90FE-B831AF283896}"/>
+              </a:ext>
+              <a:ext uri="{C183D7F6-B498-43B3-948B-1728B52AA6E4}">
+                <adec:decorative xmlns:adec="http://schemas.microsoft.com/office/drawing/2017/decorative" val="1"/>
+              </a:ext>
+            </a:extLst>
+          </p:cNvPr>
+          <p:cNvCxnSpPr>
+            <a:cxnSpLocks noGrp="1" noRot="1" noChangeAspect="1" noMove="1" noResize="1" noEditPoints="1" noAdjustHandles="1" noChangeArrowheads="1" noChangeShapeType="1"/>
+          </p:cNvCxnSpPr>
+          <p:nvPr>
+            <p:extLst>
+              <p:ext uri="{386F3935-93C4-4BCD-93E2-E3B085C9AB24}">
+                <p16:designElem xmlns:p16="http://schemas.microsoft.com/office/powerpoint/2015/main" val="1"/>
+              </p:ext>
+            </p:extLst>
+          </p:nvPr>
+        </p:nvCxnSpPr>
+        <p:spPr>
+          <a:xfrm>
+            <a:off x="0" y="6128413"/>
+            <a:ext cx="12192000" cy="0"/>
+          </a:xfrm>
+          <a:prstGeom prst="line">
+            <a:avLst/>
+          </a:prstGeom>
+          <a:ln w="12700">
+            <a:solidFill>
+              <a:srgbClr val="000001">
+                <a:alpha val="20000"/>
+              </a:srgbClr>
+            </a:solidFill>
+          </a:ln>
+        </p:spPr>
+        <p:style>
+          <a:lnRef idx="1">
+            <a:schemeClr val="accent1"/>
+          </a:lnRef>
+          <a:fillRef idx="0">
+            <a:schemeClr val="accent1"/>
+          </a:fillRef>
+          <a:effectRef idx="0">
+            <a:schemeClr val="accent1"/>
+          </a:effectRef>
+          <a:fontRef idx="minor">
+            <a:schemeClr val="tx1"/>
+          </a:fontRef>
+        </p:style>
+      </p:cxnSp>
+      <p:cxnSp>
+        <p:nvCxnSpPr>
+          <p:cNvPr id="53" name="Straight Connector 52">
+            <a:extLst>
+              <a:ext uri="{FF2B5EF4-FFF2-40B4-BE49-F238E27FC236}">
+                <a16:creationId xmlns:a16="http://schemas.microsoft.com/office/drawing/2014/main" id="{CC87E76A-8F50-413D-9BFC-C5A1525BD9BC}"/>
+              </a:ext>
+              <a:ext uri="{C183D7F6-B498-43B3-948B-1728B52AA6E4}">
+                <adec:decorative xmlns:adec="http://schemas.microsoft.com/office/drawing/2017/decorative" val="1"/>
+              </a:ext>
+            </a:extLst>
+          </p:cNvPr>
+          <p:cNvCxnSpPr>
+            <a:cxnSpLocks noGrp="1" noRot="1" noChangeAspect="1" noMove="1" noResize="1" noEditPoints="1" noAdjustHandles="1" noChangeArrowheads="1" noChangeShapeType="1"/>
+          </p:cNvCxnSpPr>
+          <p:nvPr>
+            <p:extLst>
+              <p:ext uri="{386F3935-93C4-4BCD-93E2-E3B085C9AB24}">
+                <p16:designElem xmlns:p16="http://schemas.microsoft.com/office/powerpoint/2015/main" val="1"/>
+              </p:ext>
+            </p:extLst>
+          </p:nvPr>
+        </p:nvCxnSpPr>
+        <p:spPr>
+          <a:xfrm>
+            <a:off x="2417780" y="3528542"/>
+            <a:ext cx="8637072" cy="0"/>
+          </a:xfrm>
+          <a:prstGeom prst="line">
+            <a:avLst/>
+          </a:prstGeom>
+          <a:ln w="31750"/>
+        </p:spPr>
+        <p:style>
+          <a:lnRef idx="3">
+            <a:schemeClr val="accent1"/>
+          </a:lnRef>
+          <a:fillRef idx="0">
+            <a:schemeClr val="accent1"/>
+          </a:fillRef>
+          <a:effectRef idx="2">
+            <a:schemeClr val="accent1"/>
+          </a:effectRef>
+          <a:fontRef idx="minor">
+            <a:schemeClr val="tx1"/>
+          </a:fontRef>
+        </p:style>
+      </p:cxnSp>
+      <p:sp useBgFill="1">
+        <p:nvSpPr>
+          <p:cNvPr id="54" name="Rectangle 53">
+            <a:extLst>
+              <a:ext uri="{FF2B5EF4-FFF2-40B4-BE49-F238E27FC236}">
+                <a16:creationId xmlns:a16="http://schemas.microsoft.com/office/drawing/2014/main" id="{0F28EA84-13B4-4494-A4D3-8DE462FF0E6B}"/>
+              </a:ext>
+              <a:ext uri="{C183D7F6-B498-43B3-948B-1728B52AA6E4}">
+                <adec:decorative xmlns:adec="http://schemas.microsoft.com/office/drawing/2017/decorative" val="1"/>
+              </a:ext>
+            </a:extLst>
+          </p:cNvPr>
+          <p:cNvSpPr>
+            <a:spLocks noGrp="1" noRot="1" noChangeAspect="1" noMove="1" noResize="1" noEditPoints="1" noAdjustHandles="1" noChangeArrowheads="1" noChangeShapeType="1" noTextEdit="1"/>
+          </p:cNvSpPr>
+          <p:nvPr>
+            <p:extLst>
+              <p:ext uri="{386F3935-93C4-4BCD-93E2-E3B085C9AB24}">
+                <p16:designElem xmlns:p16="http://schemas.microsoft.com/office/powerpoint/2015/main" val="1"/>
+              </p:ext>
+            </p:extLst>
+          </p:nvPr>
+        </p:nvSpPr>
+        <p:spPr>
+          <a:xfrm>
+            <a:off x="2" y="0"/>
+            <a:ext cx="12191695" cy="6858000"/>
+          </a:xfrm>
+          <a:prstGeom prst="rect">
+            <a:avLst/>
+          </a:prstGeom>
+          <a:ln>
+            <a:noFill/>
+          </a:ln>
+        </p:spPr>
+        <p:style>
+          <a:lnRef idx="2">
+            <a:schemeClr val="accent1">
+              <a:shade val="50000"/>
+            </a:schemeClr>
+          </a:lnRef>
+          <a:fillRef idx="1">
+            <a:schemeClr val="accent1"/>
+          </a:fillRef>
+          <a:effectRef idx="0">
+            <a:schemeClr val="accent1"/>
+          </a:effectRef>
+          <a:fontRef idx="minor">
+            <a:schemeClr val="lt1"/>
+          </a:fontRef>
+        </p:style>
+        <p:txBody>
+          <a:bodyPr rtlCol="0" anchor="ctr"/>
+          <a:lstStyle/>
+          <a:p>
+            <a:pPr algn="ctr"/>
+            <a:endParaRPr lang="en-US"/>
+          </a:p>
+        </p:txBody>
+      </p:sp>
+      <p:sp>
+        <p:nvSpPr>
+          <p:cNvPr id="55" name="Rectangle 54">
+            <a:extLst>
+              <a:ext uri="{FF2B5EF4-FFF2-40B4-BE49-F238E27FC236}">
+                <a16:creationId xmlns:a16="http://schemas.microsoft.com/office/drawing/2014/main" id="{6BEB1B24-66CE-4D63-A39D-2D1B481DF95E}"/>
+              </a:ext>
+              <a:ext uri="{C183D7F6-B498-43B3-948B-1728B52AA6E4}">
+                <adec:decorative xmlns:adec="http://schemas.microsoft.com/office/drawing/2017/decorative" val="1"/>
+              </a:ext>
+            </a:extLst>
+          </p:cNvPr>
+          <p:cNvSpPr>
+            <a:spLocks noGrp="1" noRot="1" noChangeAspect="1" noMove="1" noResize="1" noEditPoints="1" noAdjustHandles="1" noChangeArrowheads="1" noChangeShapeType="1" noTextEdit="1"/>
+          </p:cNvSpPr>
+          <p:nvPr>
+            <p:extLst>
+              <p:ext uri="{386F3935-93C4-4BCD-93E2-E3B085C9AB24}">
+                <p16:designElem xmlns:p16="http://schemas.microsoft.com/office/powerpoint/2015/main" val="1"/>
+              </p:ext>
+            </p:extLst>
+          </p:nvPr>
+        </p:nvSpPr>
+        <p:spPr>
+          <a:xfrm>
+            <a:off x="0" y="2019476"/>
+            <a:ext cx="12192000" cy="4105941"/>
+          </a:xfrm>
+          <a:prstGeom prst="rect">
+            <a:avLst/>
+          </a:prstGeom>
+          <a:gradFill flip="none" rotWithShape="1">
+            <a:gsLst>
+              <a:gs pos="0">
+                <a:schemeClr val="bg2">
+                  <a:alpha val="0"/>
+                </a:schemeClr>
+              </a:gs>
+              <a:gs pos="100000">
+                <a:schemeClr val="bg2"/>
+              </a:gs>
+            </a:gsLst>
+            <a:lin ang="5400000" scaled="0"/>
+            <a:tileRect/>
+          </a:gradFill>
+          <a:ln>
+            <a:noFill/>
+          </a:ln>
+        </p:spPr>
+        <p:style>
+          <a:lnRef idx="2">
+            <a:schemeClr val="accent1">
+              <a:shade val="50000"/>
+            </a:schemeClr>
+          </a:lnRef>
+          <a:fillRef idx="1">
+            <a:schemeClr val="accent1"/>
+          </a:fillRef>
+          <a:effectRef idx="0">
+            <a:schemeClr val="accent1"/>
+          </a:effectRef>
+          <a:fontRef idx="minor">
+            <a:schemeClr val="lt1"/>
+          </a:fontRef>
+        </p:style>
+        <p:txBody>
+          <a:bodyPr rtlCol="0" anchor="ctr"/>
+          <a:lstStyle/>
+          <a:p>
+            <a:pPr lvl="0" algn="ctr"/>
+            <a:endParaRPr lang="en-US"/>
+          </a:p>
+        </p:txBody>
+      </p:sp>
+      <p:sp>
+        <p:nvSpPr>
+          <p:cNvPr id="2" name="Title 1">
+            <a:extLst>
+              <a:ext uri="{FF2B5EF4-FFF2-40B4-BE49-F238E27FC236}">
+                <a16:creationId xmlns:a16="http://schemas.microsoft.com/office/drawing/2014/main" id="{7BA6A004-AC9E-F83D-7C6C-8E45C6DDE234}"/>
+              </a:ext>
+            </a:extLst>
+          </p:cNvPr>
+          <p:cNvSpPr>
+            <a:spLocks noGrp="1"/>
+          </p:cNvSpPr>
+          <p:nvPr>
+            <p:ph type="title"/>
+          </p:nvPr>
+        </p:nvSpPr>
+        <p:spPr>
+          <a:xfrm>
+            <a:off x="659301" y="1474969"/>
+            <a:ext cx="2823919" cy="1868760"/>
+          </a:xfrm>
+        </p:spPr>
+        <p:txBody>
+          <a:bodyPr vert="horz" lIns="91440" tIns="45720" rIns="91440" bIns="0" rtlCol="0" anchor="b">
+            <a:normAutofit/>
+          </a:bodyPr>
+          <a:lstStyle/>
+          <a:p>
+            <a:r>
+              <a:rPr lang="en-US" sz="3600"/>
+              <a:t>Vlajk Sándor - Git</a:t>
+            </a:r>
+          </a:p>
+        </p:txBody>
+      </p:sp>
+      <p:cxnSp>
+        <p:nvCxnSpPr>
+          <p:cNvPr id="56" name="Straight Connector 55">
+            <a:extLst>
+              <a:ext uri="{FF2B5EF4-FFF2-40B4-BE49-F238E27FC236}">
+                <a16:creationId xmlns:a16="http://schemas.microsoft.com/office/drawing/2014/main" id="{78DE337D-1DBA-4536-8145-B43EE65C747D}"/>
+              </a:ext>
+              <a:ext uri="{C183D7F6-B498-43B3-948B-1728B52AA6E4}">
+                <adec:decorative xmlns:adec="http://schemas.microsoft.com/office/drawing/2017/decorative" val="1"/>
+              </a:ext>
+            </a:extLst>
+          </p:cNvPr>
+          <p:cNvCxnSpPr>
+            <a:cxnSpLocks noGrp="1" noRot="1" noChangeAspect="1" noMove="1" noResize="1" noEditPoints="1" noAdjustHandles="1" noChangeArrowheads="1" noChangeShapeType="1"/>
+          </p:cNvCxnSpPr>
+          <p:nvPr>
+            <p:extLst>
+              <p:ext uri="{386F3935-93C4-4BCD-93E2-E3B085C9AB24}">
+                <p16:designElem xmlns:p16="http://schemas.microsoft.com/office/powerpoint/2015/main" val="1"/>
+              </p:ext>
+            </p:extLst>
+          </p:nvPr>
+        </p:nvCxnSpPr>
+        <p:spPr>
+          <a:xfrm>
+            <a:off x="659301" y="3528543"/>
+            <a:ext cx="2823919" cy="0"/>
+          </a:xfrm>
+          <a:prstGeom prst="line">
+            <a:avLst/>
+          </a:prstGeom>
+          <a:ln w="31750"/>
+        </p:spPr>
+        <p:style>
+          <a:lnRef idx="3">
+            <a:schemeClr val="accent1"/>
+          </a:lnRef>
+          <a:fillRef idx="0">
+            <a:schemeClr val="accent1"/>
+          </a:fillRef>
+          <a:effectRef idx="2">
+            <a:schemeClr val="accent1"/>
+          </a:effectRef>
+          <a:fontRef idx="minor">
+            <a:schemeClr val="tx1"/>
+          </a:fontRef>
+        </p:style>
+      </p:cxnSp>
+      <p:pic>
+        <p:nvPicPr>
+          <p:cNvPr id="5" name="Picture 4">
+            <a:extLst>
+              <a:ext uri="{FF2B5EF4-FFF2-40B4-BE49-F238E27FC236}">
+                <a16:creationId xmlns:a16="http://schemas.microsoft.com/office/drawing/2014/main" id="{A88E504C-4007-0FB3-BC00-5FF4F74B5CA7}"/>
+              </a:ext>
+            </a:extLst>
+          </p:cNvPr>
+          <p:cNvPicPr>
+            <a:picLocks noChangeAspect="1"/>
+          </p:cNvPicPr>
+          <p:nvPr/>
+        </p:nvPicPr>
+        <p:blipFill>
+          <a:blip r:embed="rId3"/>
+          <a:stretch>
+            <a:fillRect/>
+          </a:stretch>
+        </p:blipFill>
+        <p:spPr>
+          <a:xfrm>
+            <a:off x="3989479" y="1522154"/>
+            <a:ext cx="3693150" cy="3067192"/>
+          </a:xfrm>
+          <a:prstGeom prst="rect">
+            <a:avLst/>
+          </a:prstGeom>
+        </p:spPr>
+      </p:pic>
+      <p:pic>
+        <p:nvPicPr>
+          <p:cNvPr id="9" name="Picture 8">
+            <a:extLst>
+              <a:ext uri="{FF2B5EF4-FFF2-40B4-BE49-F238E27FC236}">
+                <a16:creationId xmlns:a16="http://schemas.microsoft.com/office/drawing/2014/main" id="{CE8C27E6-D0FE-7D3F-0657-BC477A7054EE}"/>
+              </a:ext>
+            </a:extLst>
+          </p:cNvPr>
+          <p:cNvPicPr>
+            <a:picLocks noChangeAspect="1"/>
+          </p:cNvPicPr>
+          <p:nvPr/>
+        </p:nvPicPr>
+        <p:blipFill>
+          <a:blip r:embed="rId4"/>
+          <a:stretch>
+            <a:fillRect/>
+          </a:stretch>
+        </p:blipFill>
+        <p:spPr>
+          <a:xfrm>
+            <a:off x="7846354" y="965341"/>
+            <a:ext cx="3687168" cy="1523440"/>
+          </a:xfrm>
+          <a:prstGeom prst="rect">
+            <a:avLst/>
+          </a:prstGeom>
+        </p:spPr>
+      </p:pic>
+      <p:pic>
+        <p:nvPicPr>
+          <p:cNvPr id="7" name="Picture 6">
+            <a:extLst>
+              <a:ext uri="{FF2B5EF4-FFF2-40B4-BE49-F238E27FC236}">
+                <a16:creationId xmlns:a16="http://schemas.microsoft.com/office/drawing/2014/main" id="{0491AA9D-40D6-945F-5458-984FA0DBC683}"/>
+              </a:ext>
+            </a:extLst>
+          </p:cNvPr>
+          <p:cNvPicPr>
+            <a:picLocks noChangeAspect="1"/>
+          </p:cNvPicPr>
+          <p:nvPr/>
+        </p:nvPicPr>
+        <p:blipFill>
+          <a:blip r:embed="rId5"/>
+          <a:stretch>
+            <a:fillRect/>
+          </a:stretch>
+        </p:blipFill>
+        <p:spPr>
+          <a:xfrm>
+            <a:off x="7846051" y="3900689"/>
+            <a:ext cx="3687168" cy="967500"/>
+          </a:xfrm>
+          <a:prstGeom prst="rect">
+            <a:avLst/>
+          </a:prstGeom>
+        </p:spPr>
+      </p:pic>
+      <p:pic>
+        <p:nvPicPr>
+          <p:cNvPr id="57" name="Picture 56">
+            <a:extLst>
+              <a:ext uri="{FF2B5EF4-FFF2-40B4-BE49-F238E27FC236}">
+                <a16:creationId xmlns:a16="http://schemas.microsoft.com/office/drawing/2014/main" id="{E7233926-059A-41AD-A9F2-56552CF4FF6B}"/>
+              </a:ext>
+              <a:ext uri="{C183D7F6-B498-43B3-948B-1728B52AA6E4}">
+                <adec:decorative xmlns:adec="http://schemas.microsoft.com/office/drawing/2017/decorative" val="1"/>
+              </a:ext>
+            </a:extLst>
+          </p:cNvPr>
+          <p:cNvPicPr>
+            <a:picLocks noGrp="1" noRot="1" noChangeAspect="1" noMove="1" noResize="1" noEditPoints="1" noAdjustHandles="1" noChangeArrowheads="1" noChangeShapeType="1" noCrop="1"/>
+          </p:cNvPicPr>
+          <p:nvPr>
+            <p:extLst>
+              <p:ext uri="{386F3935-93C4-4BCD-93E2-E3B085C9AB24}">
+                <p16:designElem xmlns:p16="http://schemas.microsoft.com/office/powerpoint/2015/main" val="1"/>
+              </p:ext>
+            </p:extLst>
+          </p:nvPr>
+        </p:nvPicPr>
+        <p:blipFill rotWithShape="1">
+          <a:blip r:embed="rId2">
+            <a:extLst>
+              <a:ext uri="{28A0092B-C50C-407E-A947-70E740481C1C}">
+                <a14:useLocalDpi xmlns:a14="http://schemas.microsoft.com/office/drawing/2010/main" val="0"/>
+              </a:ext>
+            </a:extLst>
+          </a:blip>
+          <a:srcRect t="1538" b="-1538"/>
+          <a:stretch/>
+        </p:blipFill>
+        <p:spPr bwMode="black">
+          <a:xfrm>
+            <a:off x="0" y="6126480"/>
+            <a:ext cx="12192000" cy="742950"/>
+          </a:xfrm>
+          <a:prstGeom prst="rect">
+            <a:avLst/>
+          </a:prstGeom>
+        </p:spPr>
+      </p:pic>
+      <p:cxnSp>
+        <p:nvCxnSpPr>
+          <p:cNvPr id="58" name="Straight Connector 57">
+            <a:extLst>
+              <a:ext uri="{FF2B5EF4-FFF2-40B4-BE49-F238E27FC236}">
+                <a16:creationId xmlns:a16="http://schemas.microsoft.com/office/drawing/2014/main" id="{C13C145E-93D4-481E-92DC-736D9EBA37FC}"/>
+              </a:ext>
+              <a:ext uri="{C183D7F6-B498-43B3-948B-1728B52AA6E4}">
+                <adec:decorative xmlns:adec="http://schemas.microsoft.com/office/drawing/2017/decorative" val="1"/>
+              </a:ext>
+            </a:extLst>
+          </p:cNvPr>
+          <p:cNvCxnSpPr>
+            <a:cxnSpLocks noGrp="1" noRot="1" noChangeAspect="1" noMove="1" noResize="1" noEditPoints="1" noAdjustHandles="1" noChangeArrowheads="1" noChangeShapeType="1"/>
+          </p:cNvCxnSpPr>
+          <p:nvPr>
+            <p:extLst>
+              <p:ext uri="{386F3935-93C4-4BCD-93E2-E3B085C9AB24}">
+                <p16:designElem xmlns:p16="http://schemas.microsoft.com/office/powerpoint/2015/main" val="1"/>
+              </p:ext>
+            </p:extLst>
+          </p:nvPr>
+        </p:nvCxnSpPr>
+        <p:spPr>
+          <a:xfrm>
+            <a:off x="0" y="6128413"/>
+            <a:ext cx="12192000" cy="0"/>
+          </a:xfrm>
+          <a:prstGeom prst="line">
+            <a:avLst/>
+          </a:prstGeom>
+          <a:ln w="12700">
+            <a:solidFill>
+              <a:srgbClr val="000001">
+                <a:alpha val="20000"/>
+              </a:srgbClr>
+            </a:solidFill>
+          </a:ln>
+        </p:spPr>
+        <p:style>
+          <a:lnRef idx="1">
+            <a:schemeClr val="accent1"/>
+          </a:lnRef>
+          <a:fillRef idx="0">
+            <a:schemeClr val="accent1"/>
+          </a:fillRef>
+          <a:effectRef idx="0">
+            <a:schemeClr val="accent1"/>
+          </a:effectRef>
+          <a:fontRef idx="minor">
+            <a:schemeClr val="tx1"/>
+          </a:fontRef>
+        </p:style>
+      </p:cxnSp>
+    </p:spTree>
+    <p:extLst>
+      <p:ext uri="{BB962C8B-B14F-4D97-AF65-F5344CB8AC3E}">
+        <p14:creationId xmlns:p14="http://schemas.microsoft.com/office/powerpoint/2010/main" val="851204681"/>
+      </p:ext>
+    </p:extLst>
+  </p:cSld>
+  <p:clrMapOvr>
+    <a:masterClrMapping/>
+  </p:clrMapOvr>
+</p:sld>
+</file>
+
+<file path=ppt/slides/slide13.xml><?xml version="1.0" encoding="utf-8"?>
+<p:sld xmlns:a="http://schemas.openxmlformats.org/drawingml/2006/main" xmlns:r="http://schemas.openxmlformats.org/officeDocument/2006/relationships" xmlns:p="http://schemas.openxmlformats.org/presentationml/2006/main">
+  <p:cSld>
+    <p:bg>
+      <p:bgPr>
+        <a:gradFill rotWithShape="1">
+          <a:gsLst>
+            <a:gs pos="0">
+              <a:schemeClr val="bg2">
+                <a:tint val="94000"/>
+                <a:satMod val="80000"/>
+                <a:lumMod val="106000"/>
+              </a:schemeClr>
+            </a:gs>
+            <a:gs pos="100000">
+              <a:schemeClr val="bg2">
+                <a:shade val="80000"/>
+              </a:schemeClr>
+            </a:gs>
+          </a:gsLst>
+          <a:path path="circle">
+            <a:fillToRect l="43000" r="43000" b="100000"/>
+          </a:path>
+        </a:gradFill>
+        <a:effectLst/>
+      </p:bgPr>
+    </p:bg>
+    <p:spTree>
+      <p:nvGrpSpPr>
+        <p:cNvPr id="1" name=""/>
+        <p:cNvGrpSpPr/>
+        <p:nvPr/>
+      </p:nvGrpSpPr>
+      <p:grpSpPr>
+        <a:xfrm>
+          <a:off x="0" y="0"/>
+          <a:ext cx="0" cy="0"/>
+          <a:chOff x="0" y="0"/>
+          <a:chExt cx="0" cy="0"/>
+        </a:xfrm>
+      </p:grpSpPr>
+      <p:sp>
+        <p:nvSpPr>
+          <p:cNvPr id="38" name="Rectangle 37">
+            <a:extLst>
+              <a:ext uri="{FF2B5EF4-FFF2-40B4-BE49-F238E27FC236}">
+                <a16:creationId xmlns:a16="http://schemas.microsoft.com/office/drawing/2014/main" id="{E724B9E8-02C8-4B2E-8770-A00A67760DF0}"/>
+              </a:ext>
+              <a:ext uri="{C183D7F6-B498-43B3-948B-1728B52AA6E4}">
+                <adec:decorative xmlns:adec="http://schemas.microsoft.com/office/drawing/2017/decorative" val="1"/>
+              </a:ext>
+            </a:extLst>
+          </p:cNvPr>
+          <p:cNvSpPr>
+            <a:spLocks noGrp="1" noRot="1" noChangeAspect="1" noMove="1" noResize="1" noEditPoints="1" noAdjustHandles="1" noChangeArrowheads="1" noChangeShapeType="1" noTextEdit="1"/>
+          </p:cNvSpPr>
+          <p:nvPr>
+            <p:extLst>
+              <p:ext uri="{386F3935-93C4-4BCD-93E2-E3B085C9AB24}">
+                <p16:designElem xmlns:p16="http://schemas.microsoft.com/office/powerpoint/2015/main" val="1"/>
+              </p:ext>
+            </p:extLst>
+          </p:nvPr>
+        </p:nvSpPr>
+        <p:spPr>
+          <a:xfrm>
+            <a:off x="0" y="2019476"/>
+            <a:ext cx="12192000" cy="4105941"/>
+          </a:xfrm>
+          <a:prstGeom prst="rect">
+            <a:avLst/>
+          </a:prstGeom>
+          <a:gradFill flip="none" rotWithShape="1">
+            <a:gsLst>
+              <a:gs pos="0">
+                <a:schemeClr val="bg2">
+                  <a:alpha val="0"/>
+                </a:schemeClr>
+              </a:gs>
+              <a:gs pos="100000">
+                <a:schemeClr val="bg2"/>
+              </a:gs>
+            </a:gsLst>
+            <a:lin ang="5400000" scaled="0"/>
+            <a:tileRect/>
+          </a:gradFill>
+          <a:ln>
+            <a:noFill/>
+          </a:ln>
+        </p:spPr>
+        <p:style>
+          <a:lnRef idx="2">
+            <a:schemeClr val="accent1">
+              <a:shade val="50000"/>
+            </a:schemeClr>
+          </a:lnRef>
+          <a:fillRef idx="1">
+            <a:schemeClr val="accent1"/>
+          </a:fillRef>
+          <a:effectRef idx="0">
+            <a:schemeClr val="accent1"/>
+          </a:effectRef>
+          <a:fontRef idx="minor">
+            <a:schemeClr val="lt1"/>
+          </a:fontRef>
+        </p:style>
+        <p:txBody>
+          <a:bodyPr/>
+          <a:lstStyle/>
+          <a:p>
+            <a:endParaRPr lang="en-US"/>
+          </a:p>
+        </p:txBody>
+      </p:sp>
+      <p:pic>
+        <p:nvPicPr>
+          <p:cNvPr id="39" name="Picture 38">
+            <a:extLst>
+              <a:ext uri="{FF2B5EF4-FFF2-40B4-BE49-F238E27FC236}">
+                <a16:creationId xmlns:a16="http://schemas.microsoft.com/office/drawing/2014/main" id="{7B8AE548-0BFA-4792-9962-3375923C7635}"/>
+              </a:ext>
+              <a:ext uri="{C183D7F6-B498-43B3-948B-1728B52AA6E4}">
+                <adec:decorative xmlns:adec="http://schemas.microsoft.com/office/drawing/2017/decorative" val="1"/>
+              </a:ext>
+            </a:extLst>
+          </p:cNvPr>
+          <p:cNvPicPr>
+            <a:picLocks noGrp="1" noRot="1" noChangeAspect="1" noMove="1" noResize="1" noEditPoints="1" noAdjustHandles="1" noChangeArrowheads="1" noChangeShapeType="1" noCrop="1"/>
+          </p:cNvPicPr>
+          <p:nvPr>
+            <p:extLst>
+              <p:ext uri="{386F3935-93C4-4BCD-93E2-E3B085C9AB24}">
+                <p16:designElem xmlns:p16="http://schemas.microsoft.com/office/powerpoint/2015/main" val="1"/>
+              </p:ext>
+            </p:extLst>
+          </p:nvPr>
+        </p:nvPicPr>
+        <p:blipFill rotWithShape="1">
+          <a:blip r:embed="rId2">
+            <a:extLst>
+              <a:ext uri="{28A0092B-C50C-407E-A947-70E740481C1C}">
+                <a14:useLocalDpi xmlns:a14="http://schemas.microsoft.com/office/drawing/2010/main" val="0"/>
+              </a:ext>
+            </a:extLst>
+          </a:blip>
+          <a:srcRect t="1538" b="-1538"/>
+          <a:stretch/>
+        </p:blipFill>
+        <p:spPr bwMode="black">
+          <a:xfrm>
+            <a:off x="0" y="6126480"/>
+            <a:ext cx="12192000" cy="742950"/>
+          </a:xfrm>
+          <a:prstGeom prst="rect">
+            <a:avLst/>
+          </a:prstGeom>
+        </p:spPr>
+      </p:pic>
+      <p:cxnSp>
+        <p:nvCxnSpPr>
+          <p:cNvPr id="40" name="Straight Connector 39">
+            <a:extLst>
+              <a:ext uri="{FF2B5EF4-FFF2-40B4-BE49-F238E27FC236}">
+                <a16:creationId xmlns:a16="http://schemas.microsoft.com/office/drawing/2014/main" id="{67639EF4-FA83-4D85-90FE-B831AF283896}"/>
+              </a:ext>
+              <a:ext uri="{C183D7F6-B498-43B3-948B-1728B52AA6E4}">
+                <adec:decorative xmlns:adec="http://schemas.microsoft.com/office/drawing/2017/decorative" val="1"/>
+              </a:ext>
+            </a:extLst>
+          </p:cNvPr>
+          <p:cNvCxnSpPr>
+            <a:cxnSpLocks noGrp="1" noRot="1" noChangeAspect="1" noMove="1" noResize="1" noEditPoints="1" noAdjustHandles="1" noChangeArrowheads="1" noChangeShapeType="1"/>
+          </p:cNvCxnSpPr>
+          <p:nvPr>
+            <p:extLst>
+              <p:ext uri="{386F3935-93C4-4BCD-93E2-E3B085C9AB24}">
+                <p16:designElem xmlns:p16="http://schemas.microsoft.com/office/powerpoint/2015/main" val="1"/>
+              </p:ext>
+            </p:extLst>
+          </p:nvPr>
+        </p:nvCxnSpPr>
+        <p:spPr>
+          <a:xfrm>
+            <a:off x="0" y="6128413"/>
+            <a:ext cx="12192000" cy="0"/>
+          </a:xfrm>
+          <a:prstGeom prst="line">
+            <a:avLst/>
+          </a:prstGeom>
+          <a:ln w="12700">
+            <a:solidFill>
+              <a:srgbClr val="000001">
+                <a:alpha val="20000"/>
+              </a:srgbClr>
+            </a:solidFill>
+          </a:ln>
+        </p:spPr>
+        <p:style>
+          <a:lnRef idx="1">
+            <a:schemeClr val="accent1"/>
+          </a:lnRef>
+          <a:fillRef idx="0">
+            <a:schemeClr val="accent1"/>
+          </a:fillRef>
+          <a:effectRef idx="0">
+            <a:schemeClr val="accent1"/>
+          </a:effectRef>
+          <a:fontRef idx="minor">
+            <a:schemeClr val="tx1"/>
+          </a:fontRef>
+        </p:style>
+      </p:cxnSp>
+      <p:cxnSp>
+        <p:nvCxnSpPr>
+          <p:cNvPr id="41" name="Straight Connector 40">
+            <a:extLst>
+              <a:ext uri="{FF2B5EF4-FFF2-40B4-BE49-F238E27FC236}">
+                <a16:creationId xmlns:a16="http://schemas.microsoft.com/office/drawing/2014/main" id="{CC87E76A-8F50-413D-9BFC-C5A1525BD9BC}"/>
+              </a:ext>
+              <a:ext uri="{C183D7F6-B498-43B3-948B-1728B52AA6E4}">
+                <adec:decorative xmlns:adec="http://schemas.microsoft.com/office/drawing/2017/decorative" val="1"/>
+              </a:ext>
+            </a:extLst>
+          </p:cNvPr>
+          <p:cNvCxnSpPr>
+            <a:cxnSpLocks noGrp="1" noRot="1" noChangeAspect="1" noMove="1" noResize="1" noEditPoints="1" noAdjustHandles="1" noChangeArrowheads="1" noChangeShapeType="1"/>
+          </p:cNvCxnSpPr>
+          <p:nvPr>
+            <p:extLst>
+              <p:ext uri="{386F3935-93C4-4BCD-93E2-E3B085C9AB24}">
+                <p16:designElem xmlns:p16="http://schemas.microsoft.com/office/powerpoint/2015/main" val="1"/>
+              </p:ext>
+            </p:extLst>
+          </p:nvPr>
+        </p:nvCxnSpPr>
+        <p:spPr>
+          <a:xfrm>
+            <a:off x="2417780" y="3528542"/>
+            <a:ext cx="8637072" cy="0"/>
+          </a:xfrm>
+          <a:prstGeom prst="line">
+            <a:avLst/>
+          </a:prstGeom>
+          <a:ln w="31750"/>
+        </p:spPr>
+        <p:style>
+          <a:lnRef idx="3">
+            <a:schemeClr val="accent1"/>
+          </a:lnRef>
+          <a:fillRef idx="0">
+            <a:schemeClr val="accent1"/>
+          </a:fillRef>
+          <a:effectRef idx="2">
+            <a:schemeClr val="accent1"/>
+          </a:effectRef>
+          <a:fontRef idx="minor">
+            <a:schemeClr val="tx1"/>
+          </a:fontRef>
+        </p:style>
+      </p:cxnSp>
+      <p:sp useBgFill="1">
+        <p:nvSpPr>
+          <p:cNvPr id="42" name="Rectangle 41">
+            <a:extLst>
+              <a:ext uri="{FF2B5EF4-FFF2-40B4-BE49-F238E27FC236}">
+                <a16:creationId xmlns:a16="http://schemas.microsoft.com/office/drawing/2014/main" id="{9A1C6278-B7D5-4E8E-B4DC-834832980565}"/>
+              </a:ext>
+              <a:ext uri="{C183D7F6-B498-43B3-948B-1728B52AA6E4}">
+                <adec:decorative xmlns:adec="http://schemas.microsoft.com/office/drawing/2017/decorative" val="1"/>
+              </a:ext>
+            </a:extLst>
+          </p:cNvPr>
+          <p:cNvSpPr>
+            <a:spLocks noGrp="1" noRot="1" noChangeAspect="1" noMove="1" noResize="1" noEditPoints="1" noAdjustHandles="1" noChangeArrowheads="1" noChangeShapeType="1" noTextEdit="1"/>
+          </p:cNvSpPr>
+          <p:nvPr>
+            <p:extLst>
+              <p:ext uri="{386F3935-93C4-4BCD-93E2-E3B085C9AB24}">
+                <p16:designElem xmlns:p16="http://schemas.microsoft.com/office/powerpoint/2015/main" val="1"/>
+              </p:ext>
+            </p:extLst>
+          </p:nvPr>
+        </p:nvSpPr>
+        <p:spPr>
+          <a:xfrm>
+            <a:off x="2" y="0"/>
+            <a:ext cx="12191695" cy="6858000"/>
+          </a:xfrm>
+          <a:prstGeom prst="rect">
+            <a:avLst/>
+          </a:prstGeom>
+          <a:ln>
+            <a:noFill/>
+          </a:ln>
+        </p:spPr>
+        <p:style>
+          <a:lnRef idx="2">
+            <a:schemeClr val="accent1">
+              <a:shade val="50000"/>
+            </a:schemeClr>
+          </a:lnRef>
+          <a:fillRef idx="1">
+            <a:schemeClr val="accent1"/>
+          </a:fillRef>
+          <a:effectRef idx="0">
+            <a:schemeClr val="accent1"/>
+          </a:effectRef>
+          <a:fontRef idx="minor">
+            <a:schemeClr val="lt1"/>
+          </a:fontRef>
+        </p:style>
+        <p:txBody>
+          <a:bodyPr rtlCol="0" anchor="ctr"/>
+          <a:lstStyle/>
+          <a:p>
+            <a:pPr algn="ctr"/>
+            <a:endParaRPr lang="en-US"/>
+          </a:p>
+        </p:txBody>
+      </p:sp>
+      <p:sp>
+        <p:nvSpPr>
+          <p:cNvPr id="43" name="Rectangle 42">
+            <a:extLst>
+              <a:ext uri="{FF2B5EF4-FFF2-40B4-BE49-F238E27FC236}">
+                <a16:creationId xmlns:a16="http://schemas.microsoft.com/office/drawing/2014/main" id="{C007F3D3-099E-430E-8754-C084D0FA5FE3}"/>
+              </a:ext>
+              <a:ext uri="{C183D7F6-B498-43B3-948B-1728B52AA6E4}">
+                <adec:decorative xmlns:adec="http://schemas.microsoft.com/office/drawing/2017/decorative" val="1"/>
+              </a:ext>
+            </a:extLst>
+          </p:cNvPr>
+          <p:cNvSpPr>
+            <a:spLocks noGrp="1" noRot="1" noChangeAspect="1" noMove="1" noResize="1" noEditPoints="1" noAdjustHandles="1" noChangeArrowheads="1" noChangeShapeType="1" noTextEdit="1"/>
+          </p:cNvSpPr>
+          <p:nvPr>
+            <p:extLst>
+              <p:ext uri="{386F3935-93C4-4BCD-93E2-E3B085C9AB24}">
+                <p16:designElem xmlns:p16="http://schemas.microsoft.com/office/powerpoint/2015/main" val="1"/>
+              </p:ext>
+            </p:extLst>
+          </p:nvPr>
+        </p:nvSpPr>
+        <p:spPr>
+          <a:xfrm>
+            <a:off x="0" y="2019476"/>
+            <a:ext cx="12192000" cy="4105941"/>
+          </a:xfrm>
+          <a:prstGeom prst="rect">
+            <a:avLst/>
+          </a:prstGeom>
+          <a:gradFill flip="none" rotWithShape="1">
+            <a:gsLst>
+              <a:gs pos="0">
+                <a:schemeClr val="bg2">
+                  <a:alpha val="0"/>
+                </a:schemeClr>
+              </a:gs>
+              <a:gs pos="100000">
+                <a:schemeClr val="bg2"/>
+              </a:gs>
+            </a:gsLst>
+            <a:lin ang="5400000" scaled="0"/>
+            <a:tileRect/>
+          </a:gradFill>
+          <a:ln>
+            <a:noFill/>
+          </a:ln>
+        </p:spPr>
+        <p:style>
+          <a:lnRef idx="2">
+            <a:schemeClr val="accent1">
+              <a:shade val="50000"/>
+            </a:schemeClr>
+          </a:lnRef>
+          <a:fillRef idx="1">
+            <a:schemeClr val="accent1"/>
+          </a:fillRef>
+          <a:effectRef idx="0">
+            <a:schemeClr val="accent1"/>
+          </a:effectRef>
+          <a:fontRef idx="minor">
+            <a:schemeClr val="lt1"/>
+          </a:fontRef>
+        </p:style>
+        <p:txBody>
+          <a:bodyPr rtlCol="0" anchor="ctr"/>
+          <a:lstStyle/>
+          <a:p>
+            <a:pPr lvl="0" algn="ctr"/>
+            <a:endParaRPr lang="en-US"/>
+          </a:p>
+        </p:txBody>
+      </p:sp>
+      <p:sp>
+        <p:nvSpPr>
+          <p:cNvPr id="2" name="Title 1">
+            <a:extLst>
+              <a:ext uri="{FF2B5EF4-FFF2-40B4-BE49-F238E27FC236}">
+                <a16:creationId xmlns:a16="http://schemas.microsoft.com/office/drawing/2014/main" id="{39DDDFD2-F9A9-3A01-FF2A-6CDF8AAF1529}"/>
+              </a:ext>
+            </a:extLst>
+          </p:cNvPr>
+          <p:cNvSpPr>
+            <a:spLocks noGrp="1"/>
+          </p:cNvSpPr>
+          <p:nvPr>
+            <p:ph type="title"/>
+          </p:nvPr>
+        </p:nvSpPr>
+        <p:spPr>
+          <a:xfrm>
+            <a:off x="1776729" y="4459039"/>
+            <a:ext cx="8643011" cy="551528"/>
+          </a:xfrm>
+        </p:spPr>
+        <p:txBody>
+          <a:bodyPr vert="horz" lIns="91440" tIns="45720" rIns="91440" bIns="0" rtlCol="0" anchor="b">
+            <a:normAutofit/>
+          </a:bodyPr>
+          <a:lstStyle/>
+          <a:p>
+            <a:r>
+              <a:rPr lang="en-US" sz="3600"/>
+              <a:t>Vlajk Sándor – Dokumentáció</a:t>
+            </a:r>
+          </a:p>
+        </p:txBody>
+      </p:sp>
+      <p:pic>
+        <p:nvPicPr>
+          <p:cNvPr id="11" name="Picture 10">
+            <a:extLst>
+              <a:ext uri="{FF2B5EF4-FFF2-40B4-BE49-F238E27FC236}">
+                <a16:creationId xmlns:a16="http://schemas.microsoft.com/office/drawing/2014/main" id="{3C11F97F-2AE4-3D9B-35A6-AF80BEF77AF7}"/>
+              </a:ext>
+            </a:extLst>
+          </p:cNvPr>
+          <p:cNvPicPr>
+            <a:picLocks noChangeAspect="1"/>
+          </p:cNvPicPr>
+          <p:nvPr/>
+        </p:nvPicPr>
+        <p:blipFill>
+          <a:blip r:embed="rId3"/>
+          <a:stretch>
+            <a:fillRect/>
+          </a:stretch>
+        </p:blipFill>
+        <p:spPr>
+          <a:xfrm>
+            <a:off x="215647" y="470463"/>
+            <a:ext cx="3553338" cy="3856996"/>
+          </a:xfrm>
+          <a:prstGeom prst="rect">
+            <a:avLst/>
+          </a:prstGeom>
+        </p:spPr>
+      </p:pic>
+      <p:pic>
+        <p:nvPicPr>
+          <p:cNvPr id="9" name="Picture 8">
+            <a:extLst>
+              <a:ext uri="{FF2B5EF4-FFF2-40B4-BE49-F238E27FC236}">
+                <a16:creationId xmlns:a16="http://schemas.microsoft.com/office/drawing/2014/main" id="{EB92CDCE-F939-2C1B-FB2C-35BCFBC61213}"/>
+              </a:ext>
+            </a:extLst>
+          </p:cNvPr>
+          <p:cNvPicPr>
+            <a:picLocks noChangeAspect="1"/>
+          </p:cNvPicPr>
+          <p:nvPr/>
+        </p:nvPicPr>
+        <p:blipFill>
+          <a:blip r:embed="rId4"/>
+          <a:stretch>
+            <a:fillRect/>
+          </a:stretch>
+        </p:blipFill>
+        <p:spPr>
+          <a:xfrm>
+            <a:off x="4025898" y="890198"/>
+            <a:ext cx="3376192" cy="3215823"/>
+          </a:xfrm>
+          <a:prstGeom prst="rect">
+            <a:avLst/>
+          </a:prstGeom>
+        </p:spPr>
+      </p:pic>
+      <p:pic>
+        <p:nvPicPr>
+          <p:cNvPr id="5" name="Picture 4">
+            <a:extLst>
+              <a:ext uri="{FF2B5EF4-FFF2-40B4-BE49-F238E27FC236}">
+                <a16:creationId xmlns:a16="http://schemas.microsoft.com/office/drawing/2014/main" id="{C20FFCFC-0AFB-A5C7-E6B7-F9D1DC4B2FC6}"/>
+              </a:ext>
+            </a:extLst>
+          </p:cNvPr>
+          <p:cNvPicPr>
+            <a:picLocks noChangeAspect="1"/>
+          </p:cNvPicPr>
+          <p:nvPr/>
+        </p:nvPicPr>
+        <p:blipFill>
+          <a:blip r:embed="rId5"/>
+          <a:stretch>
+            <a:fillRect/>
+          </a:stretch>
+        </p:blipFill>
+        <p:spPr>
+          <a:xfrm>
+            <a:off x="7659003" y="1278460"/>
+            <a:ext cx="4317350" cy="2439301"/>
+          </a:xfrm>
+          <a:prstGeom prst="rect">
+            <a:avLst/>
+          </a:prstGeom>
+        </p:spPr>
+      </p:pic>
+      <p:cxnSp>
+        <p:nvCxnSpPr>
+          <p:cNvPr id="44" name="Straight Connector 43">
+            <a:extLst>
+              <a:ext uri="{FF2B5EF4-FFF2-40B4-BE49-F238E27FC236}">
+                <a16:creationId xmlns:a16="http://schemas.microsoft.com/office/drawing/2014/main" id="{6B9EA5DA-6DFD-447D-B8F9-CB95CA114076}"/>
+              </a:ext>
+              <a:ext uri="{C183D7F6-B498-43B3-948B-1728B52AA6E4}">
+                <adec:decorative xmlns:adec="http://schemas.microsoft.com/office/drawing/2017/decorative" val="1"/>
+              </a:ext>
+            </a:extLst>
+          </p:cNvPr>
+          <p:cNvCxnSpPr>
+            <a:cxnSpLocks noGrp="1" noRot="1" noChangeAspect="1" noMove="1" noResize="1" noEditPoints="1" noAdjustHandles="1" noChangeArrowheads="1" noChangeShapeType="1"/>
+          </p:cNvCxnSpPr>
+          <p:nvPr>
+            <p:extLst>
+              <p:ext uri="{386F3935-93C4-4BCD-93E2-E3B085C9AB24}">
+                <p16:designElem xmlns:p16="http://schemas.microsoft.com/office/powerpoint/2015/main" val="1"/>
+              </p:ext>
+            </p:extLst>
+          </p:nvPr>
+        </p:nvCxnSpPr>
+        <p:spPr>
+          <a:xfrm>
+            <a:off x="1776728" y="5027185"/>
+            <a:ext cx="8643011" cy="0"/>
+          </a:xfrm>
+          <a:prstGeom prst="line">
+            <a:avLst/>
+          </a:prstGeom>
+          <a:ln w="31750"/>
+        </p:spPr>
+        <p:style>
+          <a:lnRef idx="3">
+            <a:schemeClr val="accent1"/>
+          </a:lnRef>
+          <a:fillRef idx="0">
+            <a:schemeClr val="accent1"/>
+          </a:fillRef>
+          <a:effectRef idx="2">
+            <a:schemeClr val="accent1"/>
+          </a:effectRef>
+          <a:fontRef idx="minor">
+            <a:schemeClr val="tx1"/>
+          </a:fontRef>
+        </p:style>
+      </p:cxnSp>
+      <p:pic>
+        <p:nvPicPr>
+          <p:cNvPr id="45" name="Picture 44">
+            <a:extLst>
+              <a:ext uri="{FF2B5EF4-FFF2-40B4-BE49-F238E27FC236}">
+                <a16:creationId xmlns:a16="http://schemas.microsoft.com/office/drawing/2014/main" id="{87612EF9-94E7-42BA-B4A9-4B38643FBAF7}"/>
+              </a:ext>
+              <a:ext uri="{C183D7F6-B498-43B3-948B-1728B52AA6E4}">
+                <adec:decorative xmlns:adec="http://schemas.microsoft.com/office/drawing/2017/decorative" val="1"/>
+              </a:ext>
+            </a:extLst>
+          </p:cNvPr>
+          <p:cNvPicPr>
+            <a:picLocks noGrp="1" noRot="1" noChangeAspect="1" noMove="1" noResize="1" noEditPoints="1" noAdjustHandles="1" noChangeArrowheads="1" noChangeShapeType="1" noCrop="1"/>
+          </p:cNvPicPr>
+          <p:nvPr>
+            <p:extLst>
+              <p:ext uri="{386F3935-93C4-4BCD-93E2-E3B085C9AB24}">
+                <p16:designElem xmlns:p16="http://schemas.microsoft.com/office/powerpoint/2015/main" val="1"/>
+              </p:ext>
+            </p:extLst>
+          </p:nvPr>
+        </p:nvPicPr>
+        <p:blipFill rotWithShape="1">
+          <a:blip r:embed="rId2">
+            <a:extLst>
+              <a:ext uri="{28A0092B-C50C-407E-A947-70E740481C1C}">
+                <a14:useLocalDpi xmlns:a14="http://schemas.microsoft.com/office/drawing/2010/main" val="0"/>
+              </a:ext>
+            </a:extLst>
+          </a:blip>
+          <a:srcRect t="1538" b="-1538"/>
+          <a:stretch/>
+        </p:blipFill>
+        <p:spPr bwMode="black">
+          <a:xfrm>
+            <a:off x="0" y="6126480"/>
+            <a:ext cx="12192000" cy="742950"/>
+          </a:xfrm>
+          <a:prstGeom prst="rect">
+            <a:avLst/>
+          </a:prstGeom>
+        </p:spPr>
+      </p:pic>
+      <p:cxnSp>
+        <p:nvCxnSpPr>
+          <p:cNvPr id="46" name="Straight Connector 45">
+            <a:extLst>
+              <a:ext uri="{FF2B5EF4-FFF2-40B4-BE49-F238E27FC236}">
+                <a16:creationId xmlns:a16="http://schemas.microsoft.com/office/drawing/2014/main" id="{9E597F0B-0A17-4BF2-A904-9D99811F3E2E}"/>
+              </a:ext>
+              <a:ext uri="{C183D7F6-B498-43B3-948B-1728B52AA6E4}">
+                <adec:decorative xmlns:adec="http://schemas.microsoft.com/office/drawing/2017/decorative" val="1"/>
+              </a:ext>
+            </a:extLst>
+          </p:cNvPr>
+          <p:cNvCxnSpPr>
+            <a:cxnSpLocks noGrp="1" noRot="1" noChangeAspect="1" noMove="1" noResize="1" noEditPoints="1" noAdjustHandles="1" noChangeArrowheads="1" noChangeShapeType="1"/>
+          </p:cNvCxnSpPr>
+          <p:nvPr>
+            <p:extLst>
+              <p:ext uri="{386F3935-93C4-4BCD-93E2-E3B085C9AB24}">
+                <p16:designElem xmlns:p16="http://schemas.microsoft.com/office/powerpoint/2015/main" val="1"/>
+              </p:ext>
+            </p:extLst>
+          </p:nvPr>
+        </p:nvCxnSpPr>
+        <p:spPr>
+          <a:xfrm>
+            <a:off x="0" y="6128413"/>
+            <a:ext cx="12192000" cy="0"/>
+          </a:xfrm>
+          <a:prstGeom prst="line">
+            <a:avLst/>
+          </a:prstGeom>
+          <a:ln w="12700">
+            <a:solidFill>
+              <a:srgbClr val="000001">
+                <a:alpha val="20000"/>
+              </a:srgbClr>
+            </a:solidFill>
+          </a:ln>
+        </p:spPr>
+        <p:style>
+          <a:lnRef idx="1">
+            <a:schemeClr val="accent1"/>
+          </a:lnRef>
+          <a:fillRef idx="0">
+            <a:schemeClr val="accent1"/>
+          </a:fillRef>
+          <a:effectRef idx="0">
+            <a:schemeClr val="accent1"/>
+          </a:effectRef>
+          <a:fontRef idx="minor">
+            <a:schemeClr val="tx1"/>
+          </a:fontRef>
+        </p:style>
+      </p:cxnSp>
+    </p:spTree>
+    <p:extLst>
+      <p:ext uri="{BB962C8B-B14F-4D97-AF65-F5344CB8AC3E}">
+        <p14:creationId xmlns:p14="http://schemas.microsoft.com/office/powerpoint/2010/main" val="3510849585"/>
+      </p:ext>
+    </p:extLst>
+  </p:cSld>
+  <p:clrMapOvr>
+    <a:masterClrMapping/>
+  </p:clrMapOvr>
+</p:sld>
+</file>
+
+<file path=ppt/slides/slide14.xml><?xml version="1.0" encoding="utf-8"?>
+<p:sld xmlns:a="http://schemas.openxmlformats.org/drawingml/2006/main" xmlns:r="http://schemas.openxmlformats.org/officeDocument/2006/relationships" xmlns:p="http://schemas.openxmlformats.org/presentationml/2006/main">
+  <p:cSld>
+    <p:spTree>
+      <p:nvGrpSpPr>
+        <p:cNvPr id="1" name=""/>
+        <p:cNvGrpSpPr/>
+        <p:nvPr/>
+      </p:nvGrpSpPr>
+      <p:grpSpPr>
+        <a:xfrm>
+          <a:off x="0" y="0"/>
+          <a:ext cx="0" cy="0"/>
+          <a:chOff x="0" y="0"/>
+          <a:chExt cx="0" cy="0"/>
+        </a:xfrm>
+      </p:grpSpPr>
+      <p:sp>
+        <p:nvSpPr>
+          <p:cNvPr id="2" name="Title 1">
+            <a:extLst>
+              <a:ext uri="{FF2B5EF4-FFF2-40B4-BE49-F238E27FC236}">
+                <a16:creationId xmlns:a16="http://schemas.microsoft.com/office/drawing/2014/main" id="{6302D0E6-DFB3-5E17-192B-D3B11F717D8C}"/>
+              </a:ext>
+            </a:extLst>
+          </p:cNvPr>
+          <p:cNvSpPr>
+            <a:spLocks noGrp="1"/>
+          </p:cNvSpPr>
+          <p:nvPr>
+            <p:ph type="title"/>
+          </p:nvPr>
+        </p:nvSpPr>
+        <p:spPr/>
+        <p:txBody>
+          <a:bodyPr/>
+          <a:lstStyle/>
+          <a:p>
+            <a:r>
+              <a:rPr lang="en-US" dirty="0"/>
+              <a:t>Vlajk Sándor – </a:t>
+            </a:r>
+            <a:r>
+              <a:rPr lang="en-US" dirty="0" err="1"/>
+              <a:t>Fejlesztés</a:t>
+            </a:r>
+            <a:endParaRPr lang="en-US" dirty="0"/>
+          </a:p>
+        </p:txBody>
+      </p:sp>
+      <p:pic>
+        <p:nvPicPr>
+          <p:cNvPr id="5" name="Picture 4">
+            <a:extLst>
+              <a:ext uri="{FF2B5EF4-FFF2-40B4-BE49-F238E27FC236}">
+                <a16:creationId xmlns:a16="http://schemas.microsoft.com/office/drawing/2014/main" id="{E7DCF374-80C3-CBE5-BC73-F12C234A38EC}"/>
+              </a:ext>
+            </a:extLst>
+          </p:cNvPr>
+          <p:cNvPicPr>
+            <a:picLocks noChangeAspect="1"/>
+          </p:cNvPicPr>
+          <p:nvPr/>
+        </p:nvPicPr>
+        <p:blipFill>
+          <a:blip r:embed="rId2"/>
+          <a:stretch>
+            <a:fillRect/>
+          </a:stretch>
+        </p:blipFill>
+        <p:spPr>
+          <a:xfrm>
+            <a:off x="809387" y="2190530"/>
+            <a:ext cx="8630854" cy="3143689"/>
+          </a:xfrm>
+          <a:prstGeom prst="rect">
+            <a:avLst/>
+          </a:prstGeom>
+        </p:spPr>
+      </p:pic>
+      <p:pic>
+        <p:nvPicPr>
+          <p:cNvPr id="7" name="Picture 6">
+            <a:extLst>
+              <a:ext uri="{FF2B5EF4-FFF2-40B4-BE49-F238E27FC236}">
+                <a16:creationId xmlns:a16="http://schemas.microsoft.com/office/drawing/2014/main" id="{13C83DBE-18EF-02F8-4CDE-12A988AA16AE}"/>
+              </a:ext>
+            </a:extLst>
+          </p:cNvPr>
+          <p:cNvPicPr>
+            <a:picLocks noChangeAspect="1"/>
+          </p:cNvPicPr>
+          <p:nvPr/>
+        </p:nvPicPr>
+        <p:blipFill>
+          <a:blip r:embed="rId3"/>
+          <a:stretch>
+            <a:fillRect/>
+          </a:stretch>
+        </p:blipFill>
+        <p:spPr>
+          <a:xfrm>
+            <a:off x="809387" y="5504284"/>
+            <a:ext cx="3410426" cy="333422"/>
+          </a:xfrm>
+          <a:prstGeom prst="rect">
+            <a:avLst/>
+          </a:prstGeom>
+        </p:spPr>
+      </p:pic>
+    </p:spTree>
+    <p:extLst>
+      <p:ext uri="{BB962C8B-B14F-4D97-AF65-F5344CB8AC3E}">
+        <p14:creationId xmlns:p14="http://schemas.microsoft.com/office/powerpoint/2010/main" val="2040790998"/>
+      </p:ext>
+    </p:extLst>
+  </p:cSld>
+  <p:clrMapOvr>
+    <a:masterClrMapping/>
+  </p:clrMapOvr>
+</p:sld>
+</file>
+
+<file path=ppt/slides/slide15.xml><?xml version="1.0" encoding="utf-8"?>
+<p:sld xmlns:a="http://schemas.openxmlformats.org/drawingml/2006/main" xmlns:r="http://schemas.openxmlformats.org/officeDocument/2006/relationships" xmlns:p="http://schemas.openxmlformats.org/presentationml/2006/main">
+  <p:cSld>
+    <p:bg>
+      <p:bgPr>
+        <a:gradFill rotWithShape="1">
+          <a:gsLst>
+            <a:gs pos="0">
+              <a:schemeClr val="bg2">
+                <a:tint val="94000"/>
+                <a:satMod val="80000"/>
+                <a:lumMod val="106000"/>
+              </a:schemeClr>
+            </a:gs>
+            <a:gs pos="100000">
+              <a:schemeClr val="bg2">
+                <a:shade val="80000"/>
+              </a:schemeClr>
+            </a:gs>
+          </a:gsLst>
+          <a:path path="circle">
+            <a:fillToRect l="43000" r="43000" b="100000"/>
+          </a:path>
+        </a:gradFill>
+        <a:effectLst/>
+      </p:bgPr>
+    </p:bg>
+    <p:spTree>
+      <p:nvGrpSpPr>
+        <p:cNvPr id="1" name=""/>
+        <p:cNvGrpSpPr/>
+        <p:nvPr/>
+      </p:nvGrpSpPr>
+      <p:grpSpPr>
+        <a:xfrm>
+          <a:off x="0" y="0"/>
+          <a:ext cx="0" cy="0"/>
+          <a:chOff x="0" y="0"/>
+          <a:chExt cx="0" cy="0"/>
+        </a:xfrm>
+      </p:grpSpPr>
+      <p:sp>
+        <p:nvSpPr>
+          <p:cNvPr id="14" name="Rectangle 13">
+            <a:extLst>
+              <a:ext uri="{FF2B5EF4-FFF2-40B4-BE49-F238E27FC236}">
+                <a16:creationId xmlns:a16="http://schemas.microsoft.com/office/drawing/2014/main" id="{E724B9E8-02C8-4B2E-8770-A00A67760DF0}"/>
+              </a:ext>
+              <a:ext uri="{C183D7F6-B498-43B3-948B-1728B52AA6E4}">
+                <adec:decorative xmlns:adec="http://schemas.microsoft.com/office/drawing/2017/decorative" val="1"/>
+              </a:ext>
+            </a:extLst>
+          </p:cNvPr>
+          <p:cNvSpPr>
+            <a:spLocks noGrp="1" noRot="1" noChangeAspect="1" noMove="1" noResize="1" noEditPoints="1" noAdjustHandles="1" noChangeArrowheads="1" noChangeShapeType="1" noTextEdit="1"/>
+          </p:cNvSpPr>
+          <p:nvPr>
+            <p:extLst>
+              <p:ext uri="{386F3935-93C4-4BCD-93E2-E3B085C9AB24}">
+                <p16:designElem xmlns:p16="http://schemas.microsoft.com/office/powerpoint/2015/main" val="1"/>
+              </p:ext>
+            </p:extLst>
+          </p:nvPr>
+        </p:nvSpPr>
+        <p:spPr>
+          <a:xfrm>
+            <a:off x="0" y="2019476"/>
+            <a:ext cx="12192000" cy="4105941"/>
+          </a:xfrm>
+          <a:prstGeom prst="rect">
+            <a:avLst/>
+          </a:prstGeom>
+          <a:gradFill flip="none" rotWithShape="1">
+            <a:gsLst>
+              <a:gs pos="0">
+                <a:schemeClr val="bg2">
+                  <a:alpha val="0"/>
+                </a:schemeClr>
+              </a:gs>
+              <a:gs pos="100000">
+                <a:schemeClr val="bg2"/>
+              </a:gs>
+            </a:gsLst>
+            <a:lin ang="5400000" scaled="0"/>
+            <a:tileRect/>
+          </a:gradFill>
+          <a:ln>
+            <a:noFill/>
+          </a:ln>
+        </p:spPr>
+        <p:style>
+          <a:lnRef idx="2">
+            <a:schemeClr val="accent1">
+              <a:shade val="50000"/>
+            </a:schemeClr>
+          </a:lnRef>
+          <a:fillRef idx="1">
+            <a:schemeClr val="accent1"/>
+          </a:fillRef>
+          <a:effectRef idx="0">
+            <a:schemeClr val="accent1"/>
+          </a:effectRef>
+          <a:fontRef idx="minor">
+            <a:schemeClr val="lt1"/>
+          </a:fontRef>
+        </p:style>
+        <p:txBody>
+          <a:bodyPr/>
+          <a:lstStyle/>
+          <a:p>
+            <a:endParaRPr lang="en-US"/>
+          </a:p>
+        </p:txBody>
+      </p:sp>
+      <p:pic>
+        <p:nvPicPr>
+          <p:cNvPr id="16" name="Picture 15">
+            <a:extLst>
+              <a:ext uri="{FF2B5EF4-FFF2-40B4-BE49-F238E27FC236}">
+                <a16:creationId xmlns:a16="http://schemas.microsoft.com/office/drawing/2014/main" id="{7B8AE548-0BFA-4792-9962-3375923C7635}"/>
+              </a:ext>
+              <a:ext uri="{C183D7F6-B498-43B3-948B-1728B52AA6E4}">
+                <adec:decorative xmlns:adec="http://schemas.microsoft.com/office/drawing/2017/decorative" val="1"/>
+              </a:ext>
+            </a:extLst>
+          </p:cNvPr>
+          <p:cNvPicPr>
+            <a:picLocks noGrp="1" noRot="1" noChangeAspect="1" noMove="1" noResize="1" noEditPoints="1" noAdjustHandles="1" noChangeArrowheads="1" noChangeShapeType="1" noCrop="1"/>
+          </p:cNvPicPr>
+          <p:nvPr>
+            <p:extLst>
+              <p:ext uri="{386F3935-93C4-4BCD-93E2-E3B085C9AB24}">
+                <p16:designElem xmlns:p16="http://schemas.microsoft.com/office/powerpoint/2015/main" val="1"/>
+              </p:ext>
+            </p:extLst>
+          </p:nvPr>
+        </p:nvPicPr>
+        <p:blipFill rotWithShape="1">
+          <a:blip r:embed="rId2">
+            <a:extLst>
+              <a:ext uri="{28A0092B-C50C-407E-A947-70E740481C1C}">
+                <a14:useLocalDpi xmlns:a14="http://schemas.microsoft.com/office/drawing/2010/main" val="0"/>
+              </a:ext>
+            </a:extLst>
+          </a:blip>
+          <a:srcRect t="1538" b="-1538"/>
+          <a:stretch/>
+        </p:blipFill>
+        <p:spPr bwMode="black">
+          <a:xfrm>
+            <a:off x="0" y="6126480"/>
+            <a:ext cx="12192000" cy="742950"/>
+          </a:xfrm>
+          <a:prstGeom prst="rect">
+            <a:avLst/>
+          </a:prstGeom>
+        </p:spPr>
+      </p:pic>
+      <p:cxnSp>
+        <p:nvCxnSpPr>
+          <p:cNvPr id="18" name="Straight Connector 17">
+            <a:extLst>
+              <a:ext uri="{FF2B5EF4-FFF2-40B4-BE49-F238E27FC236}">
+                <a16:creationId xmlns:a16="http://schemas.microsoft.com/office/drawing/2014/main" id="{67639EF4-FA83-4D85-90FE-B831AF283896}"/>
+              </a:ext>
+              <a:ext uri="{C183D7F6-B498-43B3-948B-1728B52AA6E4}">
+                <adec:decorative xmlns:adec="http://schemas.microsoft.com/office/drawing/2017/decorative" val="1"/>
+              </a:ext>
+            </a:extLst>
+          </p:cNvPr>
+          <p:cNvCxnSpPr>
+            <a:cxnSpLocks noGrp="1" noRot="1" noChangeAspect="1" noMove="1" noResize="1" noEditPoints="1" noAdjustHandles="1" noChangeArrowheads="1" noChangeShapeType="1"/>
+          </p:cNvCxnSpPr>
+          <p:nvPr>
+            <p:extLst>
+              <p:ext uri="{386F3935-93C4-4BCD-93E2-E3B085C9AB24}">
+                <p16:designElem xmlns:p16="http://schemas.microsoft.com/office/powerpoint/2015/main" val="1"/>
+              </p:ext>
+            </p:extLst>
+          </p:nvPr>
+        </p:nvCxnSpPr>
+        <p:spPr>
+          <a:xfrm>
+            <a:off x="0" y="6128413"/>
+            <a:ext cx="12192000" cy="0"/>
+          </a:xfrm>
+          <a:prstGeom prst="line">
+            <a:avLst/>
+          </a:prstGeom>
+          <a:ln w="12700">
+            <a:solidFill>
+              <a:srgbClr val="000001">
+                <a:alpha val="20000"/>
+              </a:srgbClr>
+            </a:solidFill>
+          </a:ln>
+        </p:spPr>
+        <p:style>
+          <a:lnRef idx="1">
+            <a:schemeClr val="accent1"/>
+          </a:lnRef>
+          <a:fillRef idx="0">
+            <a:schemeClr val="accent1"/>
+          </a:fillRef>
+          <a:effectRef idx="0">
+            <a:schemeClr val="accent1"/>
+          </a:effectRef>
+          <a:fontRef idx="minor">
+            <a:schemeClr val="tx1"/>
+          </a:fontRef>
+        </p:style>
+      </p:cxnSp>
+      <p:cxnSp>
+        <p:nvCxnSpPr>
+          <p:cNvPr id="20" name="Straight Connector 19">
+            <a:extLst>
+              <a:ext uri="{FF2B5EF4-FFF2-40B4-BE49-F238E27FC236}">
+                <a16:creationId xmlns:a16="http://schemas.microsoft.com/office/drawing/2014/main" id="{CC87E76A-8F50-413D-9BFC-C5A1525BD9BC}"/>
+              </a:ext>
+              <a:ext uri="{C183D7F6-B498-43B3-948B-1728B52AA6E4}">
+                <adec:decorative xmlns:adec="http://schemas.microsoft.com/office/drawing/2017/decorative" val="1"/>
+              </a:ext>
+            </a:extLst>
+          </p:cNvPr>
+          <p:cNvCxnSpPr>
+            <a:cxnSpLocks noGrp="1" noRot="1" noChangeAspect="1" noMove="1" noResize="1" noEditPoints="1" noAdjustHandles="1" noChangeArrowheads="1" noChangeShapeType="1"/>
+          </p:cNvCxnSpPr>
+          <p:nvPr>
+            <p:extLst>
+              <p:ext uri="{386F3935-93C4-4BCD-93E2-E3B085C9AB24}">
+                <p16:designElem xmlns:p16="http://schemas.microsoft.com/office/powerpoint/2015/main" val="1"/>
+              </p:ext>
+            </p:extLst>
+          </p:nvPr>
+        </p:nvCxnSpPr>
+        <p:spPr>
+          <a:xfrm>
+            <a:off x="2417780" y="3528542"/>
+            <a:ext cx="8637072" cy="0"/>
+          </a:xfrm>
+          <a:prstGeom prst="line">
+            <a:avLst/>
+          </a:prstGeom>
+          <a:ln w="31750"/>
+        </p:spPr>
+        <p:style>
+          <a:lnRef idx="3">
+            <a:schemeClr val="accent1"/>
+          </a:lnRef>
+          <a:fillRef idx="0">
+            <a:schemeClr val="accent1"/>
+          </a:fillRef>
+          <a:effectRef idx="2">
+            <a:schemeClr val="accent1"/>
+          </a:effectRef>
+          <a:fontRef idx="minor">
+            <a:schemeClr val="tx1"/>
+          </a:fontRef>
+        </p:style>
+      </p:cxnSp>
+      <p:sp useBgFill="1">
+        <p:nvSpPr>
+          <p:cNvPr id="22" name="Rectangle 21">
+            <a:extLst>
+              <a:ext uri="{FF2B5EF4-FFF2-40B4-BE49-F238E27FC236}">
+                <a16:creationId xmlns:a16="http://schemas.microsoft.com/office/drawing/2014/main" id="{9A1C6278-B7D5-4E8E-B4DC-834832980565}"/>
+              </a:ext>
+              <a:ext uri="{C183D7F6-B498-43B3-948B-1728B52AA6E4}">
+                <adec:decorative xmlns:adec="http://schemas.microsoft.com/office/drawing/2017/decorative" val="1"/>
+              </a:ext>
+            </a:extLst>
+          </p:cNvPr>
+          <p:cNvSpPr>
+            <a:spLocks noGrp="1" noRot="1" noChangeAspect="1" noMove="1" noResize="1" noEditPoints="1" noAdjustHandles="1" noChangeArrowheads="1" noChangeShapeType="1" noTextEdit="1"/>
+          </p:cNvSpPr>
+          <p:nvPr>
+            <p:extLst>
+              <p:ext uri="{386F3935-93C4-4BCD-93E2-E3B085C9AB24}">
+                <p16:designElem xmlns:p16="http://schemas.microsoft.com/office/powerpoint/2015/main" val="1"/>
+              </p:ext>
+            </p:extLst>
+          </p:nvPr>
+        </p:nvSpPr>
+        <p:spPr>
+          <a:xfrm>
+            <a:off x="2" y="0"/>
+            <a:ext cx="12191695" cy="6858000"/>
+          </a:xfrm>
+          <a:prstGeom prst="rect">
+            <a:avLst/>
+          </a:prstGeom>
+          <a:ln>
+            <a:noFill/>
+          </a:ln>
+        </p:spPr>
+        <p:style>
+          <a:lnRef idx="2">
+            <a:schemeClr val="accent1">
+              <a:shade val="50000"/>
+            </a:schemeClr>
+          </a:lnRef>
+          <a:fillRef idx="1">
+            <a:schemeClr val="accent1"/>
+          </a:fillRef>
+          <a:effectRef idx="0">
+            <a:schemeClr val="accent1"/>
+          </a:effectRef>
+          <a:fontRef idx="minor">
+            <a:schemeClr val="lt1"/>
+          </a:fontRef>
+        </p:style>
+        <p:txBody>
+          <a:bodyPr rtlCol="0" anchor="ctr"/>
+          <a:lstStyle/>
+          <a:p>
+            <a:pPr algn="ctr"/>
+            <a:endParaRPr lang="en-US"/>
+          </a:p>
+        </p:txBody>
+      </p:sp>
+      <p:sp>
+        <p:nvSpPr>
+          <p:cNvPr id="24" name="Rectangle 23">
+            <a:extLst>
+              <a:ext uri="{FF2B5EF4-FFF2-40B4-BE49-F238E27FC236}">
+                <a16:creationId xmlns:a16="http://schemas.microsoft.com/office/drawing/2014/main" id="{C007F3D3-099E-430E-8754-C084D0FA5FE3}"/>
+              </a:ext>
+              <a:ext uri="{C183D7F6-B498-43B3-948B-1728B52AA6E4}">
+                <adec:decorative xmlns:adec="http://schemas.microsoft.com/office/drawing/2017/decorative" val="1"/>
+              </a:ext>
+            </a:extLst>
+          </p:cNvPr>
+          <p:cNvSpPr>
+            <a:spLocks noGrp="1" noRot="1" noChangeAspect="1" noMove="1" noResize="1" noEditPoints="1" noAdjustHandles="1" noChangeArrowheads="1" noChangeShapeType="1" noTextEdit="1"/>
+          </p:cNvSpPr>
+          <p:nvPr>
+            <p:extLst>
+              <p:ext uri="{386F3935-93C4-4BCD-93E2-E3B085C9AB24}">
+                <p16:designElem xmlns:p16="http://schemas.microsoft.com/office/powerpoint/2015/main" val="1"/>
+              </p:ext>
+            </p:extLst>
+          </p:nvPr>
+        </p:nvSpPr>
+        <p:spPr>
+          <a:xfrm>
+            <a:off x="0" y="2019476"/>
+            <a:ext cx="12192000" cy="4105941"/>
+          </a:xfrm>
+          <a:prstGeom prst="rect">
+            <a:avLst/>
+          </a:prstGeom>
+          <a:gradFill flip="none" rotWithShape="1">
+            <a:gsLst>
+              <a:gs pos="0">
+                <a:schemeClr val="bg2">
+                  <a:alpha val="0"/>
+                </a:schemeClr>
+              </a:gs>
+              <a:gs pos="100000">
+                <a:schemeClr val="bg2"/>
+              </a:gs>
+            </a:gsLst>
+            <a:lin ang="5400000" scaled="0"/>
+            <a:tileRect/>
+          </a:gradFill>
+          <a:ln>
+            <a:noFill/>
+          </a:ln>
+        </p:spPr>
+        <p:style>
+          <a:lnRef idx="2">
+            <a:schemeClr val="accent1">
+              <a:shade val="50000"/>
+            </a:schemeClr>
+          </a:lnRef>
+          <a:fillRef idx="1">
+            <a:schemeClr val="accent1"/>
+          </a:fillRef>
+          <a:effectRef idx="0">
+            <a:schemeClr val="accent1"/>
+          </a:effectRef>
+          <a:fontRef idx="minor">
+            <a:schemeClr val="lt1"/>
+          </a:fontRef>
+        </p:style>
+        <p:txBody>
+          <a:bodyPr rtlCol="0" anchor="ctr"/>
+          <a:lstStyle/>
+          <a:p>
+            <a:pPr lvl="0" algn="ctr"/>
+            <a:endParaRPr lang="en-US"/>
+          </a:p>
+        </p:txBody>
+      </p:sp>
+      <p:sp>
+        <p:nvSpPr>
+          <p:cNvPr id="2" name="Title 1">
+            <a:extLst>
+              <a:ext uri="{FF2B5EF4-FFF2-40B4-BE49-F238E27FC236}">
+                <a16:creationId xmlns:a16="http://schemas.microsoft.com/office/drawing/2014/main" id="{13CFD6D8-D4CB-7D22-6034-0448D726F997}"/>
+              </a:ext>
+            </a:extLst>
+          </p:cNvPr>
+          <p:cNvSpPr>
+            <a:spLocks noGrp="1"/>
+          </p:cNvSpPr>
+          <p:nvPr>
+            <p:ph type="title"/>
+          </p:nvPr>
+        </p:nvSpPr>
+        <p:spPr>
+          <a:xfrm>
+            <a:off x="1776729" y="4459039"/>
+            <a:ext cx="8643011" cy="551528"/>
+          </a:xfrm>
+        </p:spPr>
+        <p:txBody>
+          <a:bodyPr vert="horz" lIns="91440" tIns="45720" rIns="91440" bIns="0" rtlCol="0" anchor="b">
+            <a:normAutofit/>
+          </a:bodyPr>
+          <a:lstStyle/>
+          <a:p>
+            <a:r>
+              <a:rPr lang="en-US" sz="3600"/>
+              <a:t>Vlajk Sándor - Fejlesztés</a:t>
+            </a:r>
+          </a:p>
+        </p:txBody>
+      </p:sp>
+      <p:pic>
+        <p:nvPicPr>
+          <p:cNvPr id="5" name="Content Placeholder 4">
+            <a:extLst>
+              <a:ext uri="{FF2B5EF4-FFF2-40B4-BE49-F238E27FC236}">
+                <a16:creationId xmlns:a16="http://schemas.microsoft.com/office/drawing/2014/main" id="{D328A2F4-206A-9FAD-C168-CDB9610FB783}"/>
+              </a:ext>
+            </a:extLst>
+          </p:cNvPr>
+          <p:cNvPicPr>
+            <a:picLocks noGrp="1" noChangeAspect="1"/>
+          </p:cNvPicPr>
+          <p:nvPr>
+            <p:ph idx="1"/>
+          </p:nvPr>
+        </p:nvPicPr>
+        <p:blipFill>
+          <a:blip r:embed="rId3"/>
+          <a:stretch>
+            <a:fillRect/>
+          </a:stretch>
+        </p:blipFill>
+        <p:spPr>
+          <a:xfrm>
+            <a:off x="984120" y="198045"/>
+            <a:ext cx="4106012" cy="3007654"/>
+          </a:xfrm>
+          <a:prstGeom prst="rect">
+            <a:avLst/>
+          </a:prstGeom>
+        </p:spPr>
+      </p:pic>
+      <p:pic>
+        <p:nvPicPr>
+          <p:cNvPr id="7" name="Picture 6">
+            <a:extLst>
+              <a:ext uri="{FF2B5EF4-FFF2-40B4-BE49-F238E27FC236}">
+                <a16:creationId xmlns:a16="http://schemas.microsoft.com/office/drawing/2014/main" id="{AA8CF25F-105A-EA84-AB38-9B2CDC7B3277}"/>
+              </a:ext>
+            </a:extLst>
+          </p:cNvPr>
+          <p:cNvPicPr>
+            <a:picLocks noChangeAspect="1"/>
+          </p:cNvPicPr>
+          <p:nvPr/>
+        </p:nvPicPr>
+        <p:blipFill>
+          <a:blip r:embed="rId4"/>
+          <a:stretch>
+            <a:fillRect/>
+          </a:stretch>
+        </p:blipFill>
+        <p:spPr>
+          <a:xfrm>
+            <a:off x="6074249" y="638316"/>
+            <a:ext cx="5549025" cy="3079707"/>
+          </a:xfrm>
+          <a:prstGeom prst="rect">
+            <a:avLst/>
+          </a:prstGeom>
+        </p:spPr>
+      </p:pic>
+      <p:pic>
+        <p:nvPicPr>
+          <p:cNvPr id="9" name="Picture 8">
+            <a:extLst>
+              <a:ext uri="{FF2B5EF4-FFF2-40B4-BE49-F238E27FC236}">
+                <a16:creationId xmlns:a16="http://schemas.microsoft.com/office/drawing/2014/main" id="{07C5DCCD-B4B3-22CE-2C2A-CC1050E657B0}"/>
+              </a:ext>
+            </a:extLst>
+          </p:cNvPr>
+          <p:cNvPicPr>
+            <a:picLocks noChangeAspect="1"/>
+          </p:cNvPicPr>
+          <p:nvPr/>
+        </p:nvPicPr>
+        <p:blipFill>
+          <a:blip r:embed="rId5"/>
+          <a:stretch>
+            <a:fillRect/>
+          </a:stretch>
+        </p:blipFill>
+        <p:spPr>
+          <a:xfrm>
+            <a:off x="1343846" y="3271561"/>
+            <a:ext cx="3386560" cy="1121616"/>
+          </a:xfrm>
+          <a:prstGeom prst="rect">
+            <a:avLst/>
+          </a:prstGeom>
+        </p:spPr>
+      </p:pic>
+      <p:cxnSp>
+        <p:nvCxnSpPr>
+          <p:cNvPr id="26" name="Straight Connector 25">
+            <a:extLst>
+              <a:ext uri="{FF2B5EF4-FFF2-40B4-BE49-F238E27FC236}">
+                <a16:creationId xmlns:a16="http://schemas.microsoft.com/office/drawing/2014/main" id="{6B9EA5DA-6DFD-447D-B8F9-CB95CA114076}"/>
+              </a:ext>
+              <a:ext uri="{C183D7F6-B498-43B3-948B-1728B52AA6E4}">
+                <adec:decorative xmlns:adec="http://schemas.microsoft.com/office/drawing/2017/decorative" val="1"/>
+              </a:ext>
+            </a:extLst>
+          </p:cNvPr>
+          <p:cNvCxnSpPr>
+            <a:cxnSpLocks noGrp="1" noRot="1" noChangeAspect="1" noMove="1" noResize="1" noEditPoints="1" noAdjustHandles="1" noChangeArrowheads="1" noChangeShapeType="1"/>
+          </p:cNvCxnSpPr>
+          <p:nvPr>
+            <p:extLst>
+              <p:ext uri="{386F3935-93C4-4BCD-93E2-E3B085C9AB24}">
+                <p16:designElem xmlns:p16="http://schemas.microsoft.com/office/powerpoint/2015/main" val="1"/>
+              </p:ext>
+            </p:extLst>
+          </p:nvPr>
+        </p:nvCxnSpPr>
+        <p:spPr>
+          <a:xfrm>
+            <a:off x="1776728" y="5027185"/>
+            <a:ext cx="8643011" cy="0"/>
+          </a:xfrm>
+          <a:prstGeom prst="line">
+            <a:avLst/>
+          </a:prstGeom>
+          <a:ln w="31750"/>
+        </p:spPr>
+        <p:style>
+          <a:lnRef idx="3">
+            <a:schemeClr val="accent1"/>
+          </a:lnRef>
+          <a:fillRef idx="0">
+            <a:schemeClr val="accent1"/>
+          </a:fillRef>
+          <a:effectRef idx="2">
+            <a:schemeClr val="accent1"/>
+          </a:effectRef>
+          <a:fontRef idx="minor">
+            <a:schemeClr val="tx1"/>
+          </a:fontRef>
+        </p:style>
+      </p:cxnSp>
+      <p:pic>
+        <p:nvPicPr>
+          <p:cNvPr id="28" name="Picture 27">
+            <a:extLst>
+              <a:ext uri="{FF2B5EF4-FFF2-40B4-BE49-F238E27FC236}">
+                <a16:creationId xmlns:a16="http://schemas.microsoft.com/office/drawing/2014/main" id="{87612EF9-94E7-42BA-B4A9-4B38643FBAF7}"/>
+              </a:ext>
+              <a:ext uri="{C183D7F6-B498-43B3-948B-1728B52AA6E4}">
+                <adec:decorative xmlns:adec="http://schemas.microsoft.com/office/drawing/2017/decorative" val="1"/>
+              </a:ext>
+            </a:extLst>
+          </p:cNvPr>
+          <p:cNvPicPr>
+            <a:picLocks noGrp="1" noRot="1" noChangeAspect="1" noMove="1" noResize="1" noEditPoints="1" noAdjustHandles="1" noChangeArrowheads="1" noChangeShapeType="1" noCrop="1"/>
+          </p:cNvPicPr>
+          <p:nvPr>
+            <p:extLst>
+              <p:ext uri="{386F3935-93C4-4BCD-93E2-E3B085C9AB24}">
+                <p16:designElem xmlns:p16="http://schemas.microsoft.com/office/powerpoint/2015/main" val="1"/>
+              </p:ext>
+            </p:extLst>
+          </p:nvPr>
+        </p:nvPicPr>
+        <p:blipFill rotWithShape="1">
+          <a:blip r:embed="rId2">
+            <a:extLst>
+              <a:ext uri="{28A0092B-C50C-407E-A947-70E740481C1C}">
+                <a14:useLocalDpi xmlns:a14="http://schemas.microsoft.com/office/drawing/2010/main" val="0"/>
+              </a:ext>
+            </a:extLst>
+          </a:blip>
+          <a:srcRect t="1538" b="-1538"/>
+          <a:stretch/>
+        </p:blipFill>
+        <p:spPr bwMode="black">
+          <a:xfrm>
+            <a:off x="0" y="6126480"/>
+            <a:ext cx="12192000" cy="742950"/>
+          </a:xfrm>
+          <a:prstGeom prst="rect">
+            <a:avLst/>
+          </a:prstGeom>
+        </p:spPr>
+      </p:pic>
+      <p:cxnSp>
+        <p:nvCxnSpPr>
+          <p:cNvPr id="30" name="Straight Connector 29">
+            <a:extLst>
+              <a:ext uri="{FF2B5EF4-FFF2-40B4-BE49-F238E27FC236}">
+                <a16:creationId xmlns:a16="http://schemas.microsoft.com/office/drawing/2014/main" id="{9E597F0B-0A17-4BF2-A904-9D99811F3E2E}"/>
+              </a:ext>
+              <a:ext uri="{C183D7F6-B498-43B3-948B-1728B52AA6E4}">
+                <adec:decorative xmlns:adec="http://schemas.microsoft.com/office/drawing/2017/decorative" val="1"/>
+              </a:ext>
+            </a:extLst>
+          </p:cNvPr>
+          <p:cNvCxnSpPr>
+            <a:cxnSpLocks noGrp="1" noRot="1" noChangeAspect="1" noMove="1" noResize="1" noEditPoints="1" noAdjustHandles="1" noChangeArrowheads="1" noChangeShapeType="1"/>
+          </p:cNvCxnSpPr>
+          <p:nvPr>
+            <p:extLst>
+              <p:ext uri="{386F3935-93C4-4BCD-93E2-E3B085C9AB24}">
+                <p16:designElem xmlns:p16="http://schemas.microsoft.com/office/powerpoint/2015/main" val="1"/>
+              </p:ext>
+            </p:extLst>
+          </p:nvPr>
+        </p:nvCxnSpPr>
+        <p:spPr>
+          <a:xfrm>
+            <a:off x="0" y="6128413"/>
+            <a:ext cx="12192000" cy="0"/>
+          </a:xfrm>
+          <a:prstGeom prst="line">
+            <a:avLst/>
+          </a:prstGeom>
+          <a:ln w="12700">
+            <a:solidFill>
+              <a:srgbClr val="000001">
+                <a:alpha val="20000"/>
+              </a:srgbClr>
+            </a:solidFill>
+          </a:ln>
+        </p:spPr>
+        <p:style>
+          <a:lnRef idx="1">
+            <a:schemeClr val="accent1"/>
+          </a:lnRef>
+          <a:fillRef idx="0">
+            <a:schemeClr val="accent1"/>
+          </a:fillRef>
+          <a:effectRef idx="0">
+            <a:schemeClr val="accent1"/>
+          </a:effectRef>
+          <a:fontRef idx="minor">
+            <a:schemeClr val="tx1"/>
+          </a:fontRef>
+        </p:style>
+      </p:cxnSp>
+    </p:spTree>
+    <p:extLst>
+      <p:ext uri="{BB962C8B-B14F-4D97-AF65-F5344CB8AC3E}">
+        <p14:creationId xmlns:p14="http://schemas.microsoft.com/office/powerpoint/2010/main" val="3079083219"/>
+      </p:ext>
+    </p:extLst>
+  </p:cSld>
+  <p:clrMapOvr>
+    <a:masterClrMapping/>
+  </p:clrMapOvr>
+</p:sld>
+</file>
+
+<file path=ppt/slides/slide16.xml><?xml version="1.0" encoding="utf-8"?>
+<p:sld xmlns:a="http://schemas.openxmlformats.org/drawingml/2006/main" xmlns:r="http://schemas.openxmlformats.org/officeDocument/2006/relationships" xmlns:p="http://schemas.openxmlformats.org/presentationml/2006/main">
+  <p:cSld>
+    <p:bg>
+      <p:bgPr>
+        <a:gradFill rotWithShape="1">
+          <a:gsLst>
+            <a:gs pos="0">
+              <a:schemeClr val="bg2">
+                <a:tint val="94000"/>
+                <a:satMod val="80000"/>
+                <a:lumMod val="106000"/>
+              </a:schemeClr>
+            </a:gs>
+            <a:gs pos="100000">
+              <a:schemeClr val="bg2">
+                <a:shade val="80000"/>
+              </a:schemeClr>
+            </a:gs>
+          </a:gsLst>
+          <a:path path="circle">
+            <a:fillToRect l="43000" r="43000" b="100000"/>
+          </a:path>
+        </a:gradFill>
+        <a:effectLst/>
+      </p:bgPr>
+    </p:bg>
+    <p:spTree>
+      <p:nvGrpSpPr>
+        <p:cNvPr id="1" name=""/>
+        <p:cNvGrpSpPr/>
+        <p:nvPr/>
+      </p:nvGrpSpPr>
+      <p:grpSpPr>
+        <a:xfrm>
+          <a:off x="0" y="0"/>
+          <a:ext cx="0" cy="0"/>
+          <a:chOff x="0" y="0"/>
+          <a:chExt cx="0" cy="0"/>
+        </a:xfrm>
+      </p:grpSpPr>
+      <p:sp>
+        <p:nvSpPr>
+          <p:cNvPr id="17" name="Rectangle 16">
+            <a:extLst>
+              <a:ext uri="{FF2B5EF4-FFF2-40B4-BE49-F238E27FC236}">
+                <a16:creationId xmlns:a16="http://schemas.microsoft.com/office/drawing/2014/main" id="{E724B9E8-02C8-4B2E-8770-A00A67760DF0}"/>
+              </a:ext>
+              <a:ext uri="{C183D7F6-B498-43B3-948B-1728B52AA6E4}">
+                <adec:decorative xmlns:adec="http://schemas.microsoft.com/office/drawing/2017/decorative" val="1"/>
+              </a:ext>
+            </a:extLst>
+          </p:cNvPr>
+          <p:cNvSpPr>
+            <a:spLocks noGrp="1" noRot="1" noChangeAspect="1" noMove="1" noResize="1" noEditPoints="1" noAdjustHandles="1" noChangeArrowheads="1" noChangeShapeType="1" noTextEdit="1"/>
+          </p:cNvSpPr>
+          <p:nvPr>
+            <p:extLst>
+              <p:ext uri="{386F3935-93C4-4BCD-93E2-E3B085C9AB24}">
+                <p16:designElem xmlns:p16="http://schemas.microsoft.com/office/powerpoint/2015/main" val="1"/>
+              </p:ext>
+            </p:extLst>
+          </p:nvPr>
+        </p:nvSpPr>
+        <p:spPr>
+          <a:xfrm>
+            <a:off x="0" y="2019476"/>
+            <a:ext cx="12192000" cy="4105941"/>
+          </a:xfrm>
+          <a:prstGeom prst="rect">
+            <a:avLst/>
+          </a:prstGeom>
+          <a:gradFill flip="none" rotWithShape="1">
+            <a:gsLst>
+              <a:gs pos="0">
+                <a:schemeClr val="bg2">
+                  <a:alpha val="0"/>
+                </a:schemeClr>
+              </a:gs>
+              <a:gs pos="100000">
+                <a:schemeClr val="bg2"/>
+              </a:gs>
+            </a:gsLst>
+            <a:lin ang="5400000" scaled="0"/>
+            <a:tileRect/>
+          </a:gradFill>
+          <a:ln>
+            <a:noFill/>
+          </a:ln>
+        </p:spPr>
+        <p:style>
+          <a:lnRef idx="2">
+            <a:schemeClr val="accent1">
+              <a:shade val="50000"/>
+            </a:schemeClr>
+          </a:lnRef>
+          <a:fillRef idx="1">
+            <a:schemeClr val="accent1"/>
+          </a:fillRef>
+          <a:effectRef idx="0">
+            <a:schemeClr val="accent1"/>
+          </a:effectRef>
+          <a:fontRef idx="minor">
+            <a:schemeClr val="lt1"/>
+          </a:fontRef>
+        </p:style>
+        <p:txBody>
+          <a:bodyPr/>
+          <a:lstStyle/>
+          <a:p>
+            <a:endParaRPr lang="en-US"/>
+          </a:p>
+        </p:txBody>
+      </p:sp>
+      <p:pic>
+        <p:nvPicPr>
+          <p:cNvPr id="19" name="Picture 18">
+            <a:extLst>
+              <a:ext uri="{FF2B5EF4-FFF2-40B4-BE49-F238E27FC236}">
+                <a16:creationId xmlns:a16="http://schemas.microsoft.com/office/drawing/2014/main" id="{7B8AE548-0BFA-4792-9962-3375923C7635}"/>
+              </a:ext>
+              <a:ext uri="{C183D7F6-B498-43B3-948B-1728B52AA6E4}">
+                <adec:decorative xmlns:adec="http://schemas.microsoft.com/office/drawing/2017/decorative" val="1"/>
+              </a:ext>
+            </a:extLst>
+          </p:cNvPr>
+          <p:cNvPicPr>
+            <a:picLocks noGrp="1" noRot="1" noChangeAspect="1" noMove="1" noResize="1" noEditPoints="1" noAdjustHandles="1" noChangeArrowheads="1" noChangeShapeType="1" noCrop="1"/>
+          </p:cNvPicPr>
+          <p:nvPr>
+            <p:extLst>
+              <p:ext uri="{386F3935-93C4-4BCD-93E2-E3B085C9AB24}">
+                <p16:designElem xmlns:p16="http://schemas.microsoft.com/office/powerpoint/2015/main" val="1"/>
+              </p:ext>
+            </p:extLst>
+          </p:nvPr>
+        </p:nvPicPr>
+        <p:blipFill rotWithShape="1">
+          <a:blip r:embed="rId2">
+            <a:extLst>
+              <a:ext uri="{28A0092B-C50C-407E-A947-70E740481C1C}">
+                <a14:useLocalDpi xmlns:a14="http://schemas.microsoft.com/office/drawing/2010/main" val="0"/>
+              </a:ext>
+            </a:extLst>
+          </a:blip>
+          <a:srcRect t="1538" b="-1538"/>
+          <a:stretch/>
+        </p:blipFill>
+        <p:spPr bwMode="black">
+          <a:xfrm>
+            <a:off x="0" y="6126480"/>
+            <a:ext cx="12192000" cy="742950"/>
+          </a:xfrm>
+          <a:prstGeom prst="rect">
+            <a:avLst/>
+          </a:prstGeom>
+        </p:spPr>
+      </p:pic>
+      <p:cxnSp>
+        <p:nvCxnSpPr>
+          <p:cNvPr id="21" name="Straight Connector 20">
+            <a:extLst>
+              <a:ext uri="{FF2B5EF4-FFF2-40B4-BE49-F238E27FC236}">
+                <a16:creationId xmlns:a16="http://schemas.microsoft.com/office/drawing/2014/main" id="{67639EF4-FA83-4D85-90FE-B831AF283896}"/>
+              </a:ext>
+              <a:ext uri="{C183D7F6-B498-43B3-948B-1728B52AA6E4}">
+                <adec:decorative xmlns:adec="http://schemas.microsoft.com/office/drawing/2017/decorative" val="1"/>
+              </a:ext>
+            </a:extLst>
+          </p:cNvPr>
+          <p:cNvCxnSpPr>
+            <a:cxnSpLocks noGrp="1" noRot="1" noChangeAspect="1" noMove="1" noResize="1" noEditPoints="1" noAdjustHandles="1" noChangeArrowheads="1" noChangeShapeType="1"/>
+          </p:cNvCxnSpPr>
+          <p:nvPr>
+            <p:extLst>
+              <p:ext uri="{386F3935-93C4-4BCD-93E2-E3B085C9AB24}">
+                <p16:designElem xmlns:p16="http://schemas.microsoft.com/office/powerpoint/2015/main" val="1"/>
+              </p:ext>
+            </p:extLst>
+          </p:nvPr>
+        </p:nvCxnSpPr>
+        <p:spPr>
+          <a:xfrm>
+            <a:off x="0" y="6128413"/>
+            <a:ext cx="12192000" cy="0"/>
+          </a:xfrm>
+          <a:prstGeom prst="line">
+            <a:avLst/>
+          </a:prstGeom>
+          <a:ln w="12700">
+            <a:solidFill>
+              <a:srgbClr val="000001">
+                <a:alpha val="20000"/>
+              </a:srgbClr>
+            </a:solidFill>
+          </a:ln>
+        </p:spPr>
+        <p:style>
+          <a:lnRef idx="1">
+            <a:schemeClr val="accent1"/>
+          </a:lnRef>
+          <a:fillRef idx="0">
+            <a:schemeClr val="accent1"/>
+          </a:fillRef>
+          <a:effectRef idx="0">
+            <a:schemeClr val="accent1"/>
+          </a:effectRef>
+          <a:fontRef idx="minor">
+            <a:schemeClr val="tx1"/>
+          </a:fontRef>
+        </p:style>
+      </p:cxnSp>
+      <p:cxnSp>
+        <p:nvCxnSpPr>
+          <p:cNvPr id="23" name="Straight Connector 22">
+            <a:extLst>
+              <a:ext uri="{FF2B5EF4-FFF2-40B4-BE49-F238E27FC236}">
+                <a16:creationId xmlns:a16="http://schemas.microsoft.com/office/drawing/2014/main" id="{CC87E76A-8F50-413D-9BFC-C5A1525BD9BC}"/>
+              </a:ext>
+              <a:ext uri="{C183D7F6-B498-43B3-948B-1728B52AA6E4}">
+                <adec:decorative xmlns:adec="http://schemas.microsoft.com/office/drawing/2017/decorative" val="1"/>
+              </a:ext>
+            </a:extLst>
+          </p:cNvPr>
+          <p:cNvCxnSpPr>
+            <a:cxnSpLocks noGrp="1" noRot="1" noChangeAspect="1" noMove="1" noResize="1" noEditPoints="1" noAdjustHandles="1" noChangeArrowheads="1" noChangeShapeType="1"/>
+          </p:cNvCxnSpPr>
+          <p:nvPr>
+            <p:extLst>
+              <p:ext uri="{386F3935-93C4-4BCD-93E2-E3B085C9AB24}">
+                <p16:designElem xmlns:p16="http://schemas.microsoft.com/office/powerpoint/2015/main" val="1"/>
+              </p:ext>
+            </p:extLst>
+          </p:nvPr>
+        </p:nvCxnSpPr>
+        <p:spPr>
+          <a:xfrm>
+            <a:off x="2417780" y="3528542"/>
+            <a:ext cx="8637072" cy="0"/>
+          </a:xfrm>
+          <a:prstGeom prst="line">
+            <a:avLst/>
+          </a:prstGeom>
+          <a:ln w="31750"/>
+        </p:spPr>
+        <p:style>
+          <a:lnRef idx="3">
+            <a:schemeClr val="accent1"/>
+          </a:lnRef>
+          <a:fillRef idx="0">
+            <a:schemeClr val="accent1"/>
+          </a:fillRef>
+          <a:effectRef idx="2">
+            <a:schemeClr val="accent1"/>
+          </a:effectRef>
+          <a:fontRef idx="minor">
+            <a:schemeClr val="tx1"/>
+          </a:fontRef>
+        </p:style>
+      </p:cxnSp>
+      <p:sp useBgFill="1">
+        <p:nvSpPr>
+          <p:cNvPr id="25" name="Rectangle 24">
+            <a:extLst>
+              <a:ext uri="{FF2B5EF4-FFF2-40B4-BE49-F238E27FC236}">
+                <a16:creationId xmlns:a16="http://schemas.microsoft.com/office/drawing/2014/main" id="{9A1C6278-B7D5-4E8E-B4DC-834832980565}"/>
+              </a:ext>
+              <a:ext uri="{C183D7F6-B498-43B3-948B-1728B52AA6E4}">
+                <adec:decorative xmlns:adec="http://schemas.microsoft.com/office/drawing/2017/decorative" val="1"/>
+              </a:ext>
+            </a:extLst>
+          </p:cNvPr>
+          <p:cNvSpPr>
+            <a:spLocks noGrp="1" noRot="1" noChangeAspect="1" noMove="1" noResize="1" noEditPoints="1" noAdjustHandles="1" noChangeArrowheads="1" noChangeShapeType="1" noTextEdit="1"/>
+          </p:cNvSpPr>
+          <p:nvPr>
+            <p:extLst>
+              <p:ext uri="{386F3935-93C4-4BCD-93E2-E3B085C9AB24}">
+                <p16:designElem xmlns:p16="http://schemas.microsoft.com/office/powerpoint/2015/main" val="1"/>
+              </p:ext>
+            </p:extLst>
+          </p:nvPr>
+        </p:nvSpPr>
+        <p:spPr>
+          <a:xfrm>
+            <a:off x="2" y="0"/>
+            <a:ext cx="12191695" cy="6858000"/>
+          </a:xfrm>
+          <a:prstGeom prst="rect">
+            <a:avLst/>
+          </a:prstGeom>
+          <a:ln>
+            <a:noFill/>
+          </a:ln>
+        </p:spPr>
+        <p:style>
+          <a:lnRef idx="2">
+            <a:schemeClr val="accent1">
+              <a:shade val="50000"/>
+            </a:schemeClr>
+          </a:lnRef>
+          <a:fillRef idx="1">
+            <a:schemeClr val="accent1"/>
+          </a:fillRef>
+          <a:effectRef idx="0">
+            <a:schemeClr val="accent1"/>
+          </a:effectRef>
+          <a:fontRef idx="minor">
+            <a:schemeClr val="lt1"/>
+          </a:fontRef>
+        </p:style>
+        <p:txBody>
+          <a:bodyPr rtlCol="0" anchor="ctr"/>
+          <a:lstStyle/>
+          <a:p>
+            <a:pPr algn="ctr"/>
+            <a:endParaRPr lang="en-US"/>
+          </a:p>
+        </p:txBody>
+      </p:sp>
+      <p:sp>
+        <p:nvSpPr>
+          <p:cNvPr id="27" name="Rectangle 26">
+            <a:extLst>
+              <a:ext uri="{FF2B5EF4-FFF2-40B4-BE49-F238E27FC236}">
+                <a16:creationId xmlns:a16="http://schemas.microsoft.com/office/drawing/2014/main" id="{C007F3D3-099E-430E-8754-C084D0FA5FE3}"/>
+              </a:ext>
+              <a:ext uri="{C183D7F6-B498-43B3-948B-1728B52AA6E4}">
+                <adec:decorative xmlns:adec="http://schemas.microsoft.com/office/drawing/2017/decorative" val="1"/>
+              </a:ext>
+            </a:extLst>
+          </p:cNvPr>
+          <p:cNvSpPr>
+            <a:spLocks noGrp="1" noRot="1" noChangeAspect="1" noMove="1" noResize="1" noEditPoints="1" noAdjustHandles="1" noChangeArrowheads="1" noChangeShapeType="1" noTextEdit="1"/>
+          </p:cNvSpPr>
+          <p:nvPr>
+            <p:extLst>
+              <p:ext uri="{386F3935-93C4-4BCD-93E2-E3B085C9AB24}">
+                <p16:designElem xmlns:p16="http://schemas.microsoft.com/office/powerpoint/2015/main" val="1"/>
+              </p:ext>
+            </p:extLst>
+          </p:nvPr>
+        </p:nvSpPr>
+        <p:spPr>
+          <a:xfrm>
+            <a:off x="0" y="2019476"/>
+            <a:ext cx="12192000" cy="4105941"/>
+          </a:xfrm>
+          <a:prstGeom prst="rect">
+            <a:avLst/>
+          </a:prstGeom>
+          <a:gradFill flip="none" rotWithShape="1">
+            <a:gsLst>
+              <a:gs pos="0">
+                <a:schemeClr val="bg2">
+                  <a:alpha val="0"/>
+                </a:schemeClr>
+              </a:gs>
+              <a:gs pos="100000">
+                <a:schemeClr val="bg2"/>
+              </a:gs>
+            </a:gsLst>
+            <a:lin ang="5400000" scaled="0"/>
+            <a:tileRect/>
+          </a:gradFill>
+          <a:ln>
+            <a:noFill/>
+          </a:ln>
+        </p:spPr>
+        <p:style>
+          <a:lnRef idx="2">
+            <a:schemeClr val="accent1">
+              <a:shade val="50000"/>
+            </a:schemeClr>
+          </a:lnRef>
+          <a:fillRef idx="1">
+            <a:schemeClr val="accent1"/>
+          </a:fillRef>
+          <a:effectRef idx="0">
+            <a:schemeClr val="accent1"/>
+          </a:effectRef>
+          <a:fontRef idx="minor">
+            <a:schemeClr val="lt1"/>
+          </a:fontRef>
+        </p:style>
+        <p:txBody>
+          <a:bodyPr rtlCol="0" anchor="ctr"/>
+          <a:lstStyle/>
+          <a:p>
+            <a:pPr lvl="0" algn="ctr"/>
+            <a:endParaRPr lang="en-US"/>
+          </a:p>
+        </p:txBody>
+      </p:sp>
+      <p:sp>
+        <p:nvSpPr>
+          <p:cNvPr id="2" name="Title 1">
+            <a:extLst>
+              <a:ext uri="{FF2B5EF4-FFF2-40B4-BE49-F238E27FC236}">
+                <a16:creationId xmlns:a16="http://schemas.microsoft.com/office/drawing/2014/main" id="{0C05D6E9-FB34-5D4E-D478-F5A8B0E7C25A}"/>
+              </a:ext>
+            </a:extLst>
+          </p:cNvPr>
+          <p:cNvSpPr>
+            <a:spLocks noGrp="1"/>
+          </p:cNvSpPr>
+          <p:nvPr>
+            <p:ph type="title"/>
+          </p:nvPr>
+        </p:nvSpPr>
+        <p:spPr>
+          <a:xfrm>
+            <a:off x="1776729" y="4459039"/>
+            <a:ext cx="8643011" cy="551528"/>
+          </a:xfrm>
+        </p:spPr>
+        <p:txBody>
+          <a:bodyPr vert="horz" lIns="91440" tIns="45720" rIns="91440" bIns="0" rtlCol="0" anchor="b">
+            <a:normAutofit/>
+          </a:bodyPr>
+          <a:lstStyle/>
+          <a:p>
+            <a:r>
+              <a:rPr lang="en-US" sz="3600"/>
+              <a:t>Vlajk Sándor - Fejlesztés</a:t>
+            </a:r>
+          </a:p>
+        </p:txBody>
+      </p:sp>
+      <p:pic>
+        <p:nvPicPr>
+          <p:cNvPr id="7" name="Content Placeholder 6">
+            <a:extLst>
+              <a:ext uri="{FF2B5EF4-FFF2-40B4-BE49-F238E27FC236}">
+                <a16:creationId xmlns:a16="http://schemas.microsoft.com/office/drawing/2014/main" id="{5CAD100C-B467-C9FA-742C-83A81B896BF9}"/>
+              </a:ext>
+            </a:extLst>
+          </p:cNvPr>
+          <p:cNvPicPr>
+            <a:picLocks noGrp="1" noChangeAspect="1"/>
+          </p:cNvPicPr>
+          <p:nvPr>
+            <p:ph idx="1"/>
+          </p:nvPr>
+        </p:nvPicPr>
+        <p:blipFill>
+          <a:blip r:embed="rId3"/>
+          <a:stretch>
+            <a:fillRect/>
+          </a:stretch>
+        </p:blipFill>
+        <p:spPr>
+          <a:xfrm>
+            <a:off x="813173" y="457201"/>
+            <a:ext cx="4934512" cy="2689308"/>
+          </a:xfrm>
+          <a:prstGeom prst="rect">
+            <a:avLst/>
+          </a:prstGeom>
+        </p:spPr>
+      </p:pic>
+      <p:pic>
+        <p:nvPicPr>
+          <p:cNvPr id="12" name="Picture 11">
+            <a:extLst>
+              <a:ext uri="{FF2B5EF4-FFF2-40B4-BE49-F238E27FC236}">
+                <a16:creationId xmlns:a16="http://schemas.microsoft.com/office/drawing/2014/main" id="{31D188B4-F8EB-7281-F69A-9DE7E48DAAA3}"/>
+              </a:ext>
+            </a:extLst>
+          </p:cNvPr>
+          <p:cNvPicPr>
+            <a:picLocks noChangeAspect="1"/>
+          </p:cNvPicPr>
+          <p:nvPr/>
+        </p:nvPicPr>
+        <p:blipFill>
+          <a:blip r:embed="rId4"/>
+          <a:stretch>
+            <a:fillRect/>
+          </a:stretch>
+        </p:blipFill>
+        <p:spPr>
+          <a:xfrm>
+            <a:off x="6025216" y="1062951"/>
+            <a:ext cx="5517445" cy="2979420"/>
+          </a:xfrm>
+          <a:prstGeom prst="rect">
+            <a:avLst/>
+          </a:prstGeom>
+        </p:spPr>
+      </p:pic>
+      <p:pic>
+        <p:nvPicPr>
+          <p:cNvPr id="9" name="Picture 8">
+            <a:extLst>
+              <a:ext uri="{FF2B5EF4-FFF2-40B4-BE49-F238E27FC236}">
+                <a16:creationId xmlns:a16="http://schemas.microsoft.com/office/drawing/2014/main" id="{D59158A9-81B7-7204-17BE-FD603E88906B}"/>
+              </a:ext>
+            </a:extLst>
+          </p:cNvPr>
+          <p:cNvPicPr>
+            <a:picLocks noChangeAspect="1"/>
+          </p:cNvPicPr>
+          <p:nvPr/>
+        </p:nvPicPr>
+        <p:blipFill>
+          <a:blip r:embed="rId5"/>
+          <a:stretch>
+            <a:fillRect/>
+          </a:stretch>
+        </p:blipFill>
+        <p:spPr>
+          <a:xfrm>
+            <a:off x="1566686" y="3252392"/>
+            <a:ext cx="3429598" cy="1251340"/>
+          </a:xfrm>
+          <a:prstGeom prst="rect">
+            <a:avLst/>
+          </a:prstGeom>
+        </p:spPr>
+      </p:pic>
+      <p:cxnSp>
+        <p:nvCxnSpPr>
+          <p:cNvPr id="29" name="Straight Connector 28">
+            <a:extLst>
+              <a:ext uri="{FF2B5EF4-FFF2-40B4-BE49-F238E27FC236}">
+                <a16:creationId xmlns:a16="http://schemas.microsoft.com/office/drawing/2014/main" id="{6B9EA5DA-6DFD-447D-B8F9-CB95CA114076}"/>
+              </a:ext>
+              <a:ext uri="{C183D7F6-B498-43B3-948B-1728B52AA6E4}">
+                <adec:decorative xmlns:adec="http://schemas.microsoft.com/office/drawing/2017/decorative" val="1"/>
+              </a:ext>
+            </a:extLst>
+          </p:cNvPr>
+          <p:cNvCxnSpPr>
+            <a:cxnSpLocks noGrp="1" noRot="1" noChangeAspect="1" noMove="1" noResize="1" noEditPoints="1" noAdjustHandles="1" noChangeArrowheads="1" noChangeShapeType="1"/>
+          </p:cNvCxnSpPr>
+          <p:nvPr>
+            <p:extLst>
+              <p:ext uri="{386F3935-93C4-4BCD-93E2-E3B085C9AB24}">
+                <p16:designElem xmlns:p16="http://schemas.microsoft.com/office/powerpoint/2015/main" val="1"/>
+              </p:ext>
+            </p:extLst>
+          </p:nvPr>
+        </p:nvCxnSpPr>
+        <p:spPr>
+          <a:xfrm>
+            <a:off x="1776728" y="5027185"/>
+            <a:ext cx="8643011" cy="0"/>
+          </a:xfrm>
+          <a:prstGeom prst="line">
+            <a:avLst/>
+          </a:prstGeom>
+          <a:ln w="31750"/>
+        </p:spPr>
+        <p:style>
+          <a:lnRef idx="3">
+            <a:schemeClr val="accent1"/>
+          </a:lnRef>
+          <a:fillRef idx="0">
+            <a:schemeClr val="accent1"/>
+          </a:fillRef>
+          <a:effectRef idx="2">
+            <a:schemeClr val="accent1"/>
+          </a:effectRef>
+          <a:fontRef idx="minor">
+            <a:schemeClr val="tx1"/>
+          </a:fontRef>
+        </p:style>
+      </p:cxnSp>
+      <p:pic>
+        <p:nvPicPr>
+          <p:cNvPr id="31" name="Picture 30">
+            <a:extLst>
+              <a:ext uri="{FF2B5EF4-FFF2-40B4-BE49-F238E27FC236}">
+                <a16:creationId xmlns:a16="http://schemas.microsoft.com/office/drawing/2014/main" id="{87612EF9-94E7-42BA-B4A9-4B38643FBAF7}"/>
+              </a:ext>
+              <a:ext uri="{C183D7F6-B498-43B3-948B-1728B52AA6E4}">
+                <adec:decorative xmlns:adec="http://schemas.microsoft.com/office/drawing/2017/decorative" val="1"/>
+              </a:ext>
+            </a:extLst>
+          </p:cNvPr>
+          <p:cNvPicPr>
+            <a:picLocks noGrp="1" noRot="1" noChangeAspect="1" noMove="1" noResize="1" noEditPoints="1" noAdjustHandles="1" noChangeArrowheads="1" noChangeShapeType="1" noCrop="1"/>
+          </p:cNvPicPr>
+          <p:nvPr>
+            <p:extLst>
+              <p:ext uri="{386F3935-93C4-4BCD-93E2-E3B085C9AB24}">
+                <p16:designElem xmlns:p16="http://schemas.microsoft.com/office/powerpoint/2015/main" val="1"/>
+              </p:ext>
+            </p:extLst>
+          </p:nvPr>
+        </p:nvPicPr>
+        <p:blipFill rotWithShape="1">
+          <a:blip r:embed="rId2">
+            <a:extLst>
+              <a:ext uri="{28A0092B-C50C-407E-A947-70E740481C1C}">
+                <a14:useLocalDpi xmlns:a14="http://schemas.microsoft.com/office/drawing/2010/main" val="0"/>
+              </a:ext>
+            </a:extLst>
+          </a:blip>
+          <a:srcRect t="1538" b="-1538"/>
+          <a:stretch/>
+        </p:blipFill>
+        <p:spPr bwMode="black">
+          <a:xfrm>
+            <a:off x="0" y="6126480"/>
+            <a:ext cx="12192000" cy="742950"/>
+          </a:xfrm>
+          <a:prstGeom prst="rect">
+            <a:avLst/>
+          </a:prstGeom>
+        </p:spPr>
+      </p:pic>
+      <p:cxnSp>
+        <p:nvCxnSpPr>
+          <p:cNvPr id="33" name="Straight Connector 32">
+            <a:extLst>
+              <a:ext uri="{FF2B5EF4-FFF2-40B4-BE49-F238E27FC236}">
+                <a16:creationId xmlns:a16="http://schemas.microsoft.com/office/drawing/2014/main" id="{9E597F0B-0A17-4BF2-A904-9D99811F3E2E}"/>
+              </a:ext>
+              <a:ext uri="{C183D7F6-B498-43B3-948B-1728B52AA6E4}">
+                <adec:decorative xmlns:adec="http://schemas.microsoft.com/office/drawing/2017/decorative" val="1"/>
+              </a:ext>
+            </a:extLst>
+          </p:cNvPr>
+          <p:cNvCxnSpPr>
+            <a:cxnSpLocks noGrp="1" noRot="1" noChangeAspect="1" noMove="1" noResize="1" noEditPoints="1" noAdjustHandles="1" noChangeArrowheads="1" noChangeShapeType="1"/>
+          </p:cNvCxnSpPr>
+          <p:nvPr>
+            <p:extLst>
+              <p:ext uri="{386F3935-93C4-4BCD-93E2-E3B085C9AB24}">
+                <p16:designElem xmlns:p16="http://schemas.microsoft.com/office/powerpoint/2015/main" val="1"/>
+              </p:ext>
+            </p:extLst>
+          </p:nvPr>
+        </p:nvCxnSpPr>
+        <p:spPr>
+          <a:xfrm>
+            <a:off x="0" y="6128413"/>
+            <a:ext cx="12192000" cy="0"/>
+          </a:xfrm>
+          <a:prstGeom prst="line">
+            <a:avLst/>
+          </a:prstGeom>
+          <a:ln w="12700">
+            <a:solidFill>
+              <a:srgbClr val="000001">
+                <a:alpha val="20000"/>
+              </a:srgbClr>
+            </a:solidFill>
+          </a:ln>
+        </p:spPr>
+        <p:style>
+          <a:lnRef idx="1">
+            <a:schemeClr val="accent1"/>
+          </a:lnRef>
+          <a:fillRef idx="0">
+            <a:schemeClr val="accent1"/>
+          </a:fillRef>
+          <a:effectRef idx="0">
+            <a:schemeClr val="accent1"/>
+          </a:effectRef>
+          <a:fontRef idx="minor">
+            <a:schemeClr val="tx1"/>
+          </a:fontRef>
+        </p:style>
+      </p:cxnSp>
+    </p:spTree>
+    <p:extLst>
+      <p:ext uri="{BB962C8B-B14F-4D97-AF65-F5344CB8AC3E}">
+        <p14:creationId xmlns:p14="http://schemas.microsoft.com/office/powerpoint/2010/main" val="3817290165"/>
+      </p:ext>
+    </p:extLst>
+  </p:cSld>
+  <p:clrMapOvr>
+    <a:masterClrMapping/>
+  </p:clrMapOvr>
+</p:sld>
+</file>
+
+<file path=ppt/slides/slide17.xml><?xml version="1.0" encoding="utf-8"?>
+<p:sld xmlns:a="http://schemas.openxmlformats.org/drawingml/2006/main" xmlns:r="http://schemas.openxmlformats.org/officeDocument/2006/relationships" xmlns:p="http://schemas.openxmlformats.org/presentationml/2006/main">
+  <p:cSld>
+    <p:bg>
+      <p:bgPr>
+        <a:gradFill rotWithShape="1">
+          <a:gsLst>
+            <a:gs pos="0">
+              <a:schemeClr val="bg2">
+                <a:tint val="94000"/>
+                <a:satMod val="80000"/>
+                <a:lumMod val="106000"/>
+              </a:schemeClr>
+            </a:gs>
+            <a:gs pos="100000">
+              <a:schemeClr val="bg2">
+                <a:shade val="80000"/>
+              </a:schemeClr>
+            </a:gs>
+          </a:gsLst>
+          <a:path path="circle">
+            <a:fillToRect l="43000" r="43000" b="100000"/>
+          </a:path>
+        </a:gradFill>
+        <a:effectLst/>
+      </p:bgPr>
+    </p:bg>
+    <p:spTree>
+      <p:nvGrpSpPr>
+        <p:cNvPr id="1" name=""/>
+        <p:cNvGrpSpPr/>
+        <p:nvPr/>
+      </p:nvGrpSpPr>
+      <p:grpSpPr>
+        <a:xfrm>
+          <a:off x="0" y="0"/>
+          <a:ext cx="0" cy="0"/>
+          <a:chOff x="0" y="0"/>
+          <a:chExt cx="0" cy="0"/>
+        </a:xfrm>
+      </p:grpSpPr>
+      <p:sp>
+        <p:nvSpPr>
+          <p:cNvPr id="33" name="Rectangle 32">
+            <a:extLst>
+              <a:ext uri="{FF2B5EF4-FFF2-40B4-BE49-F238E27FC236}">
+                <a16:creationId xmlns:a16="http://schemas.microsoft.com/office/drawing/2014/main" id="{EEA869E1-F851-4A52-92F5-77E592B76A5B}"/>
+              </a:ext>
+              <a:ext uri="{C183D7F6-B498-43B3-948B-1728B52AA6E4}">
+                <adec:decorative xmlns:adec="http://schemas.microsoft.com/office/drawing/2017/decorative" val="1"/>
+              </a:ext>
+            </a:extLst>
+          </p:cNvPr>
+          <p:cNvSpPr>
+            <a:spLocks noGrp="1" noRot="1" noChangeAspect="1" noMove="1" noResize="1" noEditPoints="1" noAdjustHandles="1" noChangeArrowheads="1" noChangeShapeType="1" noTextEdit="1"/>
+          </p:cNvSpPr>
+          <p:nvPr>
+            <p:extLst>
+              <p:ext uri="{386F3935-93C4-4BCD-93E2-E3B085C9AB24}">
+                <p16:designElem xmlns:p16="http://schemas.microsoft.com/office/powerpoint/2015/main" val="1"/>
+              </p:ext>
+            </p:extLst>
+          </p:nvPr>
+        </p:nvSpPr>
+        <p:spPr>
+          <a:xfrm>
+            <a:off x="0" y="2019476"/>
+            <a:ext cx="12192000" cy="4105941"/>
+          </a:xfrm>
+          <a:prstGeom prst="rect">
+            <a:avLst/>
+          </a:prstGeom>
+          <a:gradFill flip="none" rotWithShape="1">
+            <a:gsLst>
+              <a:gs pos="0">
+                <a:schemeClr val="bg2">
+                  <a:alpha val="0"/>
+                </a:schemeClr>
+              </a:gs>
+              <a:gs pos="100000">
+                <a:schemeClr val="bg2"/>
+              </a:gs>
+            </a:gsLst>
+            <a:lin ang="5400000" scaled="0"/>
+            <a:tileRect/>
+          </a:gradFill>
+          <a:ln>
+            <a:noFill/>
+          </a:ln>
+        </p:spPr>
+        <p:style>
+          <a:lnRef idx="2">
+            <a:schemeClr val="accent1">
+              <a:shade val="50000"/>
+            </a:schemeClr>
+          </a:lnRef>
+          <a:fillRef idx="1">
+            <a:schemeClr val="accent1"/>
+          </a:fillRef>
+          <a:effectRef idx="0">
+            <a:schemeClr val="accent1"/>
+          </a:effectRef>
+          <a:fontRef idx="minor">
+            <a:schemeClr val="lt1"/>
+          </a:fontRef>
+        </p:style>
+        <p:txBody>
+          <a:bodyPr/>
+          <a:lstStyle/>
+          <a:p>
+            <a:endParaRPr lang="en-US"/>
+          </a:p>
+        </p:txBody>
+      </p:sp>
+      <p:pic>
+        <p:nvPicPr>
+          <p:cNvPr id="35" name="Picture 34">
+            <a:extLst>
+              <a:ext uri="{FF2B5EF4-FFF2-40B4-BE49-F238E27FC236}">
+                <a16:creationId xmlns:a16="http://schemas.microsoft.com/office/drawing/2014/main" id="{B083AD55-8296-44BD-8E14-DD2DDBC351B0}"/>
+              </a:ext>
+              <a:ext uri="{C183D7F6-B498-43B3-948B-1728B52AA6E4}">
+                <adec:decorative xmlns:adec="http://schemas.microsoft.com/office/drawing/2017/decorative" val="1"/>
+              </a:ext>
+            </a:extLst>
+          </p:cNvPr>
+          <p:cNvPicPr>
+            <a:picLocks noGrp="1" noRot="1" noChangeAspect="1" noMove="1" noResize="1" noEditPoints="1" noAdjustHandles="1" noChangeArrowheads="1" noChangeShapeType="1" noCrop="1"/>
+          </p:cNvPicPr>
+          <p:nvPr>
+            <p:extLst>
+              <p:ext uri="{386F3935-93C4-4BCD-93E2-E3B085C9AB24}">
+                <p16:designElem xmlns:p16="http://schemas.microsoft.com/office/powerpoint/2015/main" val="1"/>
+              </p:ext>
+            </p:extLst>
+          </p:nvPr>
+        </p:nvPicPr>
+        <p:blipFill rotWithShape="1">
+          <a:blip r:embed="rId2">
+            <a:extLst>
+              <a:ext uri="{28A0092B-C50C-407E-A947-70E740481C1C}">
+                <a14:useLocalDpi xmlns:a14="http://schemas.microsoft.com/office/drawing/2010/main" val="0"/>
+              </a:ext>
+            </a:extLst>
+          </a:blip>
+          <a:srcRect t="1538" b="-1538"/>
+          <a:stretch/>
+        </p:blipFill>
+        <p:spPr bwMode="black">
+          <a:xfrm>
+            <a:off x="0" y="6126480"/>
+            <a:ext cx="12192000" cy="742950"/>
+          </a:xfrm>
+          <a:prstGeom prst="rect">
+            <a:avLst/>
+          </a:prstGeom>
+        </p:spPr>
+      </p:pic>
+      <p:cxnSp>
+        <p:nvCxnSpPr>
+          <p:cNvPr id="37" name="Straight Connector 36">
+            <a:extLst>
+              <a:ext uri="{FF2B5EF4-FFF2-40B4-BE49-F238E27FC236}">
+                <a16:creationId xmlns:a16="http://schemas.microsoft.com/office/drawing/2014/main" id="{2BF46B26-15FC-4C5A-94FA-AE9ED64B5C20}"/>
+              </a:ext>
+              <a:ext uri="{C183D7F6-B498-43B3-948B-1728B52AA6E4}">
+                <adec:decorative xmlns:adec="http://schemas.microsoft.com/office/drawing/2017/decorative" val="1"/>
+              </a:ext>
+            </a:extLst>
+          </p:cNvPr>
+          <p:cNvCxnSpPr>
+            <a:cxnSpLocks noGrp="1" noRot="1" noChangeAspect="1" noMove="1" noResize="1" noEditPoints="1" noAdjustHandles="1" noChangeArrowheads="1" noChangeShapeType="1"/>
+          </p:cNvCxnSpPr>
+          <p:nvPr>
+            <p:extLst>
+              <p:ext uri="{386F3935-93C4-4BCD-93E2-E3B085C9AB24}">
+                <p16:designElem xmlns:p16="http://schemas.microsoft.com/office/powerpoint/2015/main" val="1"/>
+              </p:ext>
+            </p:extLst>
+          </p:nvPr>
+        </p:nvCxnSpPr>
+        <p:spPr>
+          <a:xfrm>
+            <a:off x="0" y="6128413"/>
+            <a:ext cx="12192000" cy="0"/>
+          </a:xfrm>
+          <a:prstGeom prst="line">
+            <a:avLst/>
+          </a:prstGeom>
+          <a:ln w="12700">
+            <a:solidFill>
+              <a:srgbClr val="000001">
+                <a:alpha val="20000"/>
+              </a:srgbClr>
+            </a:solidFill>
+          </a:ln>
+        </p:spPr>
+        <p:style>
+          <a:lnRef idx="1">
+            <a:schemeClr val="accent1"/>
+          </a:lnRef>
+          <a:fillRef idx="0">
+            <a:schemeClr val="accent1"/>
+          </a:fillRef>
+          <a:effectRef idx="0">
+            <a:schemeClr val="accent1"/>
+          </a:effectRef>
+          <a:fontRef idx="minor">
+            <a:schemeClr val="tx1"/>
+          </a:fontRef>
+        </p:style>
+      </p:cxnSp>
+      <p:cxnSp>
+        <p:nvCxnSpPr>
+          <p:cNvPr id="39" name="Straight Connector 38">
+            <a:extLst>
+              <a:ext uri="{FF2B5EF4-FFF2-40B4-BE49-F238E27FC236}">
+                <a16:creationId xmlns:a16="http://schemas.microsoft.com/office/drawing/2014/main" id="{912F6065-5345-44BD-B66E-5487CCD7A9B9}"/>
+              </a:ext>
+              <a:ext uri="{C183D7F6-B498-43B3-948B-1728B52AA6E4}">
+                <adec:decorative xmlns:adec="http://schemas.microsoft.com/office/drawing/2017/decorative" val="1"/>
+              </a:ext>
+            </a:extLst>
+          </p:cNvPr>
+          <p:cNvCxnSpPr>
+            <a:cxnSpLocks noGrp="1" noRot="1" noChangeAspect="1" noMove="1" noResize="1" noEditPoints="1" noAdjustHandles="1" noChangeArrowheads="1" noChangeShapeType="1"/>
+          </p:cNvCxnSpPr>
+          <p:nvPr>
+            <p:extLst>
+              <p:ext uri="{386F3935-93C4-4BCD-93E2-E3B085C9AB24}">
+                <p16:designElem xmlns:p16="http://schemas.microsoft.com/office/powerpoint/2015/main" val="1"/>
+              </p:ext>
+            </p:extLst>
+          </p:nvPr>
+        </p:nvCxnSpPr>
+        <p:spPr>
+          <a:xfrm>
+            <a:off x="2417780" y="3528542"/>
+            <a:ext cx="8637072" cy="0"/>
+          </a:xfrm>
+          <a:prstGeom prst="line">
+            <a:avLst/>
+          </a:prstGeom>
+          <a:ln w="31750"/>
+        </p:spPr>
+        <p:style>
+          <a:lnRef idx="3">
+            <a:schemeClr val="accent1"/>
+          </a:lnRef>
+          <a:fillRef idx="0">
+            <a:schemeClr val="accent1"/>
+          </a:fillRef>
+          <a:effectRef idx="2">
+            <a:schemeClr val="accent1"/>
+          </a:effectRef>
+          <a:fontRef idx="minor">
+            <a:schemeClr val="tx1"/>
+          </a:fontRef>
+        </p:style>
+      </p:cxnSp>
+      <p:sp useBgFill="1">
+        <p:nvSpPr>
+          <p:cNvPr id="41" name="Rectangle 40">
+            <a:extLst>
+              <a:ext uri="{FF2B5EF4-FFF2-40B4-BE49-F238E27FC236}">
+                <a16:creationId xmlns:a16="http://schemas.microsoft.com/office/drawing/2014/main" id="{E7ABCFA2-55B0-438C-A39A-637FFC6246E8}"/>
+              </a:ext>
+              <a:ext uri="{C183D7F6-B498-43B3-948B-1728B52AA6E4}">
+                <adec:decorative xmlns:adec="http://schemas.microsoft.com/office/drawing/2017/decorative" val="1"/>
+              </a:ext>
+            </a:extLst>
+          </p:cNvPr>
+          <p:cNvSpPr>
+            <a:spLocks noGrp="1" noRot="1" noChangeAspect="1" noMove="1" noResize="1" noEditPoints="1" noAdjustHandles="1" noChangeArrowheads="1" noChangeShapeType="1" noTextEdit="1"/>
+          </p:cNvSpPr>
+          <p:nvPr>
+            <p:extLst>
+              <p:ext uri="{386F3935-93C4-4BCD-93E2-E3B085C9AB24}">
+                <p16:designElem xmlns:p16="http://schemas.microsoft.com/office/powerpoint/2015/main" val="1"/>
+              </p:ext>
+            </p:extLst>
+          </p:nvPr>
+        </p:nvSpPr>
+        <p:spPr>
+          <a:xfrm>
+            <a:off x="2" y="0"/>
+            <a:ext cx="12191695" cy="6858000"/>
+          </a:xfrm>
+          <a:prstGeom prst="rect">
+            <a:avLst/>
+          </a:prstGeom>
+          <a:ln>
+            <a:noFill/>
+          </a:ln>
+        </p:spPr>
+        <p:style>
+          <a:lnRef idx="2">
+            <a:schemeClr val="accent1">
+              <a:shade val="50000"/>
+            </a:schemeClr>
+          </a:lnRef>
+          <a:fillRef idx="1">
+            <a:schemeClr val="accent1"/>
+          </a:fillRef>
+          <a:effectRef idx="0">
+            <a:schemeClr val="accent1"/>
+          </a:effectRef>
+          <a:fontRef idx="minor">
+            <a:schemeClr val="lt1"/>
+          </a:fontRef>
+        </p:style>
+        <p:txBody>
+          <a:bodyPr rtlCol="0" anchor="ctr"/>
+          <a:lstStyle/>
+          <a:p>
+            <a:pPr algn="ctr"/>
+            <a:endParaRPr lang="en-US"/>
+          </a:p>
+        </p:txBody>
+      </p:sp>
+      <p:sp>
+        <p:nvSpPr>
+          <p:cNvPr id="43" name="Rectangle 42">
+            <a:extLst>
+              <a:ext uri="{FF2B5EF4-FFF2-40B4-BE49-F238E27FC236}">
+                <a16:creationId xmlns:a16="http://schemas.microsoft.com/office/drawing/2014/main" id="{1BD2C934-710E-4E0E-9ED4-03F07E019205}"/>
+              </a:ext>
+              <a:ext uri="{C183D7F6-B498-43B3-948B-1728B52AA6E4}">
+                <adec:decorative xmlns:adec="http://schemas.microsoft.com/office/drawing/2017/decorative" val="1"/>
+              </a:ext>
+            </a:extLst>
+          </p:cNvPr>
+          <p:cNvSpPr>
+            <a:spLocks noGrp="1" noRot="1" noChangeAspect="1" noMove="1" noResize="1" noEditPoints="1" noAdjustHandles="1" noChangeArrowheads="1" noChangeShapeType="1" noTextEdit="1"/>
+          </p:cNvSpPr>
+          <p:nvPr>
+            <p:extLst>
+              <p:ext uri="{386F3935-93C4-4BCD-93E2-E3B085C9AB24}">
+                <p16:designElem xmlns:p16="http://schemas.microsoft.com/office/powerpoint/2015/main" val="1"/>
+              </p:ext>
+            </p:extLst>
+          </p:nvPr>
+        </p:nvSpPr>
+        <p:spPr>
+          <a:xfrm>
+            <a:off x="0" y="2019476"/>
+            <a:ext cx="12192000" cy="4105941"/>
+          </a:xfrm>
+          <a:prstGeom prst="rect">
+            <a:avLst/>
+          </a:prstGeom>
+          <a:gradFill flip="none" rotWithShape="1">
+            <a:gsLst>
+              <a:gs pos="0">
+                <a:schemeClr val="bg2">
+                  <a:alpha val="0"/>
+                </a:schemeClr>
+              </a:gs>
+              <a:gs pos="100000">
+                <a:schemeClr val="bg2"/>
+              </a:gs>
+            </a:gsLst>
+            <a:lin ang="5400000" scaled="0"/>
+            <a:tileRect/>
+          </a:gradFill>
+          <a:ln>
+            <a:noFill/>
+          </a:ln>
+        </p:spPr>
+        <p:style>
+          <a:lnRef idx="2">
+            <a:schemeClr val="accent1">
+              <a:shade val="50000"/>
+            </a:schemeClr>
+          </a:lnRef>
+          <a:fillRef idx="1">
+            <a:schemeClr val="accent1"/>
+          </a:fillRef>
+          <a:effectRef idx="0">
+            <a:schemeClr val="accent1"/>
+          </a:effectRef>
+          <a:fontRef idx="minor">
+            <a:schemeClr val="lt1"/>
+          </a:fontRef>
+        </p:style>
+        <p:txBody>
+          <a:bodyPr rtlCol="0" anchor="ctr"/>
+          <a:lstStyle/>
+          <a:p>
+            <a:pPr lvl="0" algn="ctr"/>
+            <a:endParaRPr lang="en-US"/>
+          </a:p>
+        </p:txBody>
+      </p:sp>
+      <p:sp>
+        <p:nvSpPr>
+          <p:cNvPr id="2" name="Title 1">
+            <a:extLst>
+              <a:ext uri="{FF2B5EF4-FFF2-40B4-BE49-F238E27FC236}">
+                <a16:creationId xmlns:a16="http://schemas.microsoft.com/office/drawing/2014/main" id="{BAF48F60-BA92-C874-30CC-5ED58A820747}"/>
+              </a:ext>
+            </a:extLst>
+          </p:cNvPr>
+          <p:cNvSpPr>
+            <a:spLocks noGrp="1"/>
+          </p:cNvSpPr>
+          <p:nvPr>
+            <p:ph type="title"/>
+          </p:nvPr>
+        </p:nvSpPr>
+        <p:spPr>
+          <a:xfrm>
+            <a:off x="485695" y="1474969"/>
+            <a:ext cx="3026558" cy="1868760"/>
+          </a:xfrm>
+        </p:spPr>
+        <p:txBody>
+          <a:bodyPr vert="horz" lIns="91440" tIns="45720" rIns="91440" bIns="0" rtlCol="0" anchor="b">
+            <a:normAutofit/>
+          </a:bodyPr>
+          <a:lstStyle/>
+          <a:p>
+            <a:r>
+              <a:rPr lang="en-US" sz="3600" dirty="0"/>
+              <a:t>Vlajk Sándor - </a:t>
+            </a:r>
+            <a:r>
+              <a:rPr lang="en-US" sz="3600" dirty="0" err="1"/>
+              <a:t>Tesztelés</a:t>
+            </a:r>
+            <a:endParaRPr lang="en-US" sz="3600" dirty="0"/>
+          </a:p>
+        </p:txBody>
+      </p:sp>
+      <p:cxnSp>
+        <p:nvCxnSpPr>
+          <p:cNvPr id="45" name="Straight Connector 44">
+            <a:extLst>
+              <a:ext uri="{FF2B5EF4-FFF2-40B4-BE49-F238E27FC236}">
+                <a16:creationId xmlns:a16="http://schemas.microsoft.com/office/drawing/2014/main" id="{0AD0F4F3-8F5C-421F-9FC1-DB3ED0BF61DF}"/>
+              </a:ext>
+              <a:ext uri="{C183D7F6-B498-43B3-948B-1728B52AA6E4}">
+                <adec:decorative xmlns:adec="http://schemas.microsoft.com/office/drawing/2017/decorative" val="1"/>
+              </a:ext>
+            </a:extLst>
+          </p:cNvPr>
+          <p:cNvCxnSpPr>
+            <a:cxnSpLocks noGrp="1" noRot="1" noChangeAspect="1" noMove="1" noResize="1" noEditPoints="1" noAdjustHandles="1" noChangeArrowheads="1" noChangeShapeType="1"/>
+          </p:cNvCxnSpPr>
+          <p:nvPr>
+            <p:extLst>
+              <p:ext uri="{386F3935-93C4-4BCD-93E2-E3B085C9AB24}">
+                <p16:designElem xmlns:p16="http://schemas.microsoft.com/office/powerpoint/2015/main" val="1"/>
+              </p:ext>
+            </p:extLst>
+          </p:nvPr>
+        </p:nvCxnSpPr>
+        <p:spPr>
+          <a:xfrm>
+            <a:off x="484009" y="3526496"/>
+            <a:ext cx="3023617" cy="0"/>
+          </a:xfrm>
+          <a:prstGeom prst="line">
+            <a:avLst/>
+          </a:prstGeom>
+          <a:ln w="31750"/>
+        </p:spPr>
+        <p:style>
+          <a:lnRef idx="3">
+            <a:schemeClr val="accent1"/>
+          </a:lnRef>
+          <a:fillRef idx="0">
+            <a:schemeClr val="accent1"/>
+          </a:fillRef>
+          <a:effectRef idx="2">
+            <a:schemeClr val="accent1"/>
+          </a:effectRef>
+          <a:fontRef idx="minor">
+            <a:schemeClr val="tx1"/>
+          </a:fontRef>
+        </p:style>
+      </p:cxnSp>
+      <p:pic>
+        <p:nvPicPr>
+          <p:cNvPr id="7" name="Picture 6">
+            <a:extLst>
+              <a:ext uri="{FF2B5EF4-FFF2-40B4-BE49-F238E27FC236}">
+                <a16:creationId xmlns:a16="http://schemas.microsoft.com/office/drawing/2014/main" id="{234C8A63-DED3-546C-6BEE-CEFFDC8E281B}"/>
+              </a:ext>
+            </a:extLst>
+          </p:cNvPr>
+          <p:cNvPicPr>
+            <a:picLocks noChangeAspect="1"/>
+          </p:cNvPicPr>
+          <p:nvPr/>
+        </p:nvPicPr>
+        <p:blipFill>
+          <a:blip r:embed="rId3"/>
+          <a:stretch>
+            <a:fillRect/>
+          </a:stretch>
+        </p:blipFill>
+        <p:spPr>
+          <a:xfrm>
+            <a:off x="4528985" y="3109744"/>
+            <a:ext cx="7094289" cy="2837715"/>
+          </a:xfrm>
+          <a:prstGeom prst="rect">
+            <a:avLst/>
+          </a:prstGeom>
+        </p:spPr>
+      </p:pic>
+      <p:pic>
+        <p:nvPicPr>
+          <p:cNvPr id="5" name="Picture 4">
+            <a:extLst>
+              <a:ext uri="{FF2B5EF4-FFF2-40B4-BE49-F238E27FC236}">
+                <a16:creationId xmlns:a16="http://schemas.microsoft.com/office/drawing/2014/main" id="{468886C1-6620-95E9-B1BE-EABD49FF3267}"/>
+              </a:ext>
+            </a:extLst>
+          </p:cNvPr>
+          <p:cNvPicPr>
+            <a:picLocks noChangeAspect="1"/>
+          </p:cNvPicPr>
+          <p:nvPr/>
+        </p:nvPicPr>
+        <p:blipFill>
+          <a:blip r:embed="rId4"/>
+          <a:stretch>
+            <a:fillRect/>
+          </a:stretch>
+        </p:blipFill>
+        <p:spPr>
+          <a:xfrm>
+            <a:off x="3077701" y="159389"/>
+            <a:ext cx="7560295" cy="2608300"/>
+          </a:xfrm>
+          <a:prstGeom prst="rect">
+            <a:avLst/>
+          </a:prstGeom>
+        </p:spPr>
+      </p:pic>
+      <p:pic>
+        <p:nvPicPr>
+          <p:cNvPr id="47" name="Picture 46">
+            <a:extLst>
+              <a:ext uri="{FF2B5EF4-FFF2-40B4-BE49-F238E27FC236}">
+                <a16:creationId xmlns:a16="http://schemas.microsoft.com/office/drawing/2014/main" id="{B0A40572-62E5-460B-AD24-B6628527ACB1}"/>
+              </a:ext>
+              <a:ext uri="{C183D7F6-B498-43B3-948B-1728B52AA6E4}">
+                <adec:decorative xmlns:adec="http://schemas.microsoft.com/office/drawing/2017/decorative" val="1"/>
+              </a:ext>
+            </a:extLst>
+          </p:cNvPr>
+          <p:cNvPicPr>
+            <a:picLocks noGrp="1" noRot="1" noChangeAspect="1" noMove="1" noResize="1" noEditPoints="1" noAdjustHandles="1" noChangeArrowheads="1" noChangeShapeType="1" noCrop="1"/>
+          </p:cNvPicPr>
+          <p:nvPr>
+            <p:extLst>
+              <p:ext uri="{386F3935-93C4-4BCD-93E2-E3B085C9AB24}">
+                <p16:designElem xmlns:p16="http://schemas.microsoft.com/office/powerpoint/2015/main" val="1"/>
+              </p:ext>
+            </p:extLst>
+          </p:nvPr>
+        </p:nvPicPr>
+        <p:blipFill rotWithShape="1">
+          <a:blip r:embed="rId2">
+            <a:extLst>
+              <a:ext uri="{28A0092B-C50C-407E-A947-70E740481C1C}">
+                <a14:useLocalDpi xmlns:a14="http://schemas.microsoft.com/office/drawing/2010/main" val="0"/>
+              </a:ext>
+            </a:extLst>
+          </a:blip>
+          <a:srcRect t="1538" b="-1538"/>
+          <a:stretch/>
+        </p:blipFill>
+        <p:spPr bwMode="black">
+          <a:xfrm>
+            <a:off x="0" y="6126480"/>
+            <a:ext cx="12192000" cy="742950"/>
+          </a:xfrm>
+          <a:prstGeom prst="rect">
+            <a:avLst/>
+          </a:prstGeom>
+        </p:spPr>
+      </p:pic>
+      <p:cxnSp>
+        <p:nvCxnSpPr>
+          <p:cNvPr id="49" name="Straight Connector 48">
+            <a:extLst>
+              <a:ext uri="{FF2B5EF4-FFF2-40B4-BE49-F238E27FC236}">
+                <a16:creationId xmlns:a16="http://schemas.microsoft.com/office/drawing/2014/main" id="{F1D872D4-D7E5-4CD8-9DAC-2BC612F08E69}"/>
+              </a:ext>
+              <a:ext uri="{C183D7F6-B498-43B3-948B-1728B52AA6E4}">
+                <adec:decorative xmlns:adec="http://schemas.microsoft.com/office/drawing/2017/decorative" val="1"/>
+              </a:ext>
+            </a:extLst>
+          </p:cNvPr>
+          <p:cNvCxnSpPr>
+            <a:cxnSpLocks noGrp="1" noRot="1" noChangeAspect="1" noMove="1" noResize="1" noEditPoints="1" noAdjustHandles="1" noChangeArrowheads="1" noChangeShapeType="1"/>
+          </p:cNvCxnSpPr>
+          <p:nvPr>
+            <p:extLst>
+              <p:ext uri="{386F3935-93C4-4BCD-93E2-E3B085C9AB24}">
+                <p16:designElem xmlns:p16="http://schemas.microsoft.com/office/powerpoint/2015/main" val="1"/>
+              </p:ext>
+            </p:extLst>
+          </p:nvPr>
+        </p:nvCxnSpPr>
+        <p:spPr>
+          <a:xfrm>
+            <a:off x="0" y="6128413"/>
+            <a:ext cx="12192000" cy="0"/>
+          </a:xfrm>
+          <a:prstGeom prst="line">
+            <a:avLst/>
+          </a:prstGeom>
+          <a:ln w="12700">
+            <a:solidFill>
+              <a:srgbClr val="000001">
+                <a:alpha val="20000"/>
+              </a:srgbClr>
+            </a:solidFill>
+          </a:ln>
+        </p:spPr>
+        <p:style>
+          <a:lnRef idx="1">
+            <a:schemeClr val="accent1"/>
+          </a:lnRef>
+          <a:fillRef idx="0">
+            <a:schemeClr val="accent1"/>
+          </a:fillRef>
+          <a:effectRef idx="0">
+            <a:schemeClr val="accent1"/>
+          </a:effectRef>
+          <a:fontRef idx="minor">
+            <a:schemeClr val="tx1"/>
+          </a:fontRef>
+        </p:style>
+      </p:cxnSp>
+    </p:spTree>
+    <p:extLst>
+      <p:ext uri="{BB962C8B-B14F-4D97-AF65-F5344CB8AC3E}">
+        <p14:creationId xmlns:p14="http://schemas.microsoft.com/office/powerpoint/2010/main" val="858810309"/>
+      </p:ext>
+    </p:extLst>
+  </p:cSld>
+  <p:clrMapOvr>
+    <a:masterClrMapping/>
+  </p:clrMapOvr>
 </p:sld>
 </file>
 

</xml_diff>

<commit_message>
update: added my personal progress to PPT
</commit_message>
<xml_diff>
--- a/Kanban webapp - Buborék együttes.pptx
+++ b/Kanban webapp - Buborék együttes.pptx
@@ -5,10 +5,10 @@
     <p:sldMasterId id="2147483672" r:id="rId1"/>
   </p:sldMasterIdLst>
   <p:notesMasterIdLst>
-    <p:notesMasterId r:id="rId26"/>
+    <p:notesMasterId r:id="rId31"/>
   </p:notesMasterIdLst>
   <p:handoutMasterIdLst>
-    <p:handoutMasterId r:id="rId27"/>
+    <p:handoutMasterId r:id="rId32"/>
   </p:handoutMasterIdLst>
   <p:sldIdLst>
     <p:sldId id="258" r:id="rId2"/>
@@ -35,6 +35,11 @@
     <p:sldId id="281" r:id="rId23"/>
     <p:sldId id="282" r:id="rId24"/>
     <p:sldId id="283" r:id="rId25"/>
+    <p:sldId id="284" r:id="rId26"/>
+    <p:sldId id="285" r:id="rId27"/>
+    <p:sldId id="287" r:id="rId28"/>
+    <p:sldId id="288" r:id="rId29"/>
+    <p:sldId id="289" r:id="rId30"/>
   </p:sldIdLst>
   <p:sldSz cx="12192000" cy="6858000"/>
   <p:notesSz cx="6858000" cy="9144000"/>
@@ -247,7 +252,7 @@
             <a:fld id="{795EECD7-D4C7-4FE3-AB70-00E199DD6761}" type="datetimeFigureOut">
               <a:rPr lang="hu-HU" smtClean="0"/>
               <a:pPr/>
-              <a:t>2025. 11. 16.</a:t>
+              <a:t>2025. 11. 17.</a:t>
             </a:fld>
             <a:endParaRPr lang="hu-HU"/>
           </a:p>
@@ -427,7 +432,7 @@
             <a:fld id="{2D5DABCF-F2FF-4310-8608-C10C325E963C}" type="datetimeFigureOut">
               <a:rPr lang="hu-HU" smtClean="0"/>
               <a:pPr/>
-              <a:t>2025. 11. 16.</a:t>
+              <a:t>2025. 11. 17.</a:t>
             </a:fld>
             <a:endParaRPr lang="hu-HU"/>
           </a:p>
@@ -921,7 +926,7 @@
             <a:fld id="{67F45AC6-C491-4585-A584-9CE2AF7D5500}" type="datetime1">
               <a:rPr lang="en-US" smtClean="0"/>
               <a:pPr/>
-              <a:t>11/16/2025</a:t>
+              <a:t>11/17/2025</a:t>
             </a:fld>
             <a:endParaRPr lang="en-US"/>
           </a:p>
@@ -1135,7 +1140,7 @@
             <a:fld id="{67F45AC6-C491-4585-A584-9CE2AF7D5500}" type="datetime1">
               <a:rPr lang="en-US" smtClean="0"/>
               <a:pPr/>
-              <a:t>11/16/2025</a:t>
+              <a:t>11/17/2025</a:t>
             </a:fld>
             <a:endParaRPr lang="en-US"/>
           </a:p>
@@ -1353,7 +1358,7 @@
             <a:fld id="{67F45AC6-C491-4585-A584-9CE2AF7D5500}" type="datetime1">
               <a:rPr lang="en-US" smtClean="0"/>
               <a:pPr/>
-              <a:t>11/16/2025</a:t>
+              <a:t>11/17/2025</a:t>
             </a:fld>
             <a:endParaRPr lang="en-US"/>
           </a:p>
@@ -1557,7 +1562,7 @@
             <a:fld id="{67F45AC6-C491-4585-A584-9CE2AF7D5500}" type="datetime1">
               <a:rPr lang="en-US" smtClean="0"/>
               <a:pPr/>
-              <a:t>11/16/2025</a:t>
+              <a:t>11/17/2025</a:t>
             </a:fld>
             <a:endParaRPr lang="en-US"/>
           </a:p>
@@ -1839,7 +1844,7 @@
             <a:fld id="{67F45AC6-C491-4585-A584-9CE2AF7D5500}" type="datetime1">
               <a:rPr lang="en-US" smtClean="0"/>
               <a:pPr/>
-              <a:t>11/16/2025</a:t>
+              <a:t>11/17/2025</a:t>
             </a:fld>
             <a:endParaRPr lang="en-US"/>
           </a:p>
@@ -2110,7 +2115,7 @@
             <a:fld id="{67F45AC6-C491-4585-A584-9CE2AF7D5500}" type="datetime1">
               <a:rPr lang="en-US" smtClean="0"/>
               <a:pPr/>
-              <a:t>11/16/2025</a:t>
+              <a:t>11/17/2025</a:t>
             </a:fld>
             <a:endParaRPr lang="en-US"/>
           </a:p>
@@ -2529,7 +2534,7 @@
             <a:fld id="{67F45AC6-C491-4585-A584-9CE2AF7D5500}" type="datetime1">
               <a:rPr lang="en-US" smtClean="0"/>
               <a:pPr/>
-              <a:t>11/16/2025</a:t>
+              <a:t>11/17/2025</a:t>
             </a:fld>
             <a:endParaRPr lang="en-US"/>
           </a:p>
@@ -2681,7 +2686,7 @@
             <a:fld id="{67F45AC6-C491-4585-A584-9CE2AF7D5500}" type="datetime1">
               <a:rPr lang="en-US" smtClean="0"/>
               <a:pPr/>
-              <a:t>11/16/2025</a:t>
+              <a:t>11/17/2025</a:t>
             </a:fld>
             <a:endParaRPr lang="en-US"/>
           </a:p>
@@ -2810,7 +2815,7 @@
             <a:fld id="{67F45AC6-C491-4585-A584-9CE2AF7D5500}" type="datetime1">
               <a:rPr lang="en-US" smtClean="0"/>
               <a:pPr/>
-              <a:t>11/16/2025</a:t>
+              <a:t>11/17/2025</a:t>
             </a:fld>
             <a:endParaRPr lang="en-US"/>
           </a:p>
@@ -3064,7 +3069,7 @@
             <a:fld id="{67F45AC6-C491-4585-A584-9CE2AF7D5500}" type="datetime1">
               <a:rPr lang="en-US" smtClean="0"/>
               <a:pPr/>
-              <a:t>11/16/2025</a:t>
+              <a:t>11/17/2025</a:t>
             </a:fld>
             <a:endParaRPr lang="en-US"/>
           </a:p>
@@ -3512,7 +3517,7 @@
             <a:fld id="{67F45AC6-C491-4585-A584-9CE2AF7D5500}" type="datetime1">
               <a:rPr lang="en-US" smtClean="0"/>
               <a:pPr/>
-              <a:t>11/16/2025</a:t>
+              <a:t>11/17/2025</a:t>
             </a:fld>
             <a:endParaRPr lang="en-US"/>
           </a:p>
@@ -3849,7 +3854,7 @@
             <a:fld id="{67F45AC6-C491-4585-A584-9CE2AF7D5500}" type="datetime1">
               <a:rPr lang="en-US" smtClean="0"/>
               <a:pPr/>
-              <a:t>11/16/2025</a:t>
+              <a:t>11/17/2025</a:t>
             </a:fld>
             <a:endParaRPr lang="en-US"/>
           </a:p>
@@ -11426,6 +11431,699 @@
         </p:spPr>
       </p:pic>
     </p:spTree>
+  </p:cSld>
+  <p:clrMapOvr>
+    <a:masterClrMapping/>
+  </p:clrMapOvr>
+</p:sld>
+</file>
+
+<file path=ppt/slides/slide25.xml><?xml version="1.0" encoding="utf-8"?>
+<p:sld xmlns:a="http://schemas.openxmlformats.org/drawingml/2006/main" xmlns:r="http://schemas.openxmlformats.org/officeDocument/2006/relationships" xmlns:p="http://schemas.openxmlformats.org/presentationml/2006/main">
+  <p:cSld>
+    <p:spTree>
+      <p:nvGrpSpPr>
+        <p:cNvPr id="1" name=""/>
+        <p:cNvGrpSpPr/>
+        <p:nvPr/>
+      </p:nvGrpSpPr>
+      <p:grpSpPr>
+        <a:xfrm>
+          <a:off x="0" y="0"/>
+          <a:ext cx="0" cy="0"/>
+          <a:chOff x="0" y="0"/>
+          <a:chExt cx="0" cy="0"/>
+        </a:xfrm>
+      </p:grpSpPr>
+      <p:sp>
+        <p:nvSpPr>
+          <p:cNvPr id="2" name="Cím 1"/>
+          <p:cNvSpPr>
+            <a:spLocks noGrp="1"/>
+          </p:cNvSpPr>
+          <p:nvPr>
+            <p:ph type="title"/>
+          </p:nvPr>
+        </p:nvSpPr>
+        <p:spPr>
+          <a:xfrm>
+            <a:off x="1444671" y="798973"/>
+            <a:ext cx="3273099" cy="2418680"/>
+          </a:xfrm>
+        </p:spPr>
+        <p:txBody>
+          <a:bodyPr>
+            <a:normAutofit/>
+          </a:bodyPr>
+          <a:lstStyle/>
+          <a:p>
+            <a:r>
+              <a:rPr lang="hu-HU" sz="3200" dirty="0"/>
+              <a:t>Molnár Attila Management </a:t>
+            </a:r>
+          </a:p>
+        </p:txBody>
+      </p:sp>
+      <p:pic>
+        <p:nvPicPr>
+          <p:cNvPr id="4" name="Kép 3">
+            <a:extLst>
+              <a:ext uri="{FF2B5EF4-FFF2-40B4-BE49-F238E27FC236}">
+                <a16:creationId xmlns:a16="http://schemas.microsoft.com/office/drawing/2014/main" id="{8F5E240A-3213-AB66-3490-B67AB724433A}"/>
+              </a:ext>
+            </a:extLst>
+          </p:cNvPr>
+          <p:cNvPicPr>
+            <a:picLocks noChangeAspect="1"/>
+          </p:cNvPicPr>
+          <p:nvPr/>
+        </p:nvPicPr>
+        <p:blipFill>
+          <a:blip r:embed="rId2"/>
+          <a:stretch>
+            <a:fillRect/>
+          </a:stretch>
+        </p:blipFill>
+        <p:spPr>
+          <a:xfrm>
+            <a:off x="1107305" y="3588589"/>
+            <a:ext cx="3610465" cy="3077212"/>
+          </a:xfrm>
+          <a:prstGeom prst="rect">
+            <a:avLst/>
+          </a:prstGeom>
+        </p:spPr>
+      </p:pic>
+      <p:pic>
+        <p:nvPicPr>
+          <p:cNvPr id="9" name="Kép 8">
+            <a:extLst>
+              <a:ext uri="{FF2B5EF4-FFF2-40B4-BE49-F238E27FC236}">
+                <a16:creationId xmlns:a16="http://schemas.microsoft.com/office/drawing/2014/main" id="{DEC6BEF6-417E-4B25-FC15-F9A180853B7C}"/>
+              </a:ext>
+            </a:extLst>
+          </p:cNvPr>
+          <p:cNvPicPr>
+            <a:picLocks noChangeAspect="1"/>
+          </p:cNvPicPr>
+          <p:nvPr/>
+        </p:nvPicPr>
+        <p:blipFill>
+          <a:blip r:embed="rId3"/>
+          <a:stretch>
+            <a:fillRect/>
+          </a:stretch>
+        </p:blipFill>
+        <p:spPr>
+          <a:xfrm>
+            <a:off x="5327651" y="2370349"/>
+            <a:ext cx="3621419" cy="4208129"/>
+          </a:xfrm>
+          <a:prstGeom prst="rect">
+            <a:avLst/>
+          </a:prstGeom>
+        </p:spPr>
+      </p:pic>
+      <p:pic>
+        <p:nvPicPr>
+          <p:cNvPr id="11" name="Kép 10">
+            <a:extLst>
+              <a:ext uri="{FF2B5EF4-FFF2-40B4-BE49-F238E27FC236}">
+                <a16:creationId xmlns:a16="http://schemas.microsoft.com/office/drawing/2014/main" id="{8252F1FA-58E6-8D55-BAC6-75278DAEF71C}"/>
+              </a:ext>
+            </a:extLst>
+          </p:cNvPr>
+          <p:cNvPicPr>
+            <a:picLocks noChangeAspect="1"/>
+          </p:cNvPicPr>
+          <p:nvPr/>
+        </p:nvPicPr>
+        <p:blipFill>
+          <a:blip r:embed="rId4"/>
+          <a:stretch>
+            <a:fillRect/>
+          </a:stretch>
+        </p:blipFill>
+        <p:spPr>
+          <a:xfrm>
+            <a:off x="9320604" y="597102"/>
+            <a:ext cx="2554970" cy="3077212"/>
+          </a:xfrm>
+          <a:prstGeom prst="rect">
+            <a:avLst/>
+          </a:prstGeom>
+        </p:spPr>
+      </p:pic>
+    </p:spTree>
+    <p:extLst>
+      <p:ext uri="{BB962C8B-B14F-4D97-AF65-F5344CB8AC3E}">
+        <p14:creationId xmlns:p14="http://schemas.microsoft.com/office/powerpoint/2010/main" val="1723282750"/>
+      </p:ext>
+    </p:extLst>
+  </p:cSld>
+  <p:clrMapOvr>
+    <a:masterClrMapping/>
+  </p:clrMapOvr>
+</p:sld>
+</file>
+
+<file path=ppt/slides/slide26.xml><?xml version="1.0" encoding="utf-8"?>
+<p:sld xmlns:a="http://schemas.openxmlformats.org/drawingml/2006/main" xmlns:r="http://schemas.openxmlformats.org/officeDocument/2006/relationships" xmlns:p="http://schemas.openxmlformats.org/presentationml/2006/main">
+  <p:cSld>
+    <p:spTree>
+      <p:nvGrpSpPr>
+        <p:cNvPr id="1" name=""/>
+        <p:cNvGrpSpPr/>
+        <p:nvPr/>
+      </p:nvGrpSpPr>
+      <p:grpSpPr>
+        <a:xfrm>
+          <a:off x="0" y="0"/>
+          <a:ext cx="0" cy="0"/>
+          <a:chOff x="0" y="0"/>
+          <a:chExt cx="0" cy="0"/>
+        </a:xfrm>
+      </p:grpSpPr>
+      <p:sp>
+        <p:nvSpPr>
+          <p:cNvPr id="2" name="Cím 1"/>
+          <p:cNvSpPr>
+            <a:spLocks noGrp="1"/>
+          </p:cNvSpPr>
+          <p:nvPr>
+            <p:ph type="title"/>
+          </p:nvPr>
+        </p:nvSpPr>
+        <p:spPr>
+          <a:xfrm>
+            <a:off x="1408446" y="1253095"/>
+            <a:ext cx="8115115" cy="592958"/>
+          </a:xfrm>
+        </p:spPr>
+        <p:txBody>
+          <a:bodyPr>
+            <a:normAutofit/>
+          </a:bodyPr>
+          <a:lstStyle/>
+          <a:p>
+            <a:r>
+              <a:rPr lang="hu-HU" dirty="0"/>
+              <a:t>Molnár Attila- </a:t>
+            </a:r>
+            <a:r>
+              <a:rPr lang="hu-HU" dirty="0" err="1"/>
+              <a:t>Git</a:t>
+            </a:r>
+            <a:endParaRPr lang="hu-HU" dirty="0"/>
+          </a:p>
+        </p:txBody>
+      </p:sp>
+      <p:pic>
+        <p:nvPicPr>
+          <p:cNvPr id="6" name="Kép 5">
+            <a:extLst>
+              <a:ext uri="{FF2B5EF4-FFF2-40B4-BE49-F238E27FC236}">
+                <a16:creationId xmlns:a16="http://schemas.microsoft.com/office/drawing/2014/main" id="{C30DBF84-8C67-8166-0D65-FEF3A3210846}"/>
+              </a:ext>
+            </a:extLst>
+          </p:cNvPr>
+          <p:cNvPicPr>
+            <a:picLocks noChangeAspect="1"/>
+          </p:cNvPicPr>
+          <p:nvPr/>
+        </p:nvPicPr>
+        <p:blipFill>
+          <a:blip r:embed="rId2"/>
+          <a:stretch>
+            <a:fillRect/>
+          </a:stretch>
+        </p:blipFill>
+        <p:spPr>
+          <a:xfrm>
+            <a:off x="504301" y="2495550"/>
+            <a:ext cx="4553948" cy="4062836"/>
+          </a:xfrm>
+          <a:prstGeom prst="rect">
+            <a:avLst/>
+          </a:prstGeom>
+        </p:spPr>
+      </p:pic>
+      <p:pic>
+        <p:nvPicPr>
+          <p:cNvPr id="8" name="Kép 7">
+            <a:extLst>
+              <a:ext uri="{FF2B5EF4-FFF2-40B4-BE49-F238E27FC236}">
+                <a16:creationId xmlns:a16="http://schemas.microsoft.com/office/drawing/2014/main" id="{F34FCA43-70CA-B2A9-CAD0-DD753203776D}"/>
+              </a:ext>
+            </a:extLst>
+          </p:cNvPr>
+          <p:cNvPicPr>
+            <a:picLocks noChangeAspect="1"/>
+          </p:cNvPicPr>
+          <p:nvPr/>
+        </p:nvPicPr>
+        <p:blipFill>
+          <a:blip r:embed="rId3"/>
+          <a:stretch>
+            <a:fillRect/>
+          </a:stretch>
+        </p:blipFill>
+        <p:spPr>
+          <a:xfrm>
+            <a:off x="8818331" y="3542994"/>
+            <a:ext cx="3225422" cy="2937905"/>
+          </a:xfrm>
+          <a:prstGeom prst="rect">
+            <a:avLst/>
+          </a:prstGeom>
+        </p:spPr>
+      </p:pic>
+      <p:pic>
+        <p:nvPicPr>
+          <p:cNvPr id="10" name="Kép 9">
+            <a:extLst>
+              <a:ext uri="{FF2B5EF4-FFF2-40B4-BE49-F238E27FC236}">
+                <a16:creationId xmlns:a16="http://schemas.microsoft.com/office/drawing/2014/main" id="{437A2A37-4FD2-48EF-6E8F-8D1AA6EB3162}"/>
+              </a:ext>
+            </a:extLst>
+          </p:cNvPr>
+          <p:cNvPicPr>
+            <a:picLocks noChangeAspect="1"/>
+          </p:cNvPicPr>
+          <p:nvPr/>
+        </p:nvPicPr>
+        <p:blipFill>
+          <a:blip r:embed="rId4"/>
+          <a:stretch>
+            <a:fillRect/>
+          </a:stretch>
+        </p:blipFill>
+        <p:spPr>
+          <a:xfrm>
+            <a:off x="5237404" y="2923576"/>
+            <a:ext cx="3401772" cy="2591110"/>
+          </a:xfrm>
+          <a:prstGeom prst="rect">
+            <a:avLst/>
+          </a:prstGeom>
+        </p:spPr>
+      </p:pic>
+    </p:spTree>
+    <p:extLst>
+      <p:ext uri="{BB962C8B-B14F-4D97-AF65-F5344CB8AC3E}">
+        <p14:creationId xmlns:p14="http://schemas.microsoft.com/office/powerpoint/2010/main" val="2518564846"/>
+      </p:ext>
+    </p:extLst>
+  </p:cSld>
+  <p:clrMapOvr>
+    <a:masterClrMapping/>
+  </p:clrMapOvr>
+</p:sld>
+</file>
+
+<file path=ppt/slides/slide27.xml><?xml version="1.0" encoding="utf-8"?>
+<p:sld xmlns:a="http://schemas.openxmlformats.org/drawingml/2006/main" xmlns:r="http://schemas.openxmlformats.org/officeDocument/2006/relationships" xmlns:p="http://schemas.openxmlformats.org/presentationml/2006/main">
+  <p:cSld>
+    <p:spTree>
+      <p:nvGrpSpPr>
+        <p:cNvPr id="1" name=""/>
+        <p:cNvGrpSpPr/>
+        <p:nvPr/>
+      </p:nvGrpSpPr>
+      <p:grpSpPr>
+        <a:xfrm>
+          <a:off x="0" y="0"/>
+          <a:ext cx="0" cy="0"/>
+          <a:chOff x="0" y="0"/>
+          <a:chExt cx="0" cy="0"/>
+        </a:xfrm>
+      </p:grpSpPr>
+      <p:sp>
+        <p:nvSpPr>
+          <p:cNvPr id="3" name="Cím 1"/>
+          <p:cNvSpPr>
+            <a:spLocks noGrp="1"/>
+          </p:cNvSpPr>
+          <p:nvPr>
+            <p:ph type="title"/>
+          </p:nvPr>
+        </p:nvSpPr>
+        <p:spPr>
+          <a:xfrm>
+            <a:off x="722862" y="1290291"/>
+            <a:ext cx="9603275" cy="559792"/>
+          </a:xfrm>
+        </p:spPr>
+        <p:txBody>
+          <a:bodyPr>
+            <a:normAutofit/>
+          </a:bodyPr>
+          <a:lstStyle/>
+          <a:p>
+            <a:r>
+              <a:rPr lang="hu-HU" dirty="0"/>
+              <a:t>Molnár </a:t>
+            </a:r>
+            <a:r>
+              <a:rPr lang="hu-HU" dirty="0" err="1"/>
+              <a:t>attila</a:t>
+            </a:r>
+            <a:r>
+              <a:rPr lang="hu-HU" dirty="0"/>
+              <a:t> - Dokumentáció</a:t>
+            </a:r>
+          </a:p>
+        </p:txBody>
+      </p:sp>
+      <p:sp>
+        <p:nvSpPr>
+          <p:cNvPr id="36866" name="AutoShape 2" descr="image.png"/>
+          <p:cNvSpPr>
+            <a:spLocks noChangeAspect="1" noChangeArrowheads="1"/>
+          </p:cNvSpPr>
+          <p:nvPr/>
+        </p:nvSpPr>
+        <p:spPr bwMode="auto">
+          <a:xfrm>
+            <a:off x="155575" y="-144463"/>
+            <a:ext cx="304800" cy="304801"/>
+          </a:xfrm>
+          <a:prstGeom prst="rect">
+            <a:avLst/>
+          </a:prstGeom>
+          <a:noFill/>
+        </p:spPr>
+        <p:txBody>
+          <a:bodyPr vert="horz" wrap="square" lIns="91440" tIns="45720" rIns="91440" bIns="45720" numCol="1" anchor="t" anchorCtr="0" compatLnSpc="1">
+            <a:prstTxWarp prst="textNoShape">
+              <a:avLst/>
+            </a:prstTxWarp>
+          </a:bodyPr>
+          <a:lstStyle/>
+          <a:p>
+            <a:endParaRPr lang="hu-HU"/>
+          </a:p>
+        </p:txBody>
+      </p:sp>
+      <p:pic>
+        <p:nvPicPr>
+          <p:cNvPr id="4" name="Kép 3">
+            <a:extLst>
+              <a:ext uri="{FF2B5EF4-FFF2-40B4-BE49-F238E27FC236}">
+                <a16:creationId xmlns:a16="http://schemas.microsoft.com/office/drawing/2014/main" id="{FAC51E4C-7C89-3C54-9FFB-C72B8DF0BEB0}"/>
+              </a:ext>
+            </a:extLst>
+          </p:cNvPr>
+          <p:cNvPicPr>
+            <a:picLocks noChangeAspect="1"/>
+          </p:cNvPicPr>
+          <p:nvPr/>
+        </p:nvPicPr>
+        <p:blipFill>
+          <a:blip r:embed="rId2"/>
+          <a:stretch>
+            <a:fillRect/>
+          </a:stretch>
+        </p:blipFill>
+        <p:spPr>
+          <a:xfrm>
+            <a:off x="460375" y="2581275"/>
+            <a:ext cx="4554806" cy="2668438"/>
+          </a:xfrm>
+          <a:prstGeom prst="rect">
+            <a:avLst/>
+          </a:prstGeom>
+        </p:spPr>
+      </p:pic>
+      <p:pic>
+        <p:nvPicPr>
+          <p:cNvPr id="6" name="Kép 5">
+            <a:extLst>
+              <a:ext uri="{FF2B5EF4-FFF2-40B4-BE49-F238E27FC236}">
+                <a16:creationId xmlns:a16="http://schemas.microsoft.com/office/drawing/2014/main" id="{D3352C05-B4D6-E48D-0629-DE0E1B8E50CF}"/>
+              </a:ext>
+            </a:extLst>
+          </p:cNvPr>
+          <p:cNvPicPr>
+            <a:picLocks noChangeAspect="1"/>
+          </p:cNvPicPr>
+          <p:nvPr/>
+        </p:nvPicPr>
+        <p:blipFill>
+          <a:blip r:embed="rId3"/>
+          <a:stretch>
+            <a:fillRect/>
+          </a:stretch>
+        </p:blipFill>
+        <p:spPr>
+          <a:xfrm>
+            <a:off x="7602679" y="1066826"/>
+            <a:ext cx="4309921" cy="2229488"/>
+          </a:xfrm>
+          <a:prstGeom prst="rect">
+            <a:avLst/>
+          </a:prstGeom>
+        </p:spPr>
+      </p:pic>
+      <p:pic>
+        <p:nvPicPr>
+          <p:cNvPr id="8" name="Kép 7">
+            <a:extLst>
+              <a:ext uri="{FF2B5EF4-FFF2-40B4-BE49-F238E27FC236}">
+                <a16:creationId xmlns:a16="http://schemas.microsoft.com/office/drawing/2014/main" id="{9AFC4F46-621C-30DF-7DB2-B575265441D7}"/>
+              </a:ext>
+            </a:extLst>
+          </p:cNvPr>
+          <p:cNvPicPr>
+            <a:picLocks noChangeAspect="1"/>
+          </p:cNvPicPr>
+          <p:nvPr/>
+        </p:nvPicPr>
+        <p:blipFill>
+          <a:blip r:embed="rId4"/>
+          <a:stretch>
+            <a:fillRect/>
+          </a:stretch>
+        </p:blipFill>
+        <p:spPr>
+          <a:xfrm>
+            <a:off x="5401156" y="3561687"/>
+            <a:ext cx="4691296" cy="3019885"/>
+          </a:xfrm>
+          <a:prstGeom prst="rect">
+            <a:avLst/>
+          </a:prstGeom>
+        </p:spPr>
+      </p:pic>
+    </p:spTree>
+    <p:extLst>
+      <p:ext uri="{BB962C8B-B14F-4D97-AF65-F5344CB8AC3E}">
+        <p14:creationId xmlns:p14="http://schemas.microsoft.com/office/powerpoint/2010/main" val="2114799061"/>
+      </p:ext>
+    </p:extLst>
+  </p:cSld>
+  <p:clrMapOvr>
+    <a:masterClrMapping/>
+  </p:clrMapOvr>
+</p:sld>
+</file>
+
+<file path=ppt/slides/slide28.xml><?xml version="1.0" encoding="utf-8"?>
+<p:sld xmlns:a="http://schemas.openxmlformats.org/drawingml/2006/main" xmlns:r="http://schemas.openxmlformats.org/officeDocument/2006/relationships" xmlns:p="http://schemas.openxmlformats.org/presentationml/2006/main">
+  <p:cSld>
+    <p:spTree>
+      <p:nvGrpSpPr>
+        <p:cNvPr id="1" name=""/>
+        <p:cNvGrpSpPr/>
+        <p:nvPr/>
+      </p:nvGrpSpPr>
+      <p:grpSpPr>
+        <a:xfrm>
+          <a:off x="0" y="0"/>
+          <a:ext cx="0" cy="0"/>
+          <a:chOff x="0" y="0"/>
+          <a:chExt cx="0" cy="0"/>
+        </a:xfrm>
+      </p:grpSpPr>
+      <p:sp>
+        <p:nvSpPr>
+          <p:cNvPr id="2" name="Cím 1"/>
+          <p:cNvSpPr>
+            <a:spLocks noGrp="1"/>
+          </p:cNvSpPr>
+          <p:nvPr>
+            <p:ph type="title"/>
+          </p:nvPr>
+        </p:nvSpPr>
+        <p:spPr>
+          <a:xfrm>
+            <a:off x="1451579" y="1257300"/>
+            <a:ext cx="9603275" cy="596453"/>
+          </a:xfrm>
+        </p:spPr>
+        <p:txBody>
+          <a:bodyPr>
+            <a:normAutofit/>
+          </a:bodyPr>
+          <a:lstStyle/>
+          <a:p>
+            <a:r>
+              <a:rPr lang="hu-HU" dirty="0"/>
+              <a:t>Molnár </a:t>
+            </a:r>
+            <a:r>
+              <a:rPr lang="hu-HU" dirty="0" err="1"/>
+              <a:t>attila</a:t>
+            </a:r>
+            <a:r>
+              <a:rPr lang="hu-HU" dirty="0"/>
+              <a:t>- fejlesztés</a:t>
+            </a:r>
+          </a:p>
+        </p:txBody>
+      </p:sp>
+    </p:spTree>
+    <p:extLst>
+      <p:ext uri="{BB962C8B-B14F-4D97-AF65-F5344CB8AC3E}">
+        <p14:creationId xmlns:p14="http://schemas.microsoft.com/office/powerpoint/2010/main" val="2431580861"/>
+      </p:ext>
+    </p:extLst>
+  </p:cSld>
+  <p:clrMapOvr>
+    <a:masterClrMapping/>
+  </p:clrMapOvr>
+</p:sld>
+</file>
+
+<file path=ppt/slides/slide29.xml><?xml version="1.0" encoding="utf-8"?>
+<p:sld xmlns:a="http://schemas.openxmlformats.org/drawingml/2006/main" xmlns:r="http://schemas.openxmlformats.org/officeDocument/2006/relationships" xmlns:p="http://schemas.openxmlformats.org/presentationml/2006/main">
+  <p:cSld>
+    <p:spTree>
+      <p:nvGrpSpPr>
+        <p:cNvPr id="1" name=""/>
+        <p:cNvGrpSpPr/>
+        <p:nvPr/>
+      </p:nvGrpSpPr>
+      <p:grpSpPr>
+        <a:xfrm>
+          <a:off x="0" y="0"/>
+          <a:ext cx="0" cy="0"/>
+          <a:chOff x="0" y="0"/>
+          <a:chExt cx="0" cy="0"/>
+        </a:xfrm>
+      </p:grpSpPr>
+      <p:sp>
+        <p:nvSpPr>
+          <p:cNvPr id="3" name="Cím 1"/>
+          <p:cNvSpPr txBox="1">
+            <a:spLocks/>
+          </p:cNvSpPr>
+          <p:nvPr/>
+        </p:nvSpPr>
+        <p:spPr>
+          <a:xfrm>
+            <a:off x="1451579" y="1257300"/>
+            <a:ext cx="9603275" cy="596453"/>
+          </a:xfrm>
+          <a:prstGeom prst="rect">
+            <a:avLst/>
+          </a:prstGeom>
+        </p:spPr>
+        <p:txBody>
+          <a:bodyPr vert="horz" lIns="91440" tIns="45720" rIns="91440" bIns="45720" rtlCol="0" anchor="t">
+            <a:normAutofit/>
+          </a:bodyPr>
+          <a:lstStyle/>
+          <a:p>
+            <a:pPr marL="0" marR="0" lvl="0" indent="0" algn="l" defTabSz="914400" rtl="0" eaLnBrk="1" fontAlgn="auto" latinLnBrk="0" hangingPunct="1">
+              <a:lnSpc>
+                <a:spcPct val="90000"/>
+              </a:lnSpc>
+              <a:spcBef>
+                <a:spcPct val="0"/>
+              </a:spcBef>
+              <a:spcAft>
+                <a:spcPts val="0"/>
+              </a:spcAft>
+              <a:buClrTx/>
+              <a:buSzTx/>
+              <a:buFontTx/>
+              <a:buNone/>
+              <a:tabLst/>
+              <a:defRPr/>
+            </a:pPr>
+            <a:r>
+              <a:rPr lang="hu-HU" sz="3200" cap="all" dirty="0">
+                <a:latin typeface="+mj-lt"/>
+                <a:ea typeface="+mj-ea"/>
+                <a:cs typeface="+mj-cs"/>
+              </a:rPr>
+              <a:t>Molnár </a:t>
+            </a:r>
+            <a:r>
+              <a:rPr lang="hu-HU" sz="3200" cap="all" dirty="0" err="1">
+                <a:latin typeface="+mj-lt"/>
+                <a:ea typeface="+mj-ea"/>
+                <a:cs typeface="+mj-cs"/>
+              </a:rPr>
+              <a:t>attila</a:t>
+            </a:r>
+            <a:r>
+              <a:rPr kumimoji="0" lang="hu-HU" sz="3200" b="0" i="0" u="none" strike="noStrike" kern="1200" cap="all" spc="0" normalizeH="0" baseline="0" noProof="0" dirty="0">
+                <a:ln>
+                  <a:noFill/>
+                </a:ln>
+                <a:solidFill>
+                  <a:schemeClr val="tx1"/>
+                </a:solidFill>
+                <a:effectLst/>
+                <a:uLnTx/>
+                <a:uFillTx/>
+                <a:latin typeface="+mj-lt"/>
+                <a:ea typeface="+mj-ea"/>
+                <a:cs typeface="+mj-cs"/>
+              </a:rPr>
+              <a:t> - Tesztelés</a:t>
+            </a:r>
+          </a:p>
+        </p:txBody>
+      </p:sp>
+      <p:pic>
+        <p:nvPicPr>
+          <p:cNvPr id="4" name="Kép 3">
+            <a:extLst>
+              <a:ext uri="{FF2B5EF4-FFF2-40B4-BE49-F238E27FC236}">
+                <a16:creationId xmlns:a16="http://schemas.microsoft.com/office/drawing/2014/main" id="{70AE7B46-C699-EEAC-7EEC-3A0012D6848E}"/>
+              </a:ext>
+            </a:extLst>
+          </p:cNvPr>
+          <p:cNvPicPr>
+            <a:picLocks noChangeAspect="1"/>
+          </p:cNvPicPr>
+          <p:nvPr/>
+        </p:nvPicPr>
+        <p:blipFill>
+          <a:blip r:embed="rId2"/>
+          <a:stretch>
+            <a:fillRect/>
+          </a:stretch>
+        </p:blipFill>
+        <p:spPr>
+          <a:xfrm>
+            <a:off x="3299803" y="2219325"/>
+            <a:ext cx="5592394" cy="4486274"/>
+          </a:xfrm>
+          <a:prstGeom prst="rect">
+            <a:avLst/>
+          </a:prstGeom>
+        </p:spPr>
+      </p:pic>
+    </p:spTree>
+    <p:extLst>
+      <p:ext uri="{BB962C8B-B14F-4D97-AF65-F5344CB8AC3E}">
+        <p14:creationId xmlns:p14="http://schemas.microsoft.com/office/powerpoint/2010/main" val="158579989"/>
+      </p:ext>
+    </p:extLst>
   </p:cSld>
   <p:clrMapOvr>
     <a:masterClrMapping/>

</xml_diff>